<commit_message>
Polish required UiPath deck layout
</commit_message>
<xml_diff>
--- a/docs/CaseProof_AI_AgentHack_Required_Template_Deck.pptx
+++ b/docs/CaseProof_AI_AgentHack_Required_Template_Deck.pptx
@@ -2,17 +2,17 @@
 <file path=ppt/presentation.xml><?xml version="1.0" encoding="utf-8"?>
 <p:presentation xmlns:p="http://schemas.openxmlformats.org/presentationml/2006/main">
   <p:sldMasterIdLst>
-    <p:sldMasterId xmlns:r="http://schemas.openxmlformats.org/officeDocument/2006/relationships" id="2147483648" r:id="R3ebdc412530144f2"/>
+    <p:sldMasterId xmlns:r="http://schemas.openxmlformats.org/officeDocument/2006/relationships" id="2147483648" r:id="Ra62308831e304e22"/>
   </p:sldMasterIdLst>
   <p:notesMasterIdLst>
-    <p:notesMasterId xmlns:r="http://schemas.openxmlformats.org/officeDocument/2006/relationships" r:id="R67ccbb48b89a4b49"/>
+    <p:notesMasterId xmlns:r="http://schemas.openxmlformats.org/officeDocument/2006/relationships" r:id="R7ba01289375c4684"/>
   </p:notesMasterIdLst>
   <p:sldIdLst>
-    <p:sldId xmlns:r="http://schemas.openxmlformats.org/officeDocument/2006/relationships" id="256" r:id="Rb46a52400d1e4998"/>
-    <p:sldId xmlns:r="http://schemas.openxmlformats.org/officeDocument/2006/relationships" id="257" r:id="R0b1161942e3d4ee3"/>
-    <p:sldId xmlns:r="http://schemas.openxmlformats.org/officeDocument/2006/relationships" id="258" r:id="Rfcc20e303e50475e"/>
-    <p:sldId xmlns:r="http://schemas.openxmlformats.org/officeDocument/2006/relationships" id="259" r:id="R605d403265714a86"/>
-    <p:sldId xmlns:r="http://schemas.openxmlformats.org/officeDocument/2006/relationships" id="260" r:id="R8b10336c4cc14549"/>
+    <p:sldId xmlns:r="http://schemas.openxmlformats.org/officeDocument/2006/relationships" id="256" r:id="Rfd45aa3b4dfc4ec5"/>
+    <p:sldId xmlns:r="http://schemas.openxmlformats.org/officeDocument/2006/relationships" id="257" r:id="Rb10fb03b38f743b2"/>
+    <p:sldId xmlns:r="http://schemas.openxmlformats.org/officeDocument/2006/relationships" id="258" r:id="R064a2b339d994be0"/>
+    <p:sldId xmlns:r="http://schemas.openxmlformats.org/officeDocument/2006/relationships" id="259" r:id="R162ec346d4dc432e"/>
+    <p:sldId xmlns:r="http://schemas.openxmlformats.org/officeDocument/2006/relationships" id="260" r:id="Rc458ec4d9b374351"/>
   </p:sldIdLst>
   <p:sldSz cx="12179300" cy="6858000"/>
   <p:notesSz cx="6858000" cy="9144000"/>
@@ -947,7 +947,7 @@
           <p:nvPr/>
         </p:nvPicPr>
         <p:blipFill rotWithShape="1">
-          <a:blip xmlns:r="http://schemas.openxmlformats.org/officeDocument/2006/relationships" xmlns:a="http://schemas.openxmlformats.org/drawingml/2006/main" r:embed="Rbe2149008be94997">
+          <a:blip xmlns:r="http://schemas.openxmlformats.org/officeDocument/2006/relationships" xmlns:a="http://schemas.openxmlformats.org/drawingml/2006/main" r:embed="R5da4c45a1924449d">
             <a:alphaModFix/>
           </a:blip>
           <a:srcRect xmlns:a="http://schemas.openxmlformats.org/drawingml/2006/main" l="0" t="0" r="0" b="0"/>
@@ -971,7 +971,7 @@
           <p:cNvPr id="12" name="Google Shape;12;p9">
             <a:extLst xmlns:a="http://schemas.openxmlformats.org/drawingml/2006/main">
               <a:ext uri="{FF2B5EF4-FFF2-40B4-BE49-F238E27FC236}">
-                <a16:creationId xmlns:a16="http://schemas.microsoft.com/office/drawing/2014/main" id="{A7ADB053-667C-4E19-8DC4-B2E4B6BD0B1E}"/>
+                <a16:creationId xmlns:a16="http://schemas.microsoft.com/office/drawing/2014/main" id="{DCAF9A3A-E376-41DF-8446-4DD25AAC40B2}"/>
               </a:ext>
             </a:extLst>
           </p:cNvPr>
@@ -1047,7 +1047,7 @@
           <p:cNvPr id="13" name="Google Shape;13;p9">
             <a:extLst xmlns:a="http://schemas.openxmlformats.org/drawingml/2006/main">
               <a:ext uri="{FF2B5EF4-FFF2-40B4-BE49-F238E27FC236}">
-                <a16:creationId xmlns:a16="http://schemas.microsoft.com/office/drawing/2014/main" id="{30AF2F91-95B5-49AA-B2AE-5D18894F5EF8}"/>
+                <a16:creationId xmlns:a16="http://schemas.microsoft.com/office/drawing/2014/main" id="{2296E249-96C7-4560-82DF-1A2F496B2A51}"/>
               </a:ext>
             </a:extLst>
           </p:cNvPr>
@@ -1265,7 +1265,7 @@
           <p:cNvPr id="14" name="Google Shape;14;p9">
             <a:extLst xmlns:a="http://schemas.openxmlformats.org/drawingml/2006/main">
               <a:ext uri="{FF2B5EF4-FFF2-40B4-BE49-F238E27FC236}">
-                <a16:creationId xmlns:a16="http://schemas.microsoft.com/office/drawing/2014/main" id="{D8C2AC8D-61FF-4960-A848-140775D961EF}"/>
+                <a16:creationId xmlns:a16="http://schemas.microsoft.com/office/drawing/2014/main" id="{E85BBE39-2572-42DE-BFD0-35BC51D311F3}"/>
               </a:ext>
             </a:extLst>
           </p:cNvPr>
@@ -1319,7 +1319,7 @@
           <p:cNvPr id="15" name="Google Shape;15;p9">
             <a:extLst xmlns:a="http://schemas.openxmlformats.org/drawingml/2006/main">
               <a:ext uri="{FF2B5EF4-FFF2-40B4-BE49-F238E27FC236}">
-                <a16:creationId xmlns:a16="http://schemas.microsoft.com/office/drawing/2014/main" id="{105023F8-7D91-45BE-987F-A40852BD479B}"/>
+                <a16:creationId xmlns:a16="http://schemas.microsoft.com/office/drawing/2014/main" id="{A55F3E9F-FBC6-4C06-9DBC-59D6C1E380B2}"/>
               </a:ext>
             </a:extLst>
           </p:cNvPr>
@@ -1482,7 +1482,7 @@
           <p:nvPr/>
         </p:nvPicPr>
         <p:blipFill rotWithShape="1">
-          <a:blip xmlns:r="http://schemas.openxmlformats.org/officeDocument/2006/relationships" xmlns:a="http://schemas.openxmlformats.org/drawingml/2006/main" r:embed="Rf8cd210dd9f8481b">
+          <a:blip xmlns:r="http://schemas.openxmlformats.org/officeDocument/2006/relationships" xmlns:a="http://schemas.openxmlformats.org/drawingml/2006/main" r:embed="Rd40b3e0eea2e424f">
             <a:alphaModFix/>
           </a:blip>
           <a:srcRect xmlns:a="http://schemas.openxmlformats.org/drawingml/2006/main" l="0" t="0" r="0" b="0"/>
@@ -1530,7 +1530,7 @@
           <p:cNvPr id="70" name="Google Shape;70;p18">
             <a:extLst xmlns:a="http://schemas.openxmlformats.org/drawingml/2006/main">
               <a:ext uri="{FF2B5EF4-FFF2-40B4-BE49-F238E27FC236}">
-                <a16:creationId xmlns:a16="http://schemas.microsoft.com/office/drawing/2014/main" id="{0A0AC6EF-CFCF-4CF2-9392-8CE160FD07CE}"/>
+                <a16:creationId xmlns:a16="http://schemas.microsoft.com/office/drawing/2014/main" id="{15BCB2BA-68EF-42C3-8EB7-97703050B661}"/>
               </a:ext>
             </a:extLst>
           </p:cNvPr>
@@ -1689,7 +1689,7 @@
           <p:cNvPr id="71" name="Google Shape;71;p18">
             <a:extLst xmlns:a="http://schemas.openxmlformats.org/drawingml/2006/main">
               <a:ext uri="{FF2B5EF4-FFF2-40B4-BE49-F238E27FC236}">
-                <a16:creationId xmlns:a16="http://schemas.microsoft.com/office/drawing/2014/main" id="{341DB910-EDE0-4339-9A71-8F529152FD6B}"/>
+                <a16:creationId xmlns:a16="http://schemas.microsoft.com/office/drawing/2014/main" id="{9504A915-1709-4371-956C-D9F1BF393E6C}"/>
               </a:ext>
             </a:extLst>
           </p:cNvPr>
@@ -1920,7 +1920,7 @@
           <p:cNvPr id="72" name="Google Shape;72;p18">
             <a:extLst xmlns:a="http://schemas.openxmlformats.org/drawingml/2006/main">
               <a:ext uri="{FF2B5EF4-FFF2-40B4-BE49-F238E27FC236}">
-                <a16:creationId xmlns:a16="http://schemas.microsoft.com/office/drawing/2014/main" id="{F8C6F33A-015F-42B1-825C-6C5B5E94CBA8}"/>
+                <a16:creationId xmlns:a16="http://schemas.microsoft.com/office/drawing/2014/main" id="{4A426DFD-2EDD-4131-B7FA-8592FBADEA4F}"/>
               </a:ext>
             </a:extLst>
           </p:cNvPr>
@@ -1977,7 +1977,7 @@
           <p:nvPr/>
         </p:nvPicPr>
         <p:blipFill rotWithShape="1">
-          <a:blip xmlns:r="http://schemas.openxmlformats.org/officeDocument/2006/relationships" xmlns:a="http://schemas.openxmlformats.org/drawingml/2006/main" r:embed="Rdb1c1ed4cc204064">
+          <a:blip xmlns:r="http://schemas.openxmlformats.org/officeDocument/2006/relationships" xmlns:a="http://schemas.openxmlformats.org/drawingml/2006/main" r:embed="Re61e09930aae4c35">
             <a:alphaModFix/>
           </a:blip>
           <a:srcRect xmlns:a="http://schemas.openxmlformats.org/drawingml/2006/main" l="0" t="0" r="0" b="0"/>
@@ -2025,7 +2025,7 @@
           <p:cNvPr id="75" name="Google Shape;75;p19">
             <a:extLst xmlns:a="http://schemas.openxmlformats.org/drawingml/2006/main">
               <a:ext uri="{FF2B5EF4-FFF2-40B4-BE49-F238E27FC236}">
-                <a16:creationId xmlns:a16="http://schemas.microsoft.com/office/drawing/2014/main" id="{CE6AEAA3-AEF2-4B80-B788-2E73B11B2727}"/>
+                <a16:creationId xmlns:a16="http://schemas.microsoft.com/office/drawing/2014/main" id="{A5489A5C-2CFE-4D38-AC5D-833E07664429}"/>
               </a:ext>
             </a:extLst>
           </p:cNvPr>
@@ -2184,7 +2184,7 @@
           <p:cNvPr id="76" name="Google Shape;76;p19">
             <a:extLst xmlns:a="http://schemas.openxmlformats.org/drawingml/2006/main">
               <a:ext uri="{FF2B5EF4-FFF2-40B4-BE49-F238E27FC236}">
-                <a16:creationId xmlns:a16="http://schemas.microsoft.com/office/drawing/2014/main" id="{EA2B15B8-21DE-4188-9E9B-91237CB8847E}"/>
+                <a16:creationId xmlns:a16="http://schemas.microsoft.com/office/drawing/2014/main" id="{EDAB47D4-BDB1-4431-B84D-3E0785A9F9E6}"/>
               </a:ext>
             </a:extLst>
           </p:cNvPr>
@@ -2415,7 +2415,7 @@
           <p:cNvPr id="77" name="Google Shape;77;p19">
             <a:extLst xmlns:a="http://schemas.openxmlformats.org/drawingml/2006/main">
               <a:ext uri="{FF2B5EF4-FFF2-40B4-BE49-F238E27FC236}">
-                <a16:creationId xmlns:a16="http://schemas.microsoft.com/office/drawing/2014/main" id="{EFB2484E-935B-4448-B2B6-2585386C541F}"/>
+                <a16:creationId xmlns:a16="http://schemas.microsoft.com/office/drawing/2014/main" id="{B36BA565-9A7B-4FA4-9756-E2E04AD957F4}"/>
               </a:ext>
             </a:extLst>
           </p:cNvPr>
@@ -2472,7 +2472,7 @@
           <p:nvPr/>
         </p:nvPicPr>
         <p:blipFill rotWithShape="1">
-          <a:blip xmlns:r="http://schemas.openxmlformats.org/officeDocument/2006/relationships" xmlns:a="http://schemas.openxmlformats.org/drawingml/2006/main" r:embed="Rbbdca8d48b804dca">
+          <a:blip xmlns:r="http://schemas.openxmlformats.org/officeDocument/2006/relationships" xmlns:a="http://schemas.openxmlformats.org/drawingml/2006/main" r:embed="Rbd1e7576b06147cf">
             <a:alphaModFix/>
           </a:blip>
           <a:srcRect xmlns:a="http://schemas.openxmlformats.org/drawingml/2006/main" l="0" t="0" r="0" b="0"/>
@@ -2524,7 +2524,7 @@
           <p:nvPr/>
         </p:nvPicPr>
         <p:blipFill rotWithShape="1">
-          <a:blip xmlns:r="http://schemas.openxmlformats.org/officeDocument/2006/relationships" xmlns:a="http://schemas.openxmlformats.org/drawingml/2006/main" r:embed="R194cfdc88f994ecf">
+          <a:blip xmlns:r="http://schemas.openxmlformats.org/officeDocument/2006/relationships" xmlns:a="http://schemas.openxmlformats.org/drawingml/2006/main" r:embed="R3ad66bf9e0144c4e">
             <a:alphaModFix/>
           </a:blip>
           <a:srcRect xmlns:a="http://schemas.openxmlformats.org/drawingml/2006/main" l="0" t="0" r="0" b="0"/>
@@ -2548,7 +2548,7 @@
           <p:cNvPr id="81" name="Google Shape;81;p20">
             <a:extLst xmlns:a="http://schemas.openxmlformats.org/drawingml/2006/main">
               <a:ext uri="{FF2B5EF4-FFF2-40B4-BE49-F238E27FC236}">
-                <a16:creationId xmlns:a16="http://schemas.microsoft.com/office/drawing/2014/main" id="{37B7B48E-6B90-411F-BB0D-D2FAFF49BEB3}"/>
+                <a16:creationId xmlns:a16="http://schemas.microsoft.com/office/drawing/2014/main" id="{80C95C9A-83F6-4A5B-B8C2-88C353F2C57F}"/>
               </a:ext>
             </a:extLst>
           </p:cNvPr>
@@ -2779,7 +2779,7 @@
           <p:cNvPr id="82" name="Google Shape;82;p20">
             <a:extLst xmlns:a="http://schemas.openxmlformats.org/drawingml/2006/main">
               <a:ext uri="{FF2B5EF4-FFF2-40B4-BE49-F238E27FC236}">
-                <a16:creationId xmlns:a16="http://schemas.microsoft.com/office/drawing/2014/main" id="{F4DF674F-B85C-4D03-956B-241D5160A937}"/>
+                <a16:creationId xmlns:a16="http://schemas.microsoft.com/office/drawing/2014/main" id="{85ADAD53-DB1D-4CEE-BE67-533F8AB28432}"/>
               </a:ext>
             </a:extLst>
           </p:cNvPr>
@@ -2938,7 +2938,7 @@
           <p:cNvPr id="83" name="Google Shape;83;p20">
             <a:extLst xmlns:a="http://schemas.openxmlformats.org/drawingml/2006/main">
               <a:ext uri="{FF2B5EF4-FFF2-40B4-BE49-F238E27FC236}">
-                <a16:creationId xmlns:a16="http://schemas.microsoft.com/office/drawing/2014/main" id="{69003C7D-AA5E-4E3C-8E00-8EE0DF7A16FD}"/>
+                <a16:creationId xmlns:a16="http://schemas.microsoft.com/office/drawing/2014/main" id="{B40F01BE-53F4-4F31-8F0B-4E8599993343}"/>
               </a:ext>
             </a:extLst>
           </p:cNvPr>
@@ -3156,7 +3156,7 @@
           <p:cNvPr id="84" name="Google Shape;84;p20">
             <a:extLst xmlns:a="http://schemas.openxmlformats.org/drawingml/2006/main">
               <a:ext uri="{FF2B5EF4-FFF2-40B4-BE49-F238E27FC236}">
-                <a16:creationId xmlns:a16="http://schemas.microsoft.com/office/drawing/2014/main" id="{AC1A286A-63B0-4A42-B17D-A4C96311EECD}"/>
+                <a16:creationId xmlns:a16="http://schemas.microsoft.com/office/drawing/2014/main" id="{F802508A-1D6C-4CC7-8A62-00DD0C55C219}"/>
               </a:ext>
             </a:extLst>
           </p:cNvPr>
@@ -3374,7 +3374,7 @@
           <p:cNvPr id="85" name="Google Shape;85;p20">
             <a:extLst xmlns:a="http://schemas.openxmlformats.org/drawingml/2006/main">
               <a:ext uri="{FF2B5EF4-FFF2-40B4-BE49-F238E27FC236}">
-                <a16:creationId xmlns:a16="http://schemas.microsoft.com/office/drawing/2014/main" id="{761A2C84-2B15-4065-8BD4-6C2034EFAFF5}"/>
+                <a16:creationId xmlns:a16="http://schemas.microsoft.com/office/drawing/2014/main" id="{D07B56D1-C708-4F76-B3E7-14733DCA4E60}"/>
               </a:ext>
             </a:extLst>
           </p:cNvPr>
@@ -3592,7 +3592,7 @@
           <p:cNvPr id="86" name="Google Shape;86;p20">
             <a:extLst xmlns:a="http://schemas.openxmlformats.org/drawingml/2006/main">
               <a:ext uri="{FF2B5EF4-FFF2-40B4-BE49-F238E27FC236}">
-                <a16:creationId xmlns:a16="http://schemas.microsoft.com/office/drawing/2014/main" id="{C50EED96-E15C-4320-AAE9-1A819EB8774C}"/>
+                <a16:creationId xmlns:a16="http://schemas.microsoft.com/office/drawing/2014/main" id="{59EA1305-1817-43B6-A317-FD12C368566E}"/>
               </a:ext>
             </a:extLst>
           </p:cNvPr>
@@ -3649,7 +3649,7 @@
           <p:nvPr/>
         </p:nvPicPr>
         <p:blipFill rotWithShape="1">
-          <a:blip xmlns:r="http://schemas.openxmlformats.org/officeDocument/2006/relationships" xmlns:a="http://schemas.openxmlformats.org/drawingml/2006/main" r:embed="R2df84939e12d4483">
+          <a:blip xmlns:r="http://schemas.openxmlformats.org/officeDocument/2006/relationships" xmlns:a="http://schemas.openxmlformats.org/drawingml/2006/main" r:embed="Ra0d13ca6b7454290">
             <a:alphaModFix/>
           </a:blip>
           <a:srcRect xmlns:a="http://schemas.openxmlformats.org/drawingml/2006/main" l="0" t="0" r="0" b="0"/>
@@ -3697,7 +3697,7 @@
           <p:cNvPr id="89" name="Google Shape;89;p21">
             <a:extLst xmlns:a="http://schemas.openxmlformats.org/drawingml/2006/main">
               <a:ext uri="{FF2B5EF4-FFF2-40B4-BE49-F238E27FC236}">
-                <a16:creationId xmlns:a16="http://schemas.microsoft.com/office/drawing/2014/main" id="{B0C06167-2AFB-4EF3-91B7-4D0064367234}"/>
+                <a16:creationId xmlns:a16="http://schemas.microsoft.com/office/drawing/2014/main" id="{73924930-BEA2-45F3-B45F-FE70978E4F25}"/>
               </a:ext>
             </a:extLst>
           </p:cNvPr>
@@ -3773,7 +3773,7 @@
           <p:cNvPr id="90" name="Google Shape;90;p21">
             <a:extLst xmlns:a="http://schemas.openxmlformats.org/drawingml/2006/main">
               <a:ext uri="{FF2B5EF4-FFF2-40B4-BE49-F238E27FC236}">
-                <a16:creationId xmlns:a16="http://schemas.microsoft.com/office/drawing/2014/main" id="{5D899CAF-D8C9-4134-A105-565EF958F548}"/>
+                <a16:creationId xmlns:a16="http://schemas.microsoft.com/office/drawing/2014/main" id="{0E9E5363-4775-4FDA-B313-975DB875C072}"/>
               </a:ext>
             </a:extLst>
           </p:cNvPr>
@@ -3832,7 +3832,7 @@
           <p:cNvPr id="91" name="Google Shape;91;p21">
             <a:extLst xmlns:a="http://schemas.openxmlformats.org/drawingml/2006/main">
               <a:ext uri="{FF2B5EF4-FFF2-40B4-BE49-F238E27FC236}">
-                <a16:creationId xmlns:a16="http://schemas.microsoft.com/office/drawing/2014/main" id="{1E6AB139-B926-4230-BCDA-A845B5600B30}"/>
+                <a16:creationId xmlns:a16="http://schemas.microsoft.com/office/drawing/2014/main" id="{21A1638C-4C88-4D34-94C4-0531FC4C31DC}"/>
               </a:ext>
             </a:extLst>
           </p:cNvPr>
@@ -3886,7 +3886,7 @@
           <p:cNvPr id="92" name="Google Shape;92;p21">
             <a:extLst xmlns:a="http://schemas.openxmlformats.org/drawingml/2006/main">
               <a:ext uri="{FF2B5EF4-FFF2-40B4-BE49-F238E27FC236}">
-                <a16:creationId xmlns:a16="http://schemas.microsoft.com/office/drawing/2014/main" id="{29E9C145-5FB0-4AC0-9CCA-2608401944ED}"/>
+                <a16:creationId xmlns:a16="http://schemas.microsoft.com/office/drawing/2014/main" id="{BF0E10A1-7A24-4EB6-9076-0BB87AFD20FF}"/>
               </a:ext>
             </a:extLst>
           </p:cNvPr>
@@ -3939,7 +3939,7 @@
           <p:cNvPr id="93" name="Google Shape;93;p21">
             <a:extLst xmlns:a="http://schemas.openxmlformats.org/drawingml/2006/main">
               <a:ext uri="{FF2B5EF4-FFF2-40B4-BE49-F238E27FC236}">
-                <a16:creationId xmlns:a16="http://schemas.microsoft.com/office/drawing/2014/main" id="{2E7ACDA8-F4D9-49E8-AF10-57A344832356}"/>
+                <a16:creationId xmlns:a16="http://schemas.microsoft.com/office/drawing/2014/main" id="{40F38E61-4610-47B8-AC3E-F6B380E26781}"/>
               </a:ext>
             </a:extLst>
           </p:cNvPr>
@@ -4098,7 +4098,7 @@
           <p:cNvPr id="94" name="Google Shape;94;p21">
             <a:extLst xmlns:a="http://schemas.openxmlformats.org/drawingml/2006/main">
               <a:ext uri="{FF2B5EF4-FFF2-40B4-BE49-F238E27FC236}">
-                <a16:creationId xmlns:a16="http://schemas.microsoft.com/office/drawing/2014/main" id="{5BB5C7DD-CC48-4C8D-A127-FD671A77DCBD}"/>
+                <a16:creationId xmlns:a16="http://schemas.microsoft.com/office/drawing/2014/main" id="{D97EC30D-5043-4459-9FC0-FCFB8FE74DAE}"/>
               </a:ext>
             </a:extLst>
           </p:cNvPr>
@@ -4320,7 +4320,7 @@
           <p:nvPr/>
         </p:nvPicPr>
         <p:blipFill rotWithShape="1">
-          <a:blip xmlns:r="http://schemas.openxmlformats.org/officeDocument/2006/relationships" xmlns:a="http://schemas.openxmlformats.org/drawingml/2006/main" r:embed="R5b123374fdfa4fc0">
+          <a:blip xmlns:r="http://schemas.openxmlformats.org/officeDocument/2006/relationships" xmlns:a="http://schemas.openxmlformats.org/drawingml/2006/main" r:embed="R330e63644fbb4f24">
             <a:alphaModFix/>
           </a:blip>
           <a:srcRect xmlns:a="http://schemas.openxmlformats.org/drawingml/2006/main" l="0" t="0" r="0" b="0"/>
@@ -4348,7 +4348,7 @@
           <p:nvPr/>
         </p:nvPicPr>
         <p:blipFill rotWithShape="1">
-          <a:blip xmlns:r="http://schemas.openxmlformats.org/officeDocument/2006/relationships" xmlns:a="http://schemas.openxmlformats.org/drawingml/2006/main" r:embed="R1ebd4c95f25e4bb2">
+          <a:blip xmlns:r="http://schemas.openxmlformats.org/officeDocument/2006/relationships" xmlns:a="http://schemas.openxmlformats.org/drawingml/2006/main" r:embed="R700dc1fb329a4e79">
             <a:alphaModFix/>
           </a:blip>
           <a:srcRect xmlns:a="http://schemas.openxmlformats.org/drawingml/2006/main" l="0" t="0" r="0" b="0"/>
@@ -4389,7 +4389,7 @@
           <p:cNvPr id="98" name="Google Shape;98;p22">
             <a:extLst xmlns:a="http://schemas.openxmlformats.org/drawingml/2006/main">
               <a:ext uri="{FF2B5EF4-FFF2-40B4-BE49-F238E27FC236}">
-                <a16:creationId xmlns:a16="http://schemas.microsoft.com/office/drawing/2014/main" id="{4612FA60-17AB-4357-862B-5EE8D2939225}"/>
+                <a16:creationId xmlns:a16="http://schemas.microsoft.com/office/drawing/2014/main" id="{1FB05C6E-713D-4621-BC30-0A517CADA879}"/>
               </a:ext>
             </a:extLst>
           </p:cNvPr>
@@ -4419,7 +4419,7 @@
           <p:cNvPr id="99" name="Google Shape;99;p22">
             <a:extLst xmlns:a="http://schemas.openxmlformats.org/drawingml/2006/main">
               <a:ext uri="{FF2B5EF4-FFF2-40B4-BE49-F238E27FC236}">
-                <a16:creationId xmlns:a16="http://schemas.microsoft.com/office/drawing/2014/main" id="{A314A9FB-84BD-49FD-8BC8-865A7E89831B}"/>
+                <a16:creationId xmlns:a16="http://schemas.microsoft.com/office/drawing/2014/main" id="{75089623-D1FC-464D-B26D-02C6ED6D1C24}"/>
               </a:ext>
             </a:extLst>
           </p:cNvPr>
@@ -4578,7 +4578,7 @@
           <p:cNvPr id="100" name="Google Shape;100;p22">
             <a:extLst xmlns:a="http://schemas.openxmlformats.org/drawingml/2006/main">
               <a:ext uri="{FF2B5EF4-FFF2-40B4-BE49-F238E27FC236}">
-                <a16:creationId xmlns:a16="http://schemas.microsoft.com/office/drawing/2014/main" id="{566C20A8-51B6-4A89-BC0F-B83BCDA6B911}"/>
+                <a16:creationId xmlns:a16="http://schemas.microsoft.com/office/drawing/2014/main" id="{8816F98D-20AA-4F25-9709-ADB904B18EB9}"/>
               </a:ext>
             </a:extLst>
           </p:cNvPr>
@@ -4746,7 +4746,7 @@
           <p:cNvPr id="101" name="Google Shape;101;p22">
             <a:extLst xmlns:a="http://schemas.openxmlformats.org/drawingml/2006/main">
               <a:ext uri="{FF2B5EF4-FFF2-40B4-BE49-F238E27FC236}">
-                <a16:creationId xmlns:a16="http://schemas.microsoft.com/office/drawing/2014/main" id="{4D989FE0-F038-43D2-ADD4-C7C0990EBF83}"/>
+                <a16:creationId xmlns:a16="http://schemas.microsoft.com/office/drawing/2014/main" id="{C3D357AB-D367-4F0C-BC78-3805FCBA9B99}"/>
               </a:ext>
             </a:extLst>
           </p:cNvPr>
@@ -4964,7 +4964,7 @@
           <p:cNvPr id="102" name="Google Shape;102;p22">
             <a:extLst xmlns:a="http://schemas.openxmlformats.org/drawingml/2006/main">
               <a:ext uri="{FF2B5EF4-FFF2-40B4-BE49-F238E27FC236}">
-                <a16:creationId xmlns:a16="http://schemas.microsoft.com/office/drawing/2014/main" id="{27F9A511-E9EE-4BDD-A2AD-BFF2F2A68BCE}"/>
+                <a16:creationId xmlns:a16="http://schemas.microsoft.com/office/drawing/2014/main" id="{0BFE2DEE-806F-4358-82E7-F58BA7A32FBC}"/>
               </a:ext>
             </a:extLst>
           </p:cNvPr>
@@ -5186,7 +5186,7 @@
           <p:nvPr/>
         </p:nvPicPr>
         <p:blipFill rotWithShape="1">
-          <a:blip xmlns:r="http://schemas.openxmlformats.org/officeDocument/2006/relationships" xmlns:a="http://schemas.openxmlformats.org/drawingml/2006/main" r:embed="R3003d662ed0e48fe">
+          <a:blip xmlns:r="http://schemas.openxmlformats.org/officeDocument/2006/relationships" xmlns:a="http://schemas.openxmlformats.org/drawingml/2006/main" r:embed="R7bca80ca65b0455f">
             <a:alphaModFix/>
           </a:blip>
           <a:srcRect xmlns:a="http://schemas.openxmlformats.org/drawingml/2006/main" l="0" t="0" r="0" b="0"/>
@@ -5210,7 +5210,7 @@
           <p:cNvPr id="104" name="Google Shape;104;p22">
             <a:extLst xmlns:a="http://schemas.openxmlformats.org/drawingml/2006/main">
               <a:ext uri="{FF2B5EF4-FFF2-40B4-BE49-F238E27FC236}">
-                <a16:creationId xmlns:a16="http://schemas.microsoft.com/office/drawing/2014/main" id="{121510FB-A99B-4604-8DE0-693AFB4F64DF}"/>
+                <a16:creationId xmlns:a16="http://schemas.microsoft.com/office/drawing/2014/main" id="{E32913AD-8234-4EA3-9CF4-9F736E0C4E65}"/>
               </a:ext>
             </a:extLst>
           </p:cNvPr>
@@ -5430,7 +5430,7 @@
           <p:cNvPr id="105" name="Google Shape;105;p22">
             <a:extLst xmlns:a="http://schemas.openxmlformats.org/drawingml/2006/main">
               <a:ext uri="{FF2B5EF4-FFF2-40B4-BE49-F238E27FC236}">
-                <a16:creationId xmlns:a16="http://schemas.microsoft.com/office/drawing/2014/main" id="{038479BC-4197-43DB-BCA3-2B49C110BD77}"/>
+                <a16:creationId xmlns:a16="http://schemas.microsoft.com/office/drawing/2014/main" id="{66D43A7C-7CB9-4BBF-9E85-26D7D39EE3E1}"/>
               </a:ext>
             </a:extLst>
           </p:cNvPr>
@@ -5507,7 +5507,7 @@
           <p:cNvPr id="107" name="Google Shape;107;p23">
             <a:extLst xmlns:a="http://schemas.openxmlformats.org/drawingml/2006/main">
               <a:ext uri="{FF2B5EF4-FFF2-40B4-BE49-F238E27FC236}">
-                <a16:creationId xmlns:a16="http://schemas.microsoft.com/office/drawing/2014/main" id="{52595770-5AA6-49B4-A407-F8586992B4B6}"/>
+                <a16:creationId xmlns:a16="http://schemas.microsoft.com/office/drawing/2014/main" id="{8CFA855C-0EE0-4374-9E0F-CD63A50F58A9}"/>
               </a:ext>
             </a:extLst>
           </p:cNvPr>
@@ -5666,7 +5666,7 @@
           <p:cNvPr id="108" name="Google Shape;108;p23">
             <a:extLst xmlns:a="http://schemas.openxmlformats.org/drawingml/2006/main">
               <a:ext uri="{FF2B5EF4-FFF2-40B4-BE49-F238E27FC236}">
-                <a16:creationId xmlns:a16="http://schemas.microsoft.com/office/drawing/2014/main" id="{D99AF965-DF24-481B-BF92-D20724B89744}"/>
+                <a16:creationId xmlns:a16="http://schemas.microsoft.com/office/drawing/2014/main" id="{FE58B6E0-B45F-4807-87B3-777A82BBBDF7}"/>
               </a:ext>
             </a:extLst>
           </p:cNvPr>
@@ -5897,7 +5897,7 @@
           <p:cNvPr id="109" name="Google Shape;109;p23">
             <a:extLst xmlns:a="http://schemas.openxmlformats.org/drawingml/2006/main">
               <a:ext uri="{FF2B5EF4-FFF2-40B4-BE49-F238E27FC236}">
-                <a16:creationId xmlns:a16="http://schemas.microsoft.com/office/drawing/2014/main" id="{6FCEF3E4-11E2-4FEE-B3BD-100370345616}"/>
+                <a16:creationId xmlns:a16="http://schemas.microsoft.com/office/drawing/2014/main" id="{2EB99A61-D91E-455A-B0C6-1B0E591D21A6}"/>
               </a:ext>
             </a:extLst>
           </p:cNvPr>
@@ -6115,7 +6115,7 @@
           <p:cNvPr id="110" name="Google Shape;110;p23">
             <a:extLst xmlns:a="http://schemas.openxmlformats.org/drawingml/2006/main">
               <a:ext uri="{FF2B5EF4-FFF2-40B4-BE49-F238E27FC236}">
-                <a16:creationId xmlns:a16="http://schemas.microsoft.com/office/drawing/2014/main" id="{BFE5621F-9199-4618-8987-ADDF579A7CCA}"/>
+                <a16:creationId xmlns:a16="http://schemas.microsoft.com/office/drawing/2014/main" id="{9FD0E492-DC81-4D03-A303-46DABF807136}"/>
               </a:ext>
             </a:extLst>
           </p:cNvPr>
@@ -6168,7 +6168,7 @@
           <p:cNvPr id="111" name="Google Shape;111;p23">
             <a:extLst xmlns:a="http://schemas.openxmlformats.org/drawingml/2006/main">
               <a:ext uri="{FF2B5EF4-FFF2-40B4-BE49-F238E27FC236}">
-                <a16:creationId xmlns:a16="http://schemas.microsoft.com/office/drawing/2014/main" id="{6757BBA0-6DD3-4714-80D6-4C00A1C0DC99}"/>
+                <a16:creationId xmlns:a16="http://schemas.microsoft.com/office/drawing/2014/main" id="{48528EB2-2212-49D2-9E50-76CFE2DECF9D}"/>
               </a:ext>
             </a:extLst>
           </p:cNvPr>
@@ -6386,7 +6386,7 @@
           <p:cNvPr id="112" name="Google Shape;112;p23">
             <a:extLst xmlns:a="http://schemas.openxmlformats.org/drawingml/2006/main">
               <a:ext uri="{FF2B5EF4-FFF2-40B4-BE49-F238E27FC236}">
-                <a16:creationId xmlns:a16="http://schemas.microsoft.com/office/drawing/2014/main" id="{9808C8FA-AAD6-469B-830A-16AB6B44D98B}"/>
+                <a16:creationId xmlns:a16="http://schemas.microsoft.com/office/drawing/2014/main" id="{074EE5B2-6637-4B02-9201-63F48FC0087F}"/>
               </a:ext>
             </a:extLst>
           </p:cNvPr>
@@ -6604,7 +6604,7 @@
           <p:cNvPr id="113" name="Google Shape;113;p23">
             <a:extLst xmlns:a="http://schemas.openxmlformats.org/drawingml/2006/main">
               <a:ext uri="{FF2B5EF4-FFF2-40B4-BE49-F238E27FC236}">
-                <a16:creationId xmlns:a16="http://schemas.microsoft.com/office/drawing/2014/main" id="{B62EC5CA-F8FA-42C1-960B-9F386138BB52}"/>
+                <a16:creationId xmlns:a16="http://schemas.microsoft.com/office/drawing/2014/main" id="{33667916-0DA2-409F-AE44-25B92C28A0D9}"/>
               </a:ext>
             </a:extLst>
           </p:cNvPr>
@@ -6826,7 +6826,7 @@
           <p:nvPr/>
         </p:nvPicPr>
         <p:blipFill rotWithShape="1">
-          <a:blip xmlns:r="http://schemas.openxmlformats.org/officeDocument/2006/relationships" xmlns:a="http://schemas.openxmlformats.org/drawingml/2006/main" r:embed="R9125e703670c474d">
+          <a:blip xmlns:r="http://schemas.openxmlformats.org/officeDocument/2006/relationships" xmlns:a="http://schemas.openxmlformats.org/drawingml/2006/main" r:embed="Rebdb660a56e24f42">
             <a:alphaModFix/>
           </a:blip>
           <a:srcRect xmlns:a="http://schemas.openxmlformats.org/drawingml/2006/main" l="0" t="0" r="0" b="0"/>
@@ -6874,7 +6874,7 @@
           <p:cNvPr id="116" name="Google Shape;116;p24">
             <a:extLst xmlns:a="http://schemas.openxmlformats.org/drawingml/2006/main">
               <a:ext uri="{FF2B5EF4-FFF2-40B4-BE49-F238E27FC236}">
-                <a16:creationId xmlns:a16="http://schemas.microsoft.com/office/drawing/2014/main" id="{1F1C6217-5898-4ED1-8407-9B78BC8A4BC1}"/>
+                <a16:creationId xmlns:a16="http://schemas.microsoft.com/office/drawing/2014/main" id="{F9A43889-5D94-48EB-95E4-51EF528E56FE}"/>
               </a:ext>
             </a:extLst>
           </p:cNvPr>
@@ -7033,7 +7033,7 @@
           <p:cNvPr id="117" name="Google Shape;117;p24">
             <a:extLst xmlns:a="http://schemas.openxmlformats.org/drawingml/2006/main">
               <a:ext uri="{FF2B5EF4-FFF2-40B4-BE49-F238E27FC236}">
-                <a16:creationId xmlns:a16="http://schemas.microsoft.com/office/drawing/2014/main" id="{302A0DC1-CBD6-4835-BBF0-A6046F9EDFFE}"/>
+                <a16:creationId xmlns:a16="http://schemas.microsoft.com/office/drawing/2014/main" id="{1A6FF06A-66A9-475D-A2A1-35D7374D2DE8}"/>
               </a:ext>
             </a:extLst>
           </p:cNvPr>
@@ -7264,7 +7264,7 @@
           <p:cNvPr id="118" name="Google Shape;118;p24">
             <a:extLst xmlns:a="http://schemas.openxmlformats.org/drawingml/2006/main">
               <a:ext uri="{FF2B5EF4-FFF2-40B4-BE49-F238E27FC236}">
-                <a16:creationId xmlns:a16="http://schemas.microsoft.com/office/drawing/2014/main" id="{13D0539E-0AC0-4A27-B0D1-2AF0BB58986E}"/>
+                <a16:creationId xmlns:a16="http://schemas.microsoft.com/office/drawing/2014/main" id="{7D100447-3145-4680-9E86-F1A50B4EE831}"/>
               </a:ext>
             </a:extLst>
           </p:cNvPr>
@@ -7482,7 +7482,7 @@
           <p:cNvPr id="119" name="Google Shape;119;p24">
             <a:extLst xmlns:a="http://schemas.openxmlformats.org/drawingml/2006/main">
               <a:ext uri="{FF2B5EF4-FFF2-40B4-BE49-F238E27FC236}">
-                <a16:creationId xmlns:a16="http://schemas.microsoft.com/office/drawing/2014/main" id="{4A0F99BE-3233-468C-B2F2-CFA54F4609D3}"/>
+                <a16:creationId xmlns:a16="http://schemas.microsoft.com/office/drawing/2014/main" id="{69324283-89DF-4855-B52C-EE5B6425629F}"/>
               </a:ext>
             </a:extLst>
           </p:cNvPr>
@@ -7535,7 +7535,7 @@
           <p:cNvPr id="120" name="Google Shape;120;p24">
             <a:extLst xmlns:a="http://schemas.openxmlformats.org/drawingml/2006/main">
               <a:ext uri="{FF2B5EF4-FFF2-40B4-BE49-F238E27FC236}">
-                <a16:creationId xmlns:a16="http://schemas.microsoft.com/office/drawing/2014/main" id="{E6CF25AA-9DF8-4FE0-9546-568CB52AAE4C}"/>
+                <a16:creationId xmlns:a16="http://schemas.microsoft.com/office/drawing/2014/main" id="{14EF62CC-60BE-4D1C-A966-4EA76A8709CA}"/>
               </a:ext>
             </a:extLst>
           </p:cNvPr>
@@ -7753,7 +7753,7 @@
           <p:cNvPr id="121" name="Google Shape;121;p24">
             <a:extLst xmlns:a="http://schemas.openxmlformats.org/drawingml/2006/main">
               <a:ext uri="{FF2B5EF4-FFF2-40B4-BE49-F238E27FC236}">
-                <a16:creationId xmlns:a16="http://schemas.microsoft.com/office/drawing/2014/main" id="{8F944043-AA85-42B5-A4EB-FB17FB68BDF4}"/>
+                <a16:creationId xmlns:a16="http://schemas.microsoft.com/office/drawing/2014/main" id="{7A325419-2979-4AF8-A824-F8173F76A8BB}"/>
               </a:ext>
             </a:extLst>
           </p:cNvPr>
@@ -7971,7 +7971,7 @@
           <p:cNvPr id="122" name="Google Shape;122;p24">
             <a:extLst xmlns:a="http://schemas.openxmlformats.org/drawingml/2006/main">
               <a:ext uri="{FF2B5EF4-FFF2-40B4-BE49-F238E27FC236}">
-                <a16:creationId xmlns:a16="http://schemas.microsoft.com/office/drawing/2014/main" id="{BEB57F0B-5B03-487C-8233-DB9FB23F17C1}"/>
+                <a16:creationId xmlns:a16="http://schemas.microsoft.com/office/drawing/2014/main" id="{DF0C9908-CA95-4CC5-B263-51A92E2C4781}"/>
               </a:ext>
             </a:extLst>
           </p:cNvPr>
@@ -8189,7 +8189,7 @@
           <p:cNvPr id="123" name="Google Shape;123;p24">
             <a:extLst xmlns:a="http://schemas.openxmlformats.org/drawingml/2006/main">
               <a:ext uri="{FF2B5EF4-FFF2-40B4-BE49-F238E27FC236}">
-                <a16:creationId xmlns:a16="http://schemas.microsoft.com/office/drawing/2014/main" id="{3EFBC247-A44D-4A4D-9FD8-C9DD35DE1CCA}"/>
+                <a16:creationId xmlns:a16="http://schemas.microsoft.com/office/drawing/2014/main" id="{229286A8-7781-4CB0-A44B-37E849288717}"/>
               </a:ext>
             </a:extLst>
           </p:cNvPr>
@@ -8407,7 +8407,7 @@
           <p:cNvPr id="124" name="Google Shape;124;p24">
             <a:extLst xmlns:a="http://schemas.openxmlformats.org/drawingml/2006/main">
               <a:ext uri="{FF2B5EF4-FFF2-40B4-BE49-F238E27FC236}">
-                <a16:creationId xmlns:a16="http://schemas.microsoft.com/office/drawing/2014/main" id="{702E5068-5015-42F9-B905-648A174EB1BA}"/>
+                <a16:creationId xmlns:a16="http://schemas.microsoft.com/office/drawing/2014/main" id="{B3563878-942A-4F5B-A00B-660530C1A15D}"/>
               </a:ext>
             </a:extLst>
           </p:cNvPr>
@@ -8625,7 +8625,7 @@
           <p:cNvPr id="125" name="Google Shape;125;p24">
             <a:extLst xmlns:a="http://schemas.openxmlformats.org/drawingml/2006/main">
               <a:ext uri="{FF2B5EF4-FFF2-40B4-BE49-F238E27FC236}">
-                <a16:creationId xmlns:a16="http://schemas.microsoft.com/office/drawing/2014/main" id="{09568342-0543-496B-8530-378CE0D68638}"/>
+                <a16:creationId xmlns:a16="http://schemas.microsoft.com/office/drawing/2014/main" id="{7C3961C8-1D88-42E8-9D51-3FC6B6CE2750}"/>
               </a:ext>
             </a:extLst>
           </p:cNvPr>
@@ -8843,7 +8843,7 @@
           <p:cNvPr id="126" name="Google Shape;126;p24">
             <a:extLst xmlns:a="http://schemas.openxmlformats.org/drawingml/2006/main">
               <a:ext uri="{FF2B5EF4-FFF2-40B4-BE49-F238E27FC236}">
-                <a16:creationId xmlns:a16="http://schemas.microsoft.com/office/drawing/2014/main" id="{619FA87E-8B2F-477C-AA04-83187F4557A1}"/>
+                <a16:creationId xmlns:a16="http://schemas.microsoft.com/office/drawing/2014/main" id="{C05B9BD6-4398-4ECB-AA2A-68FF6939B0B7}"/>
               </a:ext>
             </a:extLst>
           </p:cNvPr>
@@ -9065,7 +9065,7 @@
           <p:nvPr/>
         </p:nvPicPr>
         <p:blipFill rotWithShape="1">
-          <a:blip xmlns:r="http://schemas.openxmlformats.org/officeDocument/2006/relationships" xmlns:a="http://schemas.openxmlformats.org/drawingml/2006/main" r:embed="R0a9800c03f734668">
+          <a:blip xmlns:r="http://schemas.openxmlformats.org/officeDocument/2006/relationships" xmlns:a="http://schemas.openxmlformats.org/drawingml/2006/main" r:embed="Rb5124f87f4cd43ea">
             <a:alphaModFix/>
           </a:blip>
           <a:srcRect xmlns:a="http://schemas.openxmlformats.org/drawingml/2006/main" l="0" t="0" r="0" b="0"/>
@@ -9113,7 +9113,7 @@
           <p:cNvPr id="129" name="Google Shape;129;p25">
             <a:extLst xmlns:a="http://schemas.openxmlformats.org/drawingml/2006/main">
               <a:ext uri="{FF2B5EF4-FFF2-40B4-BE49-F238E27FC236}">
-                <a16:creationId xmlns:a16="http://schemas.microsoft.com/office/drawing/2014/main" id="{5AA92133-3B39-42BC-8DA8-FA2FA20C4C9E}"/>
+                <a16:creationId xmlns:a16="http://schemas.microsoft.com/office/drawing/2014/main" id="{3B859486-CCA4-4FDB-8771-00F7CA6EDADE}"/>
               </a:ext>
             </a:extLst>
           </p:cNvPr>
@@ -9272,7 +9272,7 @@
           <p:cNvPr id="130" name="Google Shape;130;p25">
             <a:extLst xmlns:a="http://schemas.openxmlformats.org/drawingml/2006/main">
               <a:ext uri="{FF2B5EF4-FFF2-40B4-BE49-F238E27FC236}">
-                <a16:creationId xmlns:a16="http://schemas.microsoft.com/office/drawing/2014/main" id="{8F91DC11-78E0-48AD-BFD1-B1A3FD3188FB}"/>
+                <a16:creationId xmlns:a16="http://schemas.microsoft.com/office/drawing/2014/main" id="{8513670B-27AC-42C4-B607-4F2DE2D07FA2}"/>
               </a:ext>
             </a:extLst>
           </p:cNvPr>
@@ -9503,7 +9503,7 @@
           <p:cNvPr id="131" name="Google Shape;131;p25">
             <a:extLst xmlns:a="http://schemas.openxmlformats.org/drawingml/2006/main">
               <a:ext uri="{FF2B5EF4-FFF2-40B4-BE49-F238E27FC236}">
-                <a16:creationId xmlns:a16="http://schemas.microsoft.com/office/drawing/2014/main" id="{B6DD928C-43F2-4E17-BDC1-135F6490FD0F}"/>
+                <a16:creationId xmlns:a16="http://schemas.microsoft.com/office/drawing/2014/main" id="{5199F204-95EF-46C9-B431-D036F81A1EB9}"/>
               </a:ext>
             </a:extLst>
           </p:cNvPr>
@@ -9560,7 +9560,7 @@
           <p:nvPr/>
         </p:nvPicPr>
         <p:blipFill rotWithShape="1">
-          <a:blip xmlns:r="http://schemas.openxmlformats.org/officeDocument/2006/relationships" xmlns:a="http://schemas.openxmlformats.org/drawingml/2006/main" r:embed="Rf6a155ff188442b4">
+          <a:blip xmlns:r="http://schemas.openxmlformats.org/officeDocument/2006/relationships" xmlns:a="http://schemas.openxmlformats.org/drawingml/2006/main" r:embed="R98be08f744754052">
             <a:alphaModFix/>
           </a:blip>
           <a:srcRect xmlns:a="http://schemas.openxmlformats.org/drawingml/2006/main" l="0" t="0" r="0" b="0"/>
@@ -9608,7 +9608,7 @@
           <p:cNvPr id="134" name="Google Shape;134;p26">
             <a:extLst xmlns:a="http://schemas.openxmlformats.org/drawingml/2006/main">
               <a:ext uri="{FF2B5EF4-FFF2-40B4-BE49-F238E27FC236}">
-                <a16:creationId xmlns:a16="http://schemas.microsoft.com/office/drawing/2014/main" id="{E255430B-6B8F-4ACE-84C9-52A9066D754A}"/>
+                <a16:creationId xmlns:a16="http://schemas.microsoft.com/office/drawing/2014/main" id="{69029ABF-4D6E-4A04-A302-53C561370025}"/>
               </a:ext>
             </a:extLst>
           </p:cNvPr>
@@ -9767,7 +9767,7 @@
           <p:cNvPr id="135" name="Google Shape;135;p26">
             <a:extLst xmlns:a="http://schemas.openxmlformats.org/drawingml/2006/main">
               <a:ext uri="{FF2B5EF4-FFF2-40B4-BE49-F238E27FC236}">
-                <a16:creationId xmlns:a16="http://schemas.microsoft.com/office/drawing/2014/main" id="{160791E6-0B92-425F-A8F3-99E086D35BDF}"/>
+                <a16:creationId xmlns:a16="http://schemas.microsoft.com/office/drawing/2014/main" id="{91A9492E-39E3-4E0D-AE50-60B9F7C4FADD}"/>
               </a:ext>
             </a:extLst>
           </p:cNvPr>
@@ -9998,7 +9998,7 @@
           <p:cNvPr id="136" name="Google Shape;136;p26">
             <a:extLst xmlns:a="http://schemas.openxmlformats.org/drawingml/2006/main">
               <a:ext uri="{FF2B5EF4-FFF2-40B4-BE49-F238E27FC236}">
-                <a16:creationId xmlns:a16="http://schemas.microsoft.com/office/drawing/2014/main" id="{34E7C5D0-4981-420F-B00C-DB100C0F7B0F}"/>
+                <a16:creationId xmlns:a16="http://schemas.microsoft.com/office/drawing/2014/main" id="{81916E06-E573-4807-8450-CC7C013BB3D4}"/>
               </a:ext>
             </a:extLst>
           </p:cNvPr>
@@ -10055,7 +10055,7 @@
           <p:nvPr/>
         </p:nvPicPr>
         <p:blipFill rotWithShape="1">
-          <a:blip xmlns:r="http://schemas.openxmlformats.org/officeDocument/2006/relationships" xmlns:a="http://schemas.openxmlformats.org/drawingml/2006/main" r:embed="R1a050e43deb34c1a">
+          <a:blip xmlns:r="http://schemas.openxmlformats.org/officeDocument/2006/relationships" xmlns:a="http://schemas.openxmlformats.org/drawingml/2006/main" r:embed="Rd699300112cc4dd9">
             <a:alphaModFix/>
           </a:blip>
           <a:srcRect xmlns:a="http://schemas.openxmlformats.org/drawingml/2006/main" l="0" t="0" r="0" b="0"/>
@@ -10096,7 +10096,7 @@
           <p:cNvPr id="139" name="Google Shape;139;p27">
             <a:extLst xmlns:a="http://schemas.openxmlformats.org/drawingml/2006/main">
               <a:ext uri="{FF2B5EF4-FFF2-40B4-BE49-F238E27FC236}">
-                <a16:creationId xmlns:a16="http://schemas.microsoft.com/office/drawing/2014/main" id="{610CF737-4470-489F-830C-36FC17539CD8}"/>
+                <a16:creationId xmlns:a16="http://schemas.microsoft.com/office/drawing/2014/main" id="{5797F343-E46F-4672-81A6-1DC57D9A1ED2}"/>
               </a:ext>
             </a:extLst>
           </p:cNvPr>
@@ -10251,7 +10251,7 @@
           <p:cNvPr id="140" name="Google Shape;140;p27">
             <a:extLst xmlns:a="http://schemas.openxmlformats.org/drawingml/2006/main">
               <a:ext uri="{FF2B5EF4-FFF2-40B4-BE49-F238E27FC236}">
-                <a16:creationId xmlns:a16="http://schemas.microsoft.com/office/drawing/2014/main" id="{D7264804-D6B0-4DDA-997A-DCAEB4D10C11}"/>
+                <a16:creationId xmlns:a16="http://schemas.microsoft.com/office/drawing/2014/main" id="{63816D40-342F-46D3-A205-2121E35DE0B0}"/>
               </a:ext>
             </a:extLst>
           </p:cNvPr>
@@ -10419,7 +10419,7 @@
           <p:cNvPr id="141" name="Google Shape;141;p27">
             <a:extLst xmlns:a="http://schemas.openxmlformats.org/drawingml/2006/main">
               <a:ext uri="{FF2B5EF4-FFF2-40B4-BE49-F238E27FC236}">
-                <a16:creationId xmlns:a16="http://schemas.microsoft.com/office/drawing/2014/main" id="{D85A1234-9E42-4227-9733-9AD8F1AB281E}"/>
+                <a16:creationId xmlns:a16="http://schemas.microsoft.com/office/drawing/2014/main" id="{B6F8D44A-AFB7-47C5-AB97-81DEB12F7E2C}"/>
               </a:ext>
             </a:extLst>
           </p:cNvPr>
@@ -10639,7 +10639,7 @@
           <p:cNvPr id="142" name="Google Shape;142;p27">
             <a:extLst xmlns:a="http://schemas.openxmlformats.org/drawingml/2006/main">
               <a:ext uri="{FF2B5EF4-FFF2-40B4-BE49-F238E27FC236}">
-                <a16:creationId xmlns:a16="http://schemas.microsoft.com/office/drawing/2014/main" id="{6ED7DCB0-A771-4EED-9580-63281480402B}"/>
+                <a16:creationId xmlns:a16="http://schemas.microsoft.com/office/drawing/2014/main" id="{2B33C585-3F0E-4AFC-981B-BF3AA305BD53}"/>
               </a:ext>
             </a:extLst>
           </p:cNvPr>
@@ -10859,7 +10859,7 @@
           <p:cNvPr id="143" name="Google Shape;143;p27">
             <a:extLst xmlns:a="http://schemas.openxmlformats.org/drawingml/2006/main">
               <a:ext uri="{FF2B5EF4-FFF2-40B4-BE49-F238E27FC236}">
-                <a16:creationId xmlns:a16="http://schemas.microsoft.com/office/drawing/2014/main" id="{C0857251-9024-47CB-AD50-097D4914F81E}"/>
+                <a16:creationId xmlns:a16="http://schemas.microsoft.com/office/drawing/2014/main" id="{0398EEF7-BDCF-4400-98E1-770B2EF48905}"/>
               </a:ext>
             </a:extLst>
           </p:cNvPr>
@@ -11096,7 +11096,7 @@
           <p:cNvPr id="18" name="Google Shape;18;p10">
             <a:extLst xmlns:a="http://schemas.openxmlformats.org/drawingml/2006/main">
               <a:ext uri="{FF2B5EF4-FFF2-40B4-BE49-F238E27FC236}">
-                <a16:creationId xmlns:a16="http://schemas.microsoft.com/office/drawing/2014/main" id="{D889D51D-3B9A-4CDB-95C6-AC5CC3625E7C}"/>
+                <a16:creationId xmlns:a16="http://schemas.microsoft.com/office/drawing/2014/main" id="{ACE878DF-E1B6-4C9A-93D7-EC0C962DB002}"/>
               </a:ext>
             </a:extLst>
           </p:cNvPr>
@@ -11264,7 +11264,7 @@
           <p:cNvPr id="19" name="Google Shape;19;p10">
             <a:extLst xmlns:a="http://schemas.openxmlformats.org/drawingml/2006/main">
               <a:ext uri="{FF2B5EF4-FFF2-40B4-BE49-F238E27FC236}">
-                <a16:creationId xmlns:a16="http://schemas.microsoft.com/office/drawing/2014/main" id="{F9C9735F-6831-43E4-A103-3887AEBBE9D9}"/>
+                <a16:creationId xmlns:a16="http://schemas.microsoft.com/office/drawing/2014/main" id="{8A4F6385-19DB-4555-8B99-C60F1A1A7FDE}"/>
               </a:ext>
             </a:extLst>
           </p:cNvPr>
@@ -11324,7 +11324,7 @@
           <p:nvPr/>
         </p:nvPicPr>
         <p:blipFill rotWithShape="1">
-          <a:blip xmlns:r="http://schemas.openxmlformats.org/officeDocument/2006/relationships" xmlns:a="http://schemas.openxmlformats.org/drawingml/2006/main" r:embed="Rd57120c041ea46b6">
+          <a:blip xmlns:r="http://schemas.openxmlformats.org/officeDocument/2006/relationships" xmlns:a="http://schemas.openxmlformats.org/drawingml/2006/main" r:embed="R0c7b54b080654062">
             <a:alphaModFix/>
           </a:blip>
           <a:srcRect xmlns:a="http://schemas.openxmlformats.org/drawingml/2006/main" l="0" t="0" r="0" b="0"/>
@@ -11372,7 +11372,7 @@
           <p:cNvPr id="145" name="Google Shape;145;p28">
             <a:extLst xmlns:a="http://schemas.openxmlformats.org/drawingml/2006/main">
               <a:ext uri="{FF2B5EF4-FFF2-40B4-BE49-F238E27FC236}">
-                <a16:creationId xmlns:a16="http://schemas.microsoft.com/office/drawing/2014/main" id="{C8948C48-198F-40AC-B6C0-56C79B9C862F}"/>
+                <a16:creationId xmlns:a16="http://schemas.microsoft.com/office/drawing/2014/main" id="{FBD54997-8559-4CC9-A0A4-2956FB5E6606}"/>
               </a:ext>
             </a:extLst>
           </p:cNvPr>
@@ -11603,7 +11603,7 @@
           <p:cNvPr id="146" name="Google Shape;146;p28">
             <a:extLst xmlns:a="http://schemas.openxmlformats.org/drawingml/2006/main">
               <a:ext uri="{FF2B5EF4-FFF2-40B4-BE49-F238E27FC236}">
-                <a16:creationId xmlns:a16="http://schemas.microsoft.com/office/drawing/2014/main" id="{DB6FD719-6C15-4DC7-AC30-C41F8FF275A5}"/>
+                <a16:creationId xmlns:a16="http://schemas.microsoft.com/office/drawing/2014/main" id="{C3E9D184-70CA-422F-AF7E-B649A0DF67F1}"/>
               </a:ext>
             </a:extLst>
           </p:cNvPr>
@@ -11660,7 +11660,7 @@
           <p:nvPr/>
         </p:nvPicPr>
         <p:blipFill rotWithShape="1">
-          <a:blip xmlns:r="http://schemas.openxmlformats.org/officeDocument/2006/relationships" xmlns:a="http://schemas.openxmlformats.org/drawingml/2006/main" r:embed="R86064239704348aa">
+          <a:blip xmlns:r="http://schemas.openxmlformats.org/officeDocument/2006/relationships" xmlns:a="http://schemas.openxmlformats.org/drawingml/2006/main" r:embed="Rb716a39863104cc9">
             <a:alphaModFix/>
           </a:blip>
           <a:srcRect xmlns:a="http://schemas.openxmlformats.org/drawingml/2006/main" l="0" t="0" r="0" b="0"/>
@@ -11708,7 +11708,7 @@
           <p:cNvPr id="149" name="Google Shape;149;p29">
             <a:extLst xmlns:a="http://schemas.openxmlformats.org/drawingml/2006/main">
               <a:ext uri="{FF2B5EF4-FFF2-40B4-BE49-F238E27FC236}">
-                <a16:creationId xmlns:a16="http://schemas.microsoft.com/office/drawing/2014/main" id="{2467FF43-CBD0-4F12-AD0E-771BB9DC9646}"/>
+                <a16:creationId xmlns:a16="http://schemas.microsoft.com/office/drawing/2014/main" id="{A4215C53-A182-494A-930A-612CCF88F962}"/>
               </a:ext>
             </a:extLst>
           </p:cNvPr>
@@ -11939,7 +11939,7 @@
           <p:cNvPr id="150" name="Google Shape;150;p29">
             <a:extLst xmlns:a="http://schemas.openxmlformats.org/drawingml/2006/main">
               <a:ext uri="{FF2B5EF4-FFF2-40B4-BE49-F238E27FC236}">
-                <a16:creationId xmlns:a16="http://schemas.microsoft.com/office/drawing/2014/main" id="{1365CF70-C92F-4FF5-B8D9-42CD2453A8B8}"/>
+                <a16:creationId xmlns:a16="http://schemas.microsoft.com/office/drawing/2014/main" id="{3398A928-B1F8-4600-B1C5-7CA66A820F41}"/>
               </a:ext>
             </a:extLst>
           </p:cNvPr>
@@ -11996,7 +11996,7 @@
           <p:nvPr/>
         </p:nvPicPr>
         <p:blipFill rotWithShape="1">
-          <a:blip xmlns:r="http://schemas.openxmlformats.org/officeDocument/2006/relationships" xmlns:a="http://schemas.openxmlformats.org/drawingml/2006/main" r:embed="R4a1d683c97b74c89">
+          <a:blip xmlns:r="http://schemas.openxmlformats.org/officeDocument/2006/relationships" xmlns:a="http://schemas.openxmlformats.org/drawingml/2006/main" r:embed="Ra061dc79d2ff417e">
             <a:alphaModFix/>
           </a:blip>
           <a:srcRect xmlns:a="http://schemas.openxmlformats.org/drawingml/2006/main" l="0" t="0" r="0" b="0"/>
@@ -12044,7 +12044,7 @@
           <p:cNvPr id="153" name="Google Shape;153;p30">
             <a:extLst xmlns:a="http://schemas.openxmlformats.org/drawingml/2006/main">
               <a:ext uri="{FF2B5EF4-FFF2-40B4-BE49-F238E27FC236}">
-                <a16:creationId xmlns:a16="http://schemas.microsoft.com/office/drawing/2014/main" id="{4F9A77F9-8FAC-4D5B-AB3B-F97343A5A22F}"/>
+                <a16:creationId xmlns:a16="http://schemas.microsoft.com/office/drawing/2014/main" id="{1049A169-8A5C-4067-8C4D-73E20A16938C}"/>
               </a:ext>
             </a:extLst>
           </p:cNvPr>
@@ -12102,7 +12102,7 @@
           <p:nvPr/>
         </p:nvPicPr>
         <p:blipFill rotWithShape="1">
-          <a:blip xmlns:r="http://schemas.openxmlformats.org/officeDocument/2006/relationships" xmlns:a="http://schemas.openxmlformats.org/drawingml/2006/main" r:embed="Raf6d5c08a28f499a">
+          <a:blip xmlns:r="http://schemas.openxmlformats.org/officeDocument/2006/relationships" xmlns:a="http://schemas.openxmlformats.org/drawingml/2006/main" r:embed="Reec6c0a8d3664415">
             <a:alphaModFix/>
           </a:blip>
           <a:srcRect xmlns:a="http://schemas.openxmlformats.org/drawingml/2006/main" l="0" t="0" r="0" b="0"/>
@@ -12126,7 +12126,7 @@
           <p:cNvPr id="155" name="Google Shape;155;p30">
             <a:extLst xmlns:a="http://schemas.openxmlformats.org/drawingml/2006/main">
               <a:ext uri="{FF2B5EF4-FFF2-40B4-BE49-F238E27FC236}">
-                <a16:creationId xmlns:a16="http://schemas.microsoft.com/office/drawing/2014/main" id="{50D16268-BB4C-4F3D-AF19-F98C2EB46A9E}"/>
+                <a16:creationId xmlns:a16="http://schemas.microsoft.com/office/drawing/2014/main" id="{D23C4FA8-0532-4308-BDB8-C88586BF0C14}"/>
               </a:ext>
             </a:extLst>
           </p:cNvPr>
@@ -12344,7 +12344,7 @@
           <p:cNvPr id="156" name="Google Shape;156;p30">
             <a:extLst xmlns:a="http://schemas.openxmlformats.org/drawingml/2006/main">
               <a:ext uri="{FF2B5EF4-FFF2-40B4-BE49-F238E27FC236}">
-                <a16:creationId xmlns:a16="http://schemas.microsoft.com/office/drawing/2014/main" id="{F3E62B12-0754-4B02-9C07-EC4B6C74DDF5}"/>
+                <a16:creationId xmlns:a16="http://schemas.microsoft.com/office/drawing/2014/main" id="{2789A1B3-A887-4D13-860C-AA7C3E5122A4}"/>
               </a:ext>
             </a:extLst>
           </p:cNvPr>
@@ -12562,7 +12562,7 @@
           <p:cNvPr id="157" name="Google Shape;157;p30">
             <a:extLst xmlns:a="http://schemas.openxmlformats.org/drawingml/2006/main">
               <a:ext uri="{FF2B5EF4-FFF2-40B4-BE49-F238E27FC236}">
-                <a16:creationId xmlns:a16="http://schemas.microsoft.com/office/drawing/2014/main" id="{EC11EA86-96F3-46C6-852E-ED86AA03BBA7}"/>
+                <a16:creationId xmlns:a16="http://schemas.microsoft.com/office/drawing/2014/main" id="{6CB225EF-DE4C-4EE2-9EFE-54066CBE10AD}"/>
               </a:ext>
             </a:extLst>
           </p:cNvPr>
@@ -12780,7 +12780,7 @@
           <p:cNvPr id="158" name="Google Shape;158;p30">
             <a:extLst xmlns:a="http://schemas.openxmlformats.org/drawingml/2006/main">
               <a:ext uri="{FF2B5EF4-FFF2-40B4-BE49-F238E27FC236}">
-                <a16:creationId xmlns:a16="http://schemas.microsoft.com/office/drawing/2014/main" id="{D6058F4B-791A-4424-81D2-BD8ADB62E0BB}"/>
+                <a16:creationId xmlns:a16="http://schemas.microsoft.com/office/drawing/2014/main" id="{C2AC4274-07BC-478C-8C2A-AEF3228C6670}"/>
               </a:ext>
             </a:extLst>
           </p:cNvPr>
@@ -12998,7 +12998,7 @@
           <p:cNvPr id="159" name="Google Shape;159;p30">
             <a:extLst xmlns:a="http://schemas.openxmlformats.org/drawingml/2006/main">
               <a:ext uri="{FF2B5EF4-FFF2-40B4-BE49-F238E27FC236}">
-                <a16:creationId xmlns:a16="http://schemas.microsoft.com/office/drawing/2014/main" id="{9DC6C36F-82CE-416F-BE82-6C8A8BAA8B05}"/>
+                <a16:creationId xmlns:a16="http://schemas.microsoft.com/office/drawing/2014/main" id="{6DA62549-7F8D-489D-A882-04293741EE81}"/>
               </a:ext>
             </a:extLst>
           </p:cNvPr>
@@ -13216,7 +13216,7 @@
           <p:cNvPr id="160" name="Google Shape;160;p30">
             <a:extLst xmlns:a="http://schemas.openxmlformats.org/drawingml/2006/main">
               <a:ext uri="{FF2B5EF4-FFF2-40B4-BE49-F238E27FC236}">
-                <a16:creationId xmlns:a16="http://schemas.microsoft.com/office/drawing/2014/main" id="{B155B977-1098-4A2F-9283-DC80DA09229D}"/>
+                <a16:creationId xmlns:a16="http://schemas.microsoft.com/office/drawing/2014/main" id="{10644B8E-3339-4B83-9F86-A5AA41829C15}"/>
               </a:ext>
             </a:extLst>
           </p:cNvPr>
@@ -13434,7 +13434,7 @@
           <p:cNvPr id="161" name="Google Shape;161;p30">
             <a:extLst xmlns:a="http://schemas.openxmlformats.org/drawingml/2006/main">
               <a:ext uri="{FF2B5EF4-FFF2-40B4-BE49-F238E27FC236}">
-                <a16:creationId xmlns:a16="http://schemas.microsoft.com/office/drawing/2014/main" id="{A726F2E1-25B2-4749-B95B-56B958148078}"/>
+                <a16:creationId xmlns:a16="http://schemas.microsoft.com/office/drawing/2014/main" id="{ABBBB78A-1398-4F7D-A08A-4AC1AB7BE3CF}"/>
               </a:ext>
             </a:extLst>
           </p:cNvPr>
@@ -13652,7 +13652,7 @@
           <p:cNvPr id="162" name="Google Shape;162;p30">
             <a:extLst xmlns:a="http://schemas.openxmlformats.org/drawingml/2006/main">
               <a:ext uri="{FF2B5EF4-FFF2-40B4-BE49-F238E27FC236}">
-                <a16:creationId xmlns:a16="http://schemas.microsoft.com/office/drawing/2014/main" id="{8CA0EF6C-2A6B-41BC-B469-B0FBD60A1050}"/>
+                <a16:creationId xmlns:a16="http://schemas.microsoft.com/office/drawing/2014/main" id="{ADB3DAF2-B226-49F9-AC88-CA85B841B86B}"/>
               </a:ext>
             </a:extLst>
           </p:cNvPr>
@@ -13874,7 +13874,7 @@
           <p:nvPr/>
         </p:nvPicPr>
         <p:blipFill rotWithShape="1">
-          <a:blip xmlns:r="http://schemas.openxmlformats.org/officeDocument/2006/relationships" xmlns:a="http://schemas.openxmlformats.org/drawingml/2006/main" r:embed="R2d89df7182f24e5b">
+          <a:blip xmlns:r="http://schemas.openxmlformats.org/officeDocument/2006/relationships" xmlns:a="http://schemas.openxmlformats.org/drawingml/2006/main" r:embed="R7a8c2b900a9a486a">
             <a:alphaModFix/>
           </a:blip>
           <a:srcRect xmlns:a="http://schemas.openxmlformats.org/drawingml/2006/main" l="0" t="0" r="0" b="0"/>
@@ -13919,7 +13919,7 @@
           <p:nvPr/>
         </p:nvPicPr>
         <p:blipFill rotWithShape="1">
-          <a:blip xmlns:r="http://schemas.openxmlformats.org/officeDocument/2006/relationships" xmlns:a="http://schemas.openxmlformats.org/drawingml/2006/main" r:embed="R3d5cfacd818a4513">
+          <a:blip xmlns:r="http://schemas.openxmlformats.org/officeDocument/2006/relationships" xmlns:a="http://schemas.openxmlformats.org/drawingml/2006/main" r:embed="R5fe9f83a334747ea">
             <a:alphaModFix/>
           </a:blip>
           <a:srcRect xmlns:a="http://schemas.openxmlformats.org/drawingml/2006/main" l="0" t="0" r="0" b="0"/>
@@ -13947,7 +13947,7 @@
           <p:nvPr/>
         </p:nvPicPr>
         <p:blipFill rotWithShape="1">
-          <a:blip xmlns:r="http://schemas.openxmlformats.org/officeDocument/2006/relationships" xmlns:a="http://schemas.openxmlformats.org/drawingml/2006/main" r:embed="R603a39f1b22b4ed5">
+          <a:blip xmlns:r="http://schemas.openxmlformats.org/officeDocument/2006/relationships" xmlns:a="http://schemas.openxmlformats.org/drawingml/2006/main" r:embed="R566e9fc2ca234a1b">
             <a:alphaModFix/>
           </a:blip>
           <a:srcRect xmlns:a="http://schemas.openxmlformats.org/drawingml/2006/main" l="0" t="0" r="0" b="0"/>
@@ -13971,7 +13971,7 @@
           <p:cNvPr id="24" name="Google Shape;24;p11">
             <a:extLst xmlns:a="http://schemas.openxmlformats.org/drawingml/2006/main">
               <a:ext uri="{FF2B5EF4-FFF2-40B4-BE49-F238E27FC236}">
-                <a16:creationId xmlns:a16="http://schemas.microsoft.com/office/drawing/2014/main" id="{7650BE85-9705-4413-A7DC-360F390138B2}"/>
+                <a16:creationId xmlns:a16="http://schemas.microsoft.com/office/drawing/2014/main" id="{DC66FE13-F770-42BD-AA28-BF6481CD75A8}"/>
               </a:ext>
             </a:extLst>
           </p:cNvPr>
@@ -14130,7 +14130,7 @@
           <p:cNvPr id="25" name="Google Shape;25;p11">
             <a:extLst xmlns:a="http://schemas.openxmlformats.org/drawingml/2006/main">
               <a:ext uri="{FF2B5EF4-FFF2-40B4-BE49-F238E27FC236}">
-                <a16:creationId xmlns:a16="http://schemas.microsoft.com/office/drawing/2014/main" id="{B78C41A2-BAC8-4C03-BAC6-56ABC8F763F8}"/>
+                <a16:creationId xmlns:a16="http://schemas.microsoft.com/office/drawing/2014/main" id="{BA77CE6B-823B-41EB-B828-4D79472AF1FB}"/>
               </a:ext>
             </a:extLst>
           </p:cNvPr>
@@ -14361,7 +14361,7 @@
           <p:cNvPr id="26" name="Google Shape;26;p11">
             <a:extLst xmlns:a="http://schemas.openxmlformats.org/drawingml/2006/main">
               <a:ext uri="{FF2B5EF4-FFF2-40B4-BE49-F238E27FC236}">
-                <a16:creationId xmlns:a16="http://schemas.microsoft.com/office/drawing/2014/main" id="{784E466E-4443-4814-BF1D-0E5B5C520DCA}"/>
+                <a16:creationId xmlns:a16="http://schemas.microsoft.com/office/drawing/2014/main" id="{B95EEA54-B6D2-41B8-BAC0-3D4C2C485592}"/>
               </a:ext>
             </a:extLst>
           </p:cNvPr>
@@ -14579,7 +14579,7 @@
           <p:cNvPr id="27" name="Google Shape;27;p11">
             <a:extLst xmlns:a="http://schemas.openxmlformats.org/drawingml/2006/main">
               <a:ext uri="{FF2B5EF4-FFF2-40B4-BE49-F238E27FC236}">
-                <a16:creationId xmlns:a16="http://schemas.microsoft.com/office/drawing/2014/main" id="{B26BC206-4461-4D13-8CEA-580EBC577FE9}"/>
+                <a16:creationId xmlns:a16="http://schemas.microsoft.com/office/drawing/2014/main" id="{A9F5711B-87A9-4E14-8247-8E10314519D7}"/>
               </a:ext>
             </a:extLst>
           </p:cNvPr>
@@ -14797,7 +14797,7 @@
           <p:cNvPr id="28" name="Google Shape;28;p11">
             <a:extLst xmlns:a="http://schemas.openxmlformats.org/drawingml/2006/main">
               <a:ext uri="{FF2B5EF4-FFF2-40B4-BE49-F238E27FC236}">
-                <a16:creationId xmlns:a16="http://schemas.microsoft.com/office/drawing/2014/main" id="{10CBAAFA-C9FB-41A3-8D55-BBEAF90A34EF}"/>
+                <a16:creationId xmlns:a16="http://schemas.microsoft.com/office/drawing/2014/main" id="{3556A533-4C61-4895-8CF7-67702D76320B}"/>
               </a:ext>
             </a:extLst>
           </p:cNvPr>
@@ -15015,7 +15015,7 @@
           <p:cNvPr id="29" name="Google Shape;29;p11">
             <a:extLst xmlns:a="http://schemas.openxmlformats.org/drawingml/2006/main">
               <a:ext uri="{FF2B5EF4-FFF2-40B4-BE49-F238E27FC236}">
-                <a16:creationId xmlns:a16="http://schemas.microsoft.com/office/drawing/2014/main" id="{774690CB-0201-4409-B0A6-6F6E51645FF0}"/>
+                <a16:creationId xmlns:a16="http://schemas.microsoft.com/office/drawing/2014/main" id="{82D0F046-395A-4A96-BD14-83BFC751A4F3}"/>
               </a:ext>
             </a:extLst>
           </p:cNvPr>
@@ -15233,7 +15233,7 @@
           <p:cNvPr id="30" name="Google Shape;30;p11">
             <a:extLst xmlns:a="http://schemas.openxmlformats.org/drawingml/2006/main">
               <a:ext uri="{FF2B5EF4-FFF2-40B4-BE49-F238E27FC236}">
-                <a16:creationId xmlns:a16="http://schemas.microsoft.com/office/drawing/2014/main" id="{C4C9BF1F-8C13-45FD-887C-7DFD36349520}"/>
+                <a16:creationId xmlns:a16="http://schemas.microsoft.com/office/drawing/2014/main" id="{3546BFAF-CAE4-4AFB-8EBC-4D744E8917D8}"/>
               </a:ext>
             </a:extLst>
           </p:cNvPr>
@@ -15290,7 +15290,7 @@
           <p:nvPr/>
         </p:nvPicPr>
         <p:blipFill rotWithShape="1">
-          <a:blip xmlns:r="http://schemas.openxmlformats.org/officeDocument/2006/relationships" xmlns:a="http://schemas.openxmlformats.org/drawingml/2006/main" r:embed="R8db2f774094e4fd3">
+          <a:blip xmlns:r="http://schemas.openxmlformats.org/officeDocument/2006/relationships" xmlns:a="http://schemas.openxmlformats.org/drawingml/2006/main" r:embed="Rfb18842804f84649">
             <a:alphaModFix/>
           </a:blip>
           <a:srcRect xmlns:a="http://schemas.openxmlformats.org/drawingml/2006/main" l="0" t="0" r="0" b="0"/>
@@ -15331,7 +15331,7 @@
           <p:cNvPr id="33" name="Google Shape;33;p12">
             <a:extLst xmlns:a="http://schemas.openxmlformats.org/drawingml/2006/main">
               <a:ext uri="{FF2B5EF4-FFF2-40B4-BE49-F238E27FC236}">
-                <a16:creationId xmlns:a16="http://schemas.microsoft.com/office/drawing/2014/main" id="{1AB5070A-5F87-4F7E-8881-485DD024AE4C}"/>
+                <a16:creationId xmlns:a16="http://schemas.microsoft.com/office/drawing/2014/main" id="{3BFF5BEA-4D04-45CC-B69D-0795EB99C2D6}"/>
               </a:ext>
             </a:extLst>
           </p:cNvPr>
@@ -15490,7 +15490,7 @@
           <p:nvPr/>
         </p:nvPicPr>
         <p:blipFill rotWithShape="1">
-          <a:blip xmlns:r="http://schemas.openxmlformats.org/officeDocument/2006/relationships" xmlns:a="http://schemas.openxmlformats.org/drawingml/2006/main" r:embed="R6558497227b04120">
+          <a:blip xmlns:r="http://schemas.openxmlformats.org/officeDocument/2006/relationships" xmlns:a="http://schemas.openxmlformats.org/drawingml/2006/main" r:embed="R5095ea7f68b54bf0">
             <a:alphaModFix/>
           </a:blip>
           <a:srcRect xmlns:a="http://schemas.openxmlformats.org/drawingml/2006/main" l="0" t="0" r="0" b="0"/>
@@ -15514,7 +15514,7 @@
           <p:cNvPr id="35" name="Google Shape;35;p12">
             <a:extLst xmlns:a="http://schemas.openxmlformats.org/drawingml/2006/main">
               <a:ext uri="{FF2B5EF4-FFF2-40B4-BE49-F238E27FC236}">
-                <a16:creationId xmlns:a16="http://schemas.microsoft.com/office/drawing/2014/main" id="{F7F57368-E250-4F10-A4B7-969ECCEEDA81}"/>
+                <a16:creationId xmlns:a16="http://schemas.microsoft.com/office/drawing/2014/main" id="{0B625BCF-460B-4D8B-AF5D-E3398D4ECF5B}"/>
               </a:ext>
             </a:extLst>
           </p:cNvPr>
@@ -15572,7 +15572,7 @@
           <p:nvPr/>
         </p:nvPicPr>
         <p:blipFill rotWithShape="1">
-          <a:blip xmlns:r="http://schemas.openxmlformats.org/officeDocument/2006/relationships" xmlns:a="http://schemas.openxmlformats.org/drawingml/2006/main" r:embed="Rf6aeda81238a4342">
+          <a:blip xmlns:r="http://schemas.openxmlformats.org/officeDocument/2006/relationships" xmlns:a="http://schemas.openxmlformats.org/drawingml/2006/main" r:embed="R34757adf9de54807">
             <a:alphaModFix/>
           </a:blip>
           <a:srcRect xmlns:a="http://schemas.openxmlformats.org/drawingml/2006/main" l="0" t="0" r="0" b="0"/>
@@ -15600,7 +15600,7 @@
           <p:nvPr/>
         </p:nvPicPr>
         <p:blipFill rotWithShape="1">
-          <a:blip xmlns:r="http://schemas.openxmlformats.org/officeDocument/2006/relationships" xmlns:a="http://schemas.openxmlformats.org/drawingml/2006/main" r:embed="R8d582ff7c3a34322">
+          <a:blip xmlns:r="http://schemas.openxmlformats.org/officeDocument/2006/relationships" xmlns:a="http://schemas.openxmlformats.org/drawingml/2006/main" r:embed="R7b15a21b84c94487">
             <a:alphaModFix/>
           </a:blip>
           <a:srcRect xmlns:a="http://schemas.openxmlformats.org/drawingml/2006/main" l="0" t="0" r="0" b="0"/>
@@ -15652,7 +15652,7 @@
           <p:nvPr/>
         </p:nvPicPr>
         <p:blipFill rotWithShape="1">
-          <a:blip xmlns:r="http://schemas.openxmlformats.org/officeDocument/2006/relationships" xmlns:a="http://schemas.openxmlformats.org/drawingml/2006/main" r:embed="R10ad2aa6292045bd">
+          <a:blip xmlns:r="http://schemas.openxmlformats.org/officeDocument/2006/relationships" xmlns:a="http://schemas.openxmlformats.org/drawingml/2006/main" r:embed="Rb2d1976f352148b5">
             <a:alphaModFix/>
           </a:blip>
           <a:srcRect xmlns:a="http://schemas.openxmlformats.org/drawingml/2006/main" l="0" t="0" r="0" b="0"/>
@@ -15680,7 +15680,7 @@
           <p:nvPr/>
         </p:nvPicPr>
         <p:blipFill rotWithShape="1">
-          <a:blip xmlns:r="http://schemas.openxmlformats.org/officeDocument/2006/relationships" xmlns:a="http://schemas.openxmlformats.org/drawingml/2006/main" r:embed="R6796d328bb9c4b0d">
+          <a:blip xmlns:r="http://schemas.openxmlformats.org/officeDocument/2006/relationships" xmlns:a="http://schemas.openxmlformats.org/drawingml/2006/main" r:embed="R58be039657104918">
             <a:alphaModFix/>
           </a:blip>
           <a:srcRect xmlns:a="http://schemas.openxmlformats.org/drawingml/2006/main" l="0" t="0" r="0" b="0"/>
@@ -15704,7 +15704,7 @@
           <p:cNvPr id="41" name="Google Shape;41;p13">
             <a:extLst xmlns:a="http://schemas.openxmlformats.org/drawingml/2006/main">
               <a:ext uri="{FF2B5EF4-FFF2-40B4-BE49-F238E27FC236}">
-                <a16:creationId xmlns:a16="http://schemas.microsoft.com/office/drawing/2014/main" id="{5AC6954A-82E7-455A-9B02-B38998764CA7}"/>
+                <a16:creationId xmlns:a16="http://schemas.microsoft.com/office/drawing/2014/main" id="{4C8D4EFB-735D-4104-9D89-2BD6FA071670}"/>
               </a:ext>
             </a:extLst>
           </p:cNvPr>
@@ -15780,7 +15780,7 @@
           <p:cNvPr id="42" name="Google Shape;42;p13">
             <a:extLst xmlns:a="http://schemas.openxmlformats.org/drawingml/2006/main">
               <a:ext uri="{FF2B5EF4-FFF2-40B4-BE49-F238E27FC236}">
-                <a16:creationId xmlns:a16="http://schemas.microsoft.com/office/drawing/2014/main" id="{C8297FFC-1BC1-4567-9B21-4CE88875BC71}"/>
+                <a16:creationId xmlns:a16="http://schemas.microsoft.com/office/drawing/2014/main" id="{56FFA260-67AE-4AF4-956A-AA9F5BC75939}"/>
               </a:ext>
             </a:extLst>
           </p:cNvPr>
@@ -15834,7 +15834,7 @@
           <p:cNvPr id="43" name="Google Shape;43;p13">
             <a:extLst xmlns:a="http://schemas.openxmlformats.org/drawingml/2006/main">
               <a:ext uri="{FF2B5EF4-FFF2-40B4-BE49-F238E27FC236}">
-                <a16:creationId xmlns:a16="http://schemas.microsoft.com/office/drawing/2014/main" id="{89FC20BF-5477-46CA-B91B-4D0E064DC1B8}"/>
+                <a16:creationId xmlns:a16="http://schemas.microsoft.com/office/drawing/2014/main" id="{BD965C4D-E4CA-46B8-AA5B-D63862B1F24F}"/>
               </a:ext>
             </a:extLst>
           </p:cNvPr>
@@ -16052,7 +16052,7 @@
           <p:cNvPr id="44" name="Google Shape;44;p13">
             <a:extLst xmlns:a="http://schemas.openxmlformats.org/drawingml/2006/main">
               <a:ext uri="{FF2B5EF4-FFF2-40B4-BE49-F238E27FC236}">
-                <a16:creationId xmlns:a16="http://schemas.microsoft.com/office/drawing/2014/main" id="{69D8FBBA-512B-48A6-8D76-8224FA4B8FF1}"/>
+                <a16:creationId xmlns:a16="http://schemas.microsoft.com/office/drawing/2014/main" id="{35C9F8A0-55CF-42F2-9F9C-103A7BB46928}"/>
               </a:ext>
             </a:extLst>
           </p:cNvPr>
@@ -16270,7 +16270,7 @@
           <p:cNvPr id="45" name="Google Shape;45;p13">
             <a:extLst xmlns:a="http://schemas.openxmlformats.org/drawingml/2006/main">
               <a:ext uri="{FF2B5EF4-FFF2-40B4-BE49-F238E27FC236}">
-                <a16:creationId xmlns:a16="http://schemas.microsoft.com/office/drawing/2014/main" id="{3A0FC245-AF68-435D-9152-410D1BC5A991}"/>
+                <a16:creationId xmlns:a16="http://schemas.microsoft.com/office/drawing/2014/main" id="{2FF09589-0DD2-43DA-A6E5-6F8D1CDB24A0}"/>
               </a:ext>
             </a:extLst>
           </p:cNvPr>
@@ -16492,7 +16492,7 @@
           <p:nvPr/>
         </p:nvPicPr>
         <p:blipFill rotWithShape="1">
-          <a:blip xmlns:r="http://schemas.openxmlformats.org/officeDocument/2006/relationships" xmlns:a="http://schemas.openxmlformats.org/drawingml/2006/main" r:embed="R3ef7acdd31c54fe9">
+          <a:blip xmlns:r="http://schemas.openxmlformats.org/officeDocument/2006/relationships" xmlns:a="http://schemas.openxmlformats.org/drawingml/2006/main" r:embed="Rd3e182b928054a4f">
             <a:alphaModFix/>
           </a:blip>
           <a:srcRect xmlns:a="http://schemas.openxmlformats.org/drawingml/2006/main" l="0" t="0" r="0" b="0"/>
@@ -16533,7 +16533,7 @@
           <p:cNvPr id="48" name="Google Shape;48;p14">
             <a:extLst xmlns:a="http://schemas.openxmlformats.org/drawingml/2006/main">
               <a:ext uri="{FF2B5EF4-FFF2-40B4-BE49-F238E27FC236}">
-                <a16:creationId xmlns:a16="http://schemas.microsoft.com/office/drawing/2014/main" id="{73F6BE14-AED8-4A78-9F9B-F164AD39CE1E}"/>
+                <a16:creationId xmlns:a16="http://schemas.microsoft.com/office/drawing/2014/main" id="{C8EA9439-1AED-495F-AAF4-C738FA3101E4}"/>
               </a:ext>
             </a:extLst>
           </p:cNvPr>
@@ -16692,7 +16692,7 @@
           <p:cNvPr id="49" name="Google Shape;49;p14">
             <a:extLst xmlns:a="http://schemas.openxmlformats.org/drawingml/2006/main">
               <a:ext uri="{FF2B5EF4-FFF2-40B4-BE49-F238E27FC236}">
-                <a16:creationId xmlns:a16="http://schemas.microsoft.com/office/drawing/2014/main" id="{028BDBD1-43B0-4231-9474-A9940CCC6C48}"/>
+                <a16:creationId xmlns:a16="http://schemas.microsoft.com/office/drawing/2014/main" id="{88A977BC-AF88-4851-B42F-01BFDE2B9438}"/>
               </a:ext>
             </a:extLst>
           </p:cNvPr>
@@ -16860,7 +16860,7 @@
           <p:cNvPr id="50" name="Google Shape;50;p14">
             <a:extLst xmlns:a="http://schemas.openxmlformats.org/drawingml/2006/main">
               <a:ext uri="{FF2B5EF4-FFF2-40B4-BE49-F238E27FC236}">
-                <a16:creationId xmlns:a16="http://schemas.microsoft.com/office/drawing/2014/main" id="{794DFED7-164D-4E04-80BC-07F4CB43F62B}"/>
+                <a16:creationId xmlns:a16="http://schemas.microsoft.com/office/drawing/2014/main" id="{0D6CB283-06E4-478D-995C-9CD1EA7443EB}"/>
               </a:ext>
             </a:extLst>
           </p:cNvPr>
@@ -17078,7 +17078,7 @@
           <p:cNvPr id="51" name="Google Shape;51;p14">
             <a:extLst xmlns:a="http://schemas.openxmlformats.org/drawingml/2006/main">
               <a:ext uri="{FF2B5EF4-FFF2-40B4-BE49-F238E27FC236}">
-                <a16:creationId xmlns:a16="http://schemas.microsoft.com/office/drawing/2014/main" id="{1586EBAA-9F36-4093-BB68-4FF3ABC3C6EE}"/>
+                <a16:creationId xmlns:a16="http://schemas.microsoft.com/office/drawing/2014/main" id="{662E891F-0F78-4E1D-AB2B-D5BD7EE8D19A}"/>
               </a:ext>
             </a:extLst>
           </p:cNvPr>
@@ -17320,7 +17320,7 @@
           <p:cNvPr id="53" name="Google Shape;53;p15">
             <a:extLst xmlns:a="http://schemas.openxmlformats.org/drawingml/2006/main">
               <a:ext uri="{FF2B5EF4-FFF2-40B4-BE49-F238E27FC236}">
-                <a16:creationId xmlns:a16="http://schemas.microsoft.com/office/drawing/2014/main" id="{23B0C401-4112-439D-B456-518623FB3FA5}"/>
+                <a16:creationId xmlns:a16="http://schemas.microsoft.com/office/drawing/2014/main" id="{9A68B80A-6C02-4C94-9196-1E3755977F94}"/>
               </a:ext>
             </a:extLst>
           </p:cNvPr>
@@ -17479,7 +17479,7 @@
           <p:cNvPr id="54" name="Google Shape;54;p15">
             <a:extLst xmlns:a="http://schemas.openxmlformats.org/drawingml/2006/main">
               <a:ext uri="{FF2B5EF4-FFF2-40B4-BE49-F238E27FC236}">
-                <a16:creationId xmlns:a16="http://schemas.microsoft.com/office/drawing/2014/main" id="{508099AE-C8B3-4211-930E-4715244ADAE8}"/>
+                <a16:creationId xmlns:a16="http://schemas.microsoft.com/office/drawing/2014/main" id="{A18D33F9-2B25-461B-9B1A-AD36FABD2B77}"/>
               </a:ext>
             </a:extLst>
           </p:cNvPr>
@@ -17710,7 +17710,7 @@
           <p:cNvPr id="55" name="Google Shape;55;p15">
             <a:extLst xmlns:a="http://schemas.openxmlformats.org/drawingml/2006/main">
               <a:ext uri="{FF2B5EF4-FFF2-40B4-BE49-F238E27FC236}">
-                <a16:creationId xmlns:a16="http://schemas.microsoft.com/office/drawing/2014/main" id="{4B816CEB-FC31-41FB-94CA-046E06F41DF4}"/>
+                <a16:creationId xmlns:a16="http://schemas.microsoft.com/office/drawing/2014/main" id="{CBF48B26-8F77-486C-9BFB-449EB6430C31}"/>
               </a:ext>
             </a:extLst>
           </p:cNvPr>
@@ -17928,7 +17928,7 @@
           <p:cNvPr id="56" name="Google Shape;56;p15">
             <a:extLst xmlns:a="http://schemas.openxmlformats.org/drawingml/2006/main">
               <a:ext uri="{FF2B5EF4-FFF2-40B4-BE49-F238E27FC236}">
-                <a16:creationId xmlns:a16="http://schemas.microsoft.com/office/drawing/2014/main" id="{E927EF3C-4548-4EED-9AA6-AED8569244E1}"/>
+                <a16:creationId xmlns:a16="http://schemas.microsoft.com/office/drawing/2014/main" id="{CDBF4122-1880-4110-BAFE-677C368EF1B0}"/>
               </a:ext>
             </a:extLst>
           </p:cNvPr>
@@ -18146,7 +18146,7 @@
           <p:cNvPr id="57" name="Google Shape;57;p15">
             <a:extLst xmlns:a="http://schemas.openxmlformats.org/drawingml/2006/main">
               <a:ext uri="{FF2B5EF4-FFF2-40B4-BE49-F238E27FC236}">
-                <a16:creationId xmlns:a16="http://schemas.microsoft.com/office/drawing/2014/main" id="{34764F3C-C6F7-4005-8907-841C6DAE4E58}"/>
+                <a16:creationId xmlns:a16="http://schemas.microsoft.com/office/drawing/2014/main" id="{706B8ADA-C5F8-46C7-B132-36B90E1D87F2}"/>
               </a:ext>
             </a:extLst>
           </p:cNvPr>
@@ -18203,7 +18203,7 @@
           <p:nvPr/>
         </p:nvPicPr>
         <p:blipFill rotWithShape="1">
-          <a:blip xmlns:r="http://schemas.openxmlformats.org/officeDocument/2006/relationships" xmlns:a="http://schemas.openxmlformats.org/drawingml/2006/main" r:embed="R2f729f63502d4d59">
+          <a:blip xmlns:r="http://schemas.openxmlformats.org/officeDocument/2006/relationships" xmlns:a="http://schemas.openxmlformats.org/drawingml/2006/main" r:embed="Rd9152a3060e84ac4">
             <a:alphaModFix/>
           </a:blip>
           <a:srcRect xmlns:a="http://schemas.openxmlformats.org/drawingml/2006/main" l="0" t="0" r="0" b="0"/>
@@ -18251,7 +18251,7 @@
           <p:cNvPr id="60" name="Google Shape;60;p16">
             <a:extLst xmlns:a="http://schemas.openxmlformats.org/drawingml/2006/main">
               <a:ext uri="{FF2B5EF4-FFF2-40B4-BE49-F238E27FC236}">
-                <a16:creationId xmlns:a16="http://schemas.microsoft.com/office/drawing/2014/main" id="{8A209319-779C-4491-B5A4-93D6C3C83C95}"/>
+                <a16:creationId xmlns:a16="http://schemas.microsoft.com/office/drawing/2014/main" id="{525D5EB5-073C-4D67-8815-3DD75EF0FF31}"/>
               </a:ext>
             </a:extLst>
           </p:cNvPr>
@@ -18410,7 +18410,7 @@
           <p:cNvPr id="61" name="Google Shape;61;p16">
             <a:extLst xmlns:a="http://schemas.openxmlformats.org/drawingml/2006/main">
               <a:ext uri="{FF2B5EF4-FFF2-40B4-BE49-F238E27FC236}">
-                <a16:creationId xmlns:a16="http://schemas.microsoft.com/office/drawing/2014/main" id="{C799589A-C8B0-4FAC-842C-D6826CF35B11}"/>
+                <a16:creationId xmlns:a16="http://schemas.microsoft.com/office/drawing/2014/main" id="{5B709F27-1261-4239-A8A6-52734B790169}"/>
               </a:ext>
             </a:extLst>
           </p:cNvPr>
@@ -18641,7 +18641,7 @@
           <p:cNvPr id="62" name="Google Shape;62;p16">
             <a:extLst xmlns:a="http://schemas.openxmlformats.org/drawingml/2006/main">
               <a:ext uri="{FF2B5EF4-FFF2-40B4-BE49-F238E27FC236}">
-                <a16:creationId xmlns:a16="http://schemas.microsoft.com/office/drawing/2014/main" id="{4A207519-7626-4CD3-8945-E8A05D2105F5}"/>
+                <a16:creationId xmlns:a16="http://schemas.microsoft.com/office/drawing/2014/main" id="{6709A728-6FC1-4D01-B3CE-546C3B2D996D}"/>
               </a:ext>
             </a:extLst>
           </p:cNvPr>
@@ -18859,7 +18859,7 @@
           <p:cNvPr id="63" name="Google Shape;63;p16">
             <a:extLst xmlns:a="http://schemas.openxmlformats.org/drawingml/2006/main">
               <a:ext uri="{FF2B5EF4-FFF2-40B4-BE49-F238E27FC236}">
-                <a16:creationId xmlns:a16="http://schemas.microsoft.com/office/drawing/2014/main" id="{1E229162-F4EB-49AC-B2BE-EB8350C41B32}"/>
+                <a16:creationId xmlns:a16="http://schemas.microsoft.com/office/drawing/2014/main" id="{425DB64E-1FE5-43DD-A58A-46C0258BEF8A}"/>
               </a:ext>
             </a:extLst>
           </p:cNvPr>
@@ -19077,7 +19077,7 @@
           <p:cNvPr id="64" name="Google Shape;64;p16">
             <a:extLst xmlns:a="http://schemas.openxmlformats.org/drawingml/2006/main">
               <a:ext uri="{FF2B5EF4-FFF2-40B4-BE49-F238E27FC236}">
-                <a16:creationId xmlns:a16="http://schemas.microsoft.com/office/drawing/2014/main" id="{4C34BA6D-B822-48ED-B49B-3821EEE8409B}"/>
+                <a16:creationId xmlns:a16="http://schemas.microsoft.com/office/drawing/2014/main" id="{A71CF536-8E98-45D6-8995-99AB232E299D}"/>
               </a:ext>
             </a:extLst>
           </p:cNvPr>
@@ -19134,7 +19134,7 @@
           <p:nvPr/>
         </p:nvPicPr>
         <p:blipFill rotWithShape="1">
-          <a:blip xmlns:r="http://schemas.openxmlformats.org/officeDocument/2006/relationships" xmlns:a="http://schemas.openxmlformats.org/drawingml/2006/main" r:embed="Re0efd39927444818">
+          <a:blip xmlns:r="http://schemas.openxmlformats.org/officeDocument/2006/relationships" xmlns:a="http://schemas.openxmlformats.org/drawingml/2006/main" r:embed="R05c7d50307e34b8a">
             <a:alphaModFix/>
           </a:blip>
           <a:srcRect xmlns:a="http://schemas.openxmlformats.org/drawingml/2006/main" l="0" t="0" r="0" b="0"/>
@@ -19175,7 +19175,7 @@
           <p:cNvPr id="67" name="Google Shape;67;p17">
             <a:extLst xmlns:a="http://schemas.openxmlformats.org/drawingml/2006/main">
               <a:ext uri="{FF2B5EF4-FFF2-40B4-BE49-F238E27FC236}">
-                <a16:creationId xmlns:a16="http://schemas.microsoft.com/office/drawing/2014/main" id="{6889D450-A3D2-42E7-8CDC-AA6FF91BEE58}"/>
+                <a16:creationId xmlns:a16="http://schemas.microsoft.com/office/drawing/2014/main" id="{7EEE96A4-F2CC-4761-8FA7-1CDDD78FE3A9}"/>
               </a:ext>
             </a:extLst>
           </p:cNvPr>
@@ -19334,7 +19334,7 @@
           <p:cNvPr id="68" name="Google Shape;68;p17">
             <a:extLst xmlns:a="http://schemas.openxmlformats.org/drawingml/2006/main">
               <a:ext uri="{FF2B5EF4-FFF2-40B4-BE49-F238E27FC236}">
-                <a16:creationId xmlns:a16="http://schemas.microsoft.com/office/drawing/2014/main" id="{935045EC-14D1-42E8-AFE8-657A9C057DCF}"/>
+                <a16:creationId xmlns:a16="http://schemas.microsoft.com/office/drawing/2014/main" id="{133031B4-849A-4E61-9E25-71A5042E5009}"/>
               </a:ext>
             </a:extLst>
           </p:cNvPr>
@@ -19526,7 +19526,7 @@
           <p:cNvPr id="6" name="Google Shape;6;p8">
             <a:extLst xmlns:a="http://schemas.openxmlformats.org/drawingml/2006/main">
               <a:ext uri="{FF2B5EF4-FFF2-40B4-BE49-F238E27FC236}">
-                <a16:creationId xmlns:a16="http://schemas.microsoft.com/office/drawing/2014/main" id="{F1FEF2BB-8FB7-4FC4-9B5B-470709761B30}"/>
+                <a16:creationId xmlns:a16="http://schemas.microsoft.com/office/drawing/2014/main" id="{85D30A25-CC67-4317-ABAD-280DE1651BB1}"/>
               </a:ext>
             </a:extLst>
           </p:cNvPr>
@@ -19757,7 +19757,7 @@
           <p:cNvPr id="7" name="Google Shape;7;p8">
             <a:extLst xmlns:a="http://schemas.openxmlformats.org/drawingml/2006/main">
               <a:ext uri="{FF2B5EF4-FFF2-40B4-BE49-F238E27FC236}">
-                <a16:creationId xmlns:a16="http://schemas.microsoft.com/office/drawing/2014/main" id="{6179BE7A-9FF5-4ABC-9160-7E2D18A2AF1A}"/>
+                <a16:creationId xmlns:a16="http://schemas.microsoft.com/office/drawing/2014/main" id="{6AFA95CB-38EA-4ACC-9EAE-BFF660F96425}"/>
               </a:ext>
             </a:extLst>
           </p:cNvPr>
@@ -19810,7 +19810,7 @@
           <p:cNvPr id="8" name="Google Shape;8;p8">
             <a:extLst xmlns:a="http://schemas.openxmlformats.org/drawingml/2006/main">
               <a:ext uri="{FF2B5EF4-FFF2-40B4-BE49-F238E27FC236}">
-                <a16:creationId xmlns:a16="http://schemas.microsoft.com/office/drawing/2014/main" id="{50714760-1C7F-4D2A-B9B6-198B1CD6D1B7}"/>
+                <a16:creationId xmlns:a16="http://schemas.microsoft.com/office/drawing/2014/main" id="{1C4378C7-DC23-49C5-AD3F-C0733AC2F0B8}"/>
               </a:ext>
             </a:extLst>
           </p:cNvPr>
@@ -20032,7 +20032,7 @@
           <p:nvPr/>
         </p:nvPicPr>
         <p:blipFill rotWithShape="1">
-          <a:blip xmlns:r="http://schemas.openxmlformats.org/officeDocument/2006/relationships" xmlns:a="http://schemas.openxmlformats.org/drawingml/2006/main" r:embed="Rcf2c0fbe095f4531">
+          <a:blip xmlns:r="http://schemas.openxmlformats.org/officeDocument/2006/relationships" xmlns:a="http://schemas.openxmlformats.org/drawingml/2006/main" r:embed="R5c0568be64ef4ba9">
             <a:alphaModFix/>
           </a:blip>
           <a:srcRect xmlns:a="http://schemas.openxmlformats.org/drawingml/2006/main" l="0" t="0" r="0" b="0"/>
@@ -20055,28 +20055,28 @@
   </p:cSld>
   <p:clrMap bg1="lt1" tx1="dk1" bg2="dk2" tx2="lt2" accent1="accent1" accent2="accent2" accent3="accent3" accent4="accent4" accent5="accent5" accent6="accent6" hlink="hlink" folHlink="folHlink"/>
   <p:sldLayoutIdLst>
-    <p:sldLayoutId xmlns:r="http://schemas.openxmlformats.org/officeDocument/2006/relationships" id="2147483649" r:id="R89f5e585736548e8"/>
-    <p:sldLayoutId xmlns:r="http://schemas.openxmlformats.org/officeDocument/2006/relationships" id="2147483650" r:id="R606cefdd1fbb4b29"/>
-    <p:sldLayoutId xmlns:r="http://schemas.openxmlformats.org/officeDocument/2006/relationships" id="2147483651" r:id="Rdaf34b608b624177"/>
-    <p:sldLayoutId xmlns:r="http://schemas.openxmlformats.org/officeDocument/2006/relationships" id="2147483652" r:id="R4a4d52b9006b4434"/>
-    <p:sldLayoutId xmlns:r="http://schemas.openxmlformats.org/officeDocument/2006/relationships" id="2147483653" r:id="R19d8384f497545b2"/>
-    <p:sldLayoutId xmlns:r="http://schemas.openxmlformats.org/officeDocument/2006/relationships" id="2147483654" r:id="Rf1d53d35fbdd4f3f"/>
-    <p:sldLayoutId xmlns:r="http://schemas.openxmlformats.org/officeDocument/2006/relationships" id="2147483655" r:id="Rc9157078c2704354"/>
-    <p:sldLayoutId xmlns:r="http://schemas.openxmlformats.org/officeDocument/2006/relationships" id="2147483656" r:id="Rcd57eadc695b4139"/>
-    <p:sldLayoutId xmlns:r="http://schemas.openxmlformats.org/officeDocument/2006/relationships" id="2147483657" r:id="Rc3f72f14b30746b1"/>
-    <p:sldLayoutId xmlns:r="http://schemas.openxmlformats.org/officeDocument/2006/relationships" id="2147483658" r:id="R1b40ac6f4f284456"/>
-    <p:sldLayoutId xmlns:r="http://schemas.openxmlformats.org/officeDocument/2006/relationships" id="2147483659" r:id="Rc8eb5182274046d8"/>
-    <p:sldLayoutId xmlns:r="http://schemas.openxmlformats.org/officeDocument/2006/relationships" id="2147483660" r:id="R0b860f76228948a3"/>
-    <p:sldLayoutId xmlns:r="http://schemas.openxmlformats.org/officeDocument/2006/relationships" id="2147483661" r:id="R5e3555d5e7f0497f"/>
-    <p:sldLayoutId xmlns:r="http://schemas.openxmlformats.org/officeDocument/2006/relationships" id="2147483662" r:id="R696a6a5cd5f64be1"/>
-    <p:sldLayoutId xmlns:r="http://schemas.openxmlformats.org/officeDocument/2006/relationships" id="2147483663" r:id="Re8628f2df1814af4"/>
-    <p:sldLayoutId xmlns:r="http://schemas.openxmlformats.org/officeDocument/2006/relationships" id="2147483664" r:id="R3aa315b63c4f4bb3"/>
-    <p:sldLayoutId xmlns:r="http://schemas.openxmlformats.org/officeDocument/2006/relationships" id="2147483665" r:id="Rdc23cd386bf244a3"/>
-    <p:sldLayoutId xmlns:r="http://schemas.openxmlformats.org/officeDocument/2006/relationships" id="2147483666" r:id="Rb9bc0a0d4eee43e4"/>
-    <p:sldLayoutId xmlns:r="http://schemas.openxmlformats.org/officeDocument/2006/relationships" id="2147483667" r:id="Rd8676c4928a94b81"/>
-    <p:sldLayoutId xmlns:r="http://schemas.openxmlformats.org/officeDocument/2006/relationships" id="2147483668" r:id="R4bedcd380c7a4bf3"/>
-    <p:sldLayoutId xmlns:r="http://schemas.openxmlformats.org/officeDocument/2006/relationships" id="2147483669" r:id="R0dbb2888612d4f6a"/>
-    <p:sldLayoutId xmlns:r="http://schemas.openxmlformats.org/officeDocument/2006/relationships" id="2147483670" r:id="Rd42971eb5dc84fea"/>
+    <p:sldLayoutId xmlns:r="http://schemas.openxmlformats.org/officeDocument/2006/relationships" id="2147483649" r:id="R7da027bd1f8b406d"/>
+    <p:sldLayoutId xmlns:r="http://schemas.openxmlformats.org/officeDocument/2006/relationships" id="2147483650" r:id="Rd997d324fe2b46c7"/>
+    <p:sldLayoutId xmlns:r="http://schemas.openxmlformats.org/officeDocument/2006/relationships" id="2147483651" r:id="Ra9cbf199b51843bd"/>
+    <p:sldLayoutId xmlns:r="http://schemas.openxmlformats.org/officeDocument/2006/relationships" id="2147483652" r:id="R441a71c0e1884092"/>
+    <p:sldLayoutId xmlns:r="http://schemas.openxmlformats.org/officeDocument/2006/relationships" id="2147483653" r:id="R884c12a18e1249cd"/>
+    <p:sldLayoutId xmlns:r="http://schemas.openxmlformats.org/officeDocument/2006/relationships" id="2147483654" r:id="R18793e220b6846dc"/>
+    <p:sldLayoutId xmlns:r="http://schemas.openxmlformats.org/officeDocument/2006/relationships" id="2147483655" r:id="R6a655d78c6b4473d"/>
+    <p:sldLayoutId xmlns:r="http://schemas.openxmlformats.org/officeDocument/2006/relationships" id="2147483656" r:id="R082ac8aef9334be1"/>
+    <p:sldLayoutId xmlns:r="http://schemas.openxmlformats.org/officeDocument/2006/relationships" id="2147483657" r:id="Rc6a12ad3adcd4115"/>
+    <p:sldLayoutId xmlns:r="http://schemas.openxmlformats.org/officeDocument/2006/relationships" id="2147483658" r:id="R1cc37ff1e4804834"/>
+    <p:sldLayoutId xmlns:r="http://schemas.openxmlformats.org/officeDocument/2006/relationships" id="2147483659" r:id="Rbc66ced73e1d4d18"/>
+    <p:sldLayoutId xmlns:r="http://schemas.openxmlformats.org/officeDocument/2006/relationships" id="2147483660" r:id="Re2434ccfad1f4337"/>
+    <p:sldLayoutId xmlns:r="http://schemas.openxmlformats.org/officeDocument/2006/relationships" id="2147483661" r:id="R7c68a751a96d4fc4"/>
+    <p:sldLayoutId xmlns:r="http://schemas.openxmlformats.org/officeDocument/2006/relationships" id="2147483662" r:id="R8bbbff316f564371"/>
+    <p:sldLayoutId xmlns:r="http://schemas.openxmlformats.org/officeDocument/2006/relationships" id="2147483663" r:id="Rd52f6596f47b4262"/>
+    <p:sldLayoutId xmlns:r="http://schemas.openxmlformats.org/officeDocument/2006/relationships" id="2147483664" r:id="R80a97aa161354ba8"/>
+    <p:sldLayoutId xmlns:r="http://schemas.openxmlformats.org/officeDocument/2006/relationships" id="2147483665" r:id="Rf260568b8e9649f3"/>
+    <p:sldLayoutId xmlns:r="http://schemas.openxmlformats.org/officeDocument/2006/relationships" id="2147483666" r:id="Rf20708f1400d4279"/>
+    <p:sldLayoutId xmlns:r="http://schemas.openxmlformats.org/officeDocument/2006/relationships" id="2147483667" r:id="R61e9a45bf74f4854"/>
+    <p:sldLayoutId xmlns:r="http://schemas.openxmlformats.org/officeDocument/2006/relationships" id="2147483668" r:id="Ra284b89acd7b4a84"/>
+    <p:sldLayoutId xmlns:r="http://schemas.openxmlformats.org/officeDocument/2006/relationships" id="2147483669" r:id="Rd1826b7dca2a4593"/>
+    <p:sldLayoutId xmlns:r="http://schemas.openxmlformats.org/officeDocument/2006/relationships" id="2147483670" r:id="R48ca543717424cb5"/>
   </p:sldLayoutIdLst>
   <p:hf hdr="0" ftr="0" dt="0"/>
   <p:txStyles>
@@ -20915,7 +20915,7 @@
           <p:cNvPr id="168" name="Google Shape;168;p1">
             <a:extLst xmlns:a="http://schemas.openxmlformats.org/drawingml/2006/main">
               <a:ext uri="{FF2B5EF4-FFF2-40B4-BE49-F238E27FC236}">
-                <a16:creationId xmlns:a16="http://schemas.microsoft.com/office/drawing/2014/main" id="{E3C86D70-835F-4F2C-B8C6-588463F810F7}"/>
+                <a16:creationId xmlns:a16="http://schemas.microsoft.com/office/drawing/2014/main" id="{A285F88A-7B50-46EC-9793-CE559E3091C1}"/>
               </a:ext>
             </a:extLst>
           </p:cNvPr>
@@ -20966,6 +20966,23 @@
                   <a:srgbClr val="F0F6FC"/>
                 </a:highlight>
               </a:rPr>
+              <a:t>A multimodal AI accessibility platform that combines computer vision, conversational AI, document intelligence, and intelligent automation to simplify everyday life for people with disabilities.</a:t>
+            </a:r>
+          </a:p>
+          <a:p xmlns:a="http://schemas.openxmlformats.org/drawingml/2006/main">
+            <a:pPr marL="0" indent="0" algn="l">
+              <a:lnSpc>
+                <a:spcPct val="115000"/>
+              </a:lnSpc>
+              <a:spcBef>
+                <a:spcPts val="1200"/>
+              </a:spcBef>
+              <a:spcAft>
+                <a:spcPts val="0"/>
+              </a:spcAft>
+              <a:buNone/>
+            </a:pPr>
+            <a:r>
               <a:t/>
             </a:r>
           </a:p>
@@ -20976,7 +20993,7 @@
           <p:cNvPr id="169" name="Google Shape;169;p1">
             <a:extLst xmlns:a="http://schemas.openxmlformats.org/drawingml/2006/main">
               <a:ext uri="{FF2B5EF4-FFF2-40B4-BE49-F238E27FC236}">
-                <a16:creationId xmlns:a16="http://schemas.microsoft.com/office/drawing/2014/main" id="{377C3F88-6612-443E-9A7C-F8E76B6FACD9}"/>
+                <a16:creationId xmlns:a16="http://schemas.microsoft.com/office/drawing/2014/main" id="{BCEFD977-CF5D-43E9-A607-1A983B9267EB}"/>
               </a:ext>
             </a:extLst>
           </p:cNvPr>
@@ -21017,33 +21034,42 @@
                 <a:spcPts val="0"/>
               </a:spcAft>
               <a:buNone/>
-              <a:defRPr sz="3750" b="1">
-                <a:solidFill>
-                  <a:srgbClr val="FFFFFF"/>
-                </a:solidFill>
-              </a:defRPr>
             </a:pPr>
             <a:r>
-              <a:rPr sz="3750" b="1" u="sng">
-                <a:solidFill>
-                  <a:srgbClr val="FFFFFF"/>
-                </a:solidFill>
-              </a:rPr>
-              <a:t>CaseProof AI</a:t>
+              <a:rPr sz="5300" u="sng"/>
+              <a:t>AURA- Adaptive Universal</a:t>
+            </a:r>
+          </a:p>
+          <a:p xmlns:a="http://schemas.openxmlformats.org/drawingml/2006/main">
+            <a:pPr marL="0" indent="0" algn="l">
+              <a:lnSpc>
+                <a:spcPct val="115000"/>
+              </a:lnSpc>
+              <a:spcBef>
+                <a:spcPts val="0"/>
+              </a:spcBef>
+              <a:spcAft>
+                <a:spcPts val="0"/>
+              </a:spcAft>
+              <a:buNone/>
+            </a:pPr>
+            <a:r>
+              <a:rPr sz="5300" u="sng"/>
+              <a:t>Reality ASSISTANT</a:t>
             </a:r>
           </a:p>
         </p:txBody>
       </p:sp>
       <p:pic>
         <p:nvPicPr>
-          <p:cNvPr id="175" name="Google Shape;170;p1"/>
+          <p:cNvPr id="185" name="Google Shape;170;p1"/>
           <p:cNvPicPr>
             <a:picLocks xmlns:a="http://schemas.openxmlformats.org/drawingml/2006/main" noChangeAspect="1"/>
           </p:cNvPicPr>
           <p:nvPr/>
         </p:nvPicPr>
         <p:blipFill>
-          <a:blip xmlns:r="http://schemas.openxmlformats.org/officeDocument/2006/relationships" xmlns:a="http://schemas.openxmlformats.org/drawingml/2006/main" r:embed="Raa48e00edfcd4d56">
+          <a:blip xmlns:r="http://schemas.openxmlformats.org/officeDocument/2006/relationships" xmlns:a="http://schemas.openxmlformats.org/drawingml/2006/main" r:embed="R10eb87ca73974e60">
             <a:alphaModFix/>
           </a:blip>
           <a:stretch xmlns:a="http://schemas.openxmlformats.org/drawingml/2006/main">
@@ -21065,10 +21091,10 @@
       </p:pic>
       <p:sp>
         <p:nvSpPr>
-          <p:cNvPr id="171" name="subtitle-cover">
+          <p:cNvPr id="171" name="clean-title-background">
             <a:extLst xmlns:a="http://schemas.openxmlformats.org/drawingml/2006/main">
               <a:ext uri="{FF2B5EF4-FFF2-40B4-BE49-F238E27FC236}">
-                <a16:creationId xmlns:a16="http://schemas.microsoft.com/office/drawing/2014/main" id="{EDEFCD6B-6866-4E12-BAB2-78A91123C55C}"/>
+                <a16:creationId xmlns:a16="http://schemas.microsoft.com/office/drawing/2014/main" id="{CDAAFDE4-0E0C-424F-AD88-B6B01ABF25BD}"/>
               </a:ext>
             </a:extLst>
           </p:cNvPr>
@@ -21079,8 +21105,8 @@
         </p:nvSpPr>
         <p:spPr>
           <a:xfrm xmlns:a="http://schemas.openxmlformats.org/drawingml/2006/main">
-            <a:off x="514350" y="3733800"/>
-            <a:ext cx="9429750" cy="838200"/>
+            <a:off x="0" y="0"/>
+            <a:ext cx="12192000" cy="6858000"/>
           </a:xfrm>
           <a:prstGeom xmlns:a="http://schemas.openxmlformats.org/drawingml/2006/main" prst="rect">
             <a:avLst/>
@@ -21098,10 +21124,10 @@
       </p:sp>
       <p:sp>
         <p:nvSpPr>
-          <p:cNvPr id="172" name="clean-subtitle">
+          <p:cNvPr id="172" name="title-frame-top">
             <a:extLst xmlns:a="http://schemas.openxmlformats.org/drawingml/2006/main">
               <a:ext uri="{FF2B5EF4-FFF2-40B4-BE49-F238E27FC236}">
-                <a16:creationId xmlns:a16="http://schemas.microsoft.com/office/drawing/2014/main" id="{28E063D9-5578-4376-ABB5-03A18882FB0E}"/>
+                <a16:creationId xmlns:a16="http://schemas.microsoft.com/office/drawing/2014/main" id="{CA41AA9B-289E-447A-BFDE-94D1427D4C0A}"/>
               </a:ext>
             </a:extLst>
           </p:cNvPr>
@@ -21112,8 +21138,190 @@
         </p:nvSpPr>
         <p:spPr>
           <a:xfrm xmlns:a="http://schemas.openxmlformats.org/drawingml/2006/main">
-            <a:off x="628650" y="3829050"/>
-            <a:ext cx="9144000" cy="685800"/>
+            <a:off x="266700" y="209550"/>
+            <a:ext cx="11658600" cy="19050"/>
+          </a:xfrm>
+          <a:prstGeom xmlns:a="http://schemas.openxmlformats.org/drawingml/2006/main" prst="rect">
+            <a:avLst/>
+          </a:prstGeom>
+          <a:solidFill xmlns:a="http://schemas.openxmlformats.org/drawingml/2006/main">
+            <a:srgbClr val="FFFFFF"/>
+          </a:solidFill>
+          <a:ln xmlns:a="http://schemas.openxmlformats.org/drawingml/2006/main" w="0">
+            <a:solidFill>
+              <a:srgbClr val="FFFFFF"/>
+            </a:solidFill>
+            <a:prstDash val="solid"/>
+          </a:ln>
+        </p:spPr>
+      </p:sp>
+      <p:sp>
+        <p:nvSpPr>
+          <p:cNvPr id="173" name="title-frame-left">
+            <a:extLst xmlns:a="http://schemas.openxmlformats.org/drawingml/2006/main">
+              <a:ext uri="{FF2B5EF4-FFF2-40B4-BE49-F238E27FC236}">
+                <a16:creationId xmlns:a16="http://schemas.microsoft.com/office/drawing/2014/main" id="{2400B869-1140-4450-93FE-2FE852114C60}"/>
+              </a:ext>
+            </a:extLst>
+          </p:cNvPr>
+          <p:cNvSpPr>
+            <a:spLocks xmlns:a="http://schemas.openxmlformats.org/drawingml/2006/main" noGrp="1"/>
+          </p:cNvSpPr>
+          <p:nvPr/>
+        </p:nvSpPr>
+        <p:spPr>
+          <a:xfrm xmlns:a="http://schemas.openxmlformats.org/drawingml/2006/main">
+            <a:off x="266700" y="209550"/>
+            <a:ext cx="19050" cy="6438900"/>
+          </a:xfrm>
+          <a:prstGeom xmlns:a="http://schemas.openxmlformats.org/drawingml/2006/main" prst="rect">
+            <a:avLst/>
+          </a:prstGeom>
+          <a:solidFill xmlns:a="http://schemas.openxmlformats.org/drawingml/2006/main">
+            <a:srgbClr val="FFFFFF"/>
+          </a:solidFill>
+          <a:ln xmlns:a="http://schemas.openxmlformats.org/drawingml/2006/main" w="0">
+            <a:solidFill>
+              <a:srgbClr val="FFFFFF"/>
+            </a:solidFill>
+            <a:prstDash val="solid"/>
+          </a:ln>
+        </p:spPr>
+      </p:sp>
+      <p:sp>
+        <p:nvSpPr>
+          <p:cNvPr id="174" name="title-frame-right">
+            <a:extLst xmlns:a="http://schemas.openxmlformats.org/drawingml/2006/main">
+              <a:ext uri="{FF2B5EF4-FFF2-40B4-BE49-F238E27FC236}">
+                <a16:creationId xmlns:a16="http://schemas.microsoft.com/office/drawing/2014/main" id="{D252FE25-D5C5-49BD-BFEE-60EE9900EC02}"/>
+              </a:ext>
+            </a:extLst>
+          </p:cNvPr>
+          <p:cNvSpPr>
+            <a:spLocks xmlns:a="http://schemas.openxmlformats.org/drawingml/2006/main" noGrp="1"/>
+          </p:cNvSpPr>
+          <p:nvPr/>
+        </p:nvSpPr>
+        <p:spPr>
+          <a:xfrm xmlns:a="http://schemas.openxmlformats.org/drawingml/2006/main">
+            <a:off x="11906250" y="209550"/>
+            <a:ext cx="19050" cy="6438900"/>
+          </a:xfrm>
+          <a:prstGeom xmlns:a="http://schemas.openxmlformats.org/drawingml/2006/main" prst="rect">
+            <a:avLst/>
+          </a:prstGeom>
+          <a:solidFill xmlns:a="http://schemas.openxmlformats.org/drawingml/2006/main">
+            <a:srgbClr val="FFFFFF"/>
+          </a:solidFill>
+          <a:ln xmlns:a="http://schemas.openxmlformats.org/drawingml/2006/main" w="0">
+            <a:solidFill>
+              <a:srgbClr val="FFFFFF"/>
+            </a:solidFill>
+            <a:prstDash val="solid"/>
+          </a:ln>
+        </p:spPr>
+      </p:sp>
+      <p:sp>
+        <p:nvSpPr>
+          <p:cNvPr id="175" name="title-frame-bottom">
+            <a:extLst xmlns:a="http://schemas.openxmlformats.org/drawingml/2006/main">
+              <a:ext uri="{FF2B5EF4-FFF2-40B4-BE49-F238E27FC236}">
+                <a16:creationId xmlns:a16="http://schemas.microsoft.com/office/drawing/2014/main" id="{76D81F2B-2320-43F6-AEE9-6F510DAF577C}"/>
+              </a:ext>
+            </a:extLst>
+          </p:cNvPr>
+          <p:cNvSpPr>
+            <a:spLocks xmlns:a="http://schemas.openxmlformats.org/drawingml/2006/main" noGrp="1"/>
+          </p:cNvSpPr>
+          <p:nvPr/>
+        </p:nvSpPr>
+        <p:spPr>
+          <a:xfrm xmlns:a="http://schemas.openxmlformats.org/drawingml/2006/main">
+            <a:off x="266700" y="6629400"/>
+            <a:ext cx="11658600" cy="19050"/>
+          </a:xfrm>
+          <a:prstGeom xmlns:a="http://schemas.openxmlformats.org/drawingml/2006/main" prst="rect">
+            <a:avLst/>
+          </a:prstGeom>
+          <a:solidFill xmlns:a="http://schemas.openxmlformats.org/drawingml/2006/main">
+            <a:srgbClr val="FFFFFF"/>
+          </a:solidFill>
+          <a:ln xmlns:a="http://schemas.openxmlformats.org/drawingml/2006/main" w="0">
+            <a:solidFill>
+              <a:srgbClr val="FFFFFF"/>
+            </a:solidFill>
+            <a:prstDash val="solid"/>
+          </a:ln>
+        </p:spPr>
+      </p:sp>
+      <p:sp>
+        <p:nvSpPr>
+          <p:cNvPr id="176" name="wordmark">
+            <a:extLst xmlns:a="http://schemas.openxmlformats.org/drawingml/2006/main">
+              <a:ext uri="{FF2B5EF4-FFF2-40B4-BE49-F238E27FC236}">
+                <a16:creationId xmlns:a16="http://schemas.microsoft.com/office/drawing/2014/main" id="{D9F95B75-026F-45DF-BE49-2FF6BFAA0568}"/>
+              </a:ext>
+            </a:extLst>
+          </p:cNvPr>
+          <p:cNvSpPr>
+            <a:spLocks xmlns:a="http://schemas.openxmlformats.org/drawingml/2006/main" noGrp="1"/>
+          </p:cNvSpPr>
+          <p:nvPr/>
+        </p:nvSpPr>
+        <p:spPr>
+          <a:xfrm xmlns:a="http://schemas.openxmlformats.org/drawingml/2006/main">
+            <a:off x="10287000" y="514350"/>
+            <a:ext cx="1285875" cy="400050"/>
+          </a:xfrm>
+          <a:prstGeom xmlns:a="http://schemas.openxmlformats.org/drawingml/2006/main" prst="rect">
+            <a:avLst/>
+          </a:prstGeom>
+          <a:noFill xmlns:a="http://schemas.openxmlformats.org/drawingml/2006/main"/>
+          <a:ln xmlns:a="http://schemas.openxmlformats.org/drawingml/2006/main" w="0">
+            <a:noFill/>
+            <a:prstDash val="solid"/>
+          </a:ln>
+        </p:spPr>
+        <p:txBody>
+          <a:bodyPr xmlns:a="http://schemas.openxmlformats.org/drawingml/2006/main"/>
+          <a:lstStyle xmlns:a="http://schemas.openxmlformats.org/drawingml/2006/main"/>
+          <a:p xmlns:a="http://schemas.openxmlformats.org/drawingml/2006/main">
+            <a:pPr algn="r">
+              <a:defRPr sz="2250" b="1">
+                <a:solidFill>
+                  <a:srgbClr val="FFFFFF"/>
+                </a:solidFill>
+              </a:defRPr>
+            </a:pPr>
+            <a:r>
+              <a:rPr sz="2250" b="1">
+                <a:solidFill>
+                  <a:srgbClr val="FFFFFF"/>
+                </a:solidFill>
+              </a:rPr>
+              <a:t>UiPath</a:t>
+            </a:r>
+          </a:p>
+        </p:txBody>
+      </p:sp>
+      <p:sp>
+        <p:nvSpPr>
+          <p:cNvPr id="177" name="main-title">
+            <a:extLst xmlns:a="http://schemas.openxmlformats.org/drawingml/2006/main">
+              <a:ext uri="{FF2B5EF4-FFF2-40B4-BE49-F238E27FC236}">
+                <a16:creationId xmlns:a16="http://schemas.microsoft.com/office/drawing/2014/main" id="{6752F4B6-B8FD-4050-8CCE-35AC712A33A0}"/>
+              </a:ext>
+            </a:extLst>
+          </p:cNvPr>
+          <p:cNvSpPr>
+            <a:spLocks xmlns:a="http://schemas.openxmlformats.org/drawingml/2006/main" noGrp="1"/>
+          </p:cNvSpPr>
+          <p:nvPr/>
+        </p:nvSpPr>
+        <p:spPr>
+          <a:xfrm xmlns:a="http://schemas.openxmlformats.org/drawingml/2006/main">
+            <a:off x="685800" y="1657350"/>
+            <a:ext cx="7810500" cy="762000"/>
           </a:xfrm>
           <a:prstGeom xmlns:a="http://schemas.openxmlformats.org/drawingml/2006/main" prst="rect">
             <a:avLst/>
@@ -21129,14 +21337,64 @@
           <a:lstStyle xmlns:a="http://schemas.openxmlformats.org/drawingml/2006/main"/>
           <a:p xmlns:a="http://schemas.openxmlformats.org/drawingml/2006/main">
             <a:pPr>
-              <a:defRPr sz="1800">
+              <a:defRPr sz="4050" b="1" u="sng">
                 <a:solidFill>
                   <a:srgbClr val="FFFFFF"/>
                 </a:solidFill>
               </a:defRPr>
             </a:pPr>
             <a:r>
-              <a:rPr sz="1800">
+              <a:rPr sz="4050" b="1" u="sng">
+                <a:solidFill>
+                  <a:srgbClr val="FFFFFF"/>
+                </a:solidFill>
+              </a:rPr>
+              <a:t>CaseProof AI</a:t>
+            </a:r>
+          </a:p>
+        </p:txBody>
+      </p:sp>
+      <p:sp>
+        <p:nvSpPr>
+          <p:cNvPr id="178" name="main-subtitle">
+            <a:extLst xmlns:a="http://schemas.openxmlformats.org/drawingml/2006/main">
+              <a:ext uri="{FF2B5EF4-FFF2-40B4-BE49-F238E27FC236}">
+                <a16:creationId xmlns:a16="http://schemas.microsoft.com/office/drawing/2014/main" id="{711768A6-7030-400C-B0D4-53428CCB91E6}"/>
+              </a:ext>
+            </a:extLst>
+          </p:cNvPr>
+          <p:cNvSpPr>
+            <a:spLocks xmlns:a="http://schemas.openxmlformats.org/drawingml/2006/main" noGrp="1"/>
+          </p:cNvSpPr>
+          <p:nvPr/>
+        </p:nvSpPr>
+        <p:spPr>
+          <a:xfrm xmlns:a="http://schemas.openxmlformats.org/drawingml/2006/main">
+            <a:off x="704850" y="3581400"/>
+            <a:ext cx="8858250" cy="914400"/>
+          </a:xfrm>
+          <a:prstGeom xmlns:a="http://schemas.openxmlformats.org/drawingml/2006/main" prst="rect">
+            <a:avLst/>
+          </a:prstGeom>
+          <a:noFill xmlns:a="http://schemas.openxmlformats.org/drawingml/2006/main"/>
+          <a:ln xmlns:a="http://schemas.openxmlformats.org/drawingml/2006/main" w="0">
+            <a:noFill/>
+            <a:prstDash val="solid"/>
+          </a:ln>
+        </p:spPr>
+        <p:txBody>
+          <a:bodyPr xmlns:a="http://schemas.openxmlformats.org/drawingml/2006/main"/>
+          <a:lstStyle xmlns:a="http://schemas.openxmlformats.org/drawingml/2006/main"/>
+          <a:p xmlns:a="http://schemas.openxmlformats.org/drawingml/2006/main">
+            <a:pPr>
+              <a:defRPr sz="1875">
+                <a:solidFill>
+                  <a:srgbClr val="FFFFFF"/>
+                </a:solidFill>
+              </a:defRPr>
+            </a:pPr>
+            <a:r>
+              <a:rPr sz="1875">
                 <a:solidFill>
                   <a:srgbClr val="FFFFFF"/>
                 </a:solidFill>
@@ -21146,10 +21404,142 @@
           </a:p>
         </p:txBody>
       </p:sp>
+      <p:sp>
+        <p:nvSpPr>
+          <p:cNvPr id="179" name="accent-pixel-a">
+            <a:extLst xmlns:a="http://schemas.openxmlformats.org/drawingml/2006/main">
+              <a:ext uri="{FF2B5EF4-FFF2-40B4-BE49-F238E27FC236}">
+                <a16:creationId xmlns:a16="http://schemas.microsoft.com/office/drawing/2014/main" id="{5D56E077-9866-4DAB-8EC9-612007C7057A}"/>
+              </a:ext>
+            </a:extLst>
+          </p:cNvPr>
+          <p:cNvSpPr>
+            <a:spLocks xmlns:a="http://schemas.openxmlformats.org/drawingml/2006/main" noGrp="1"/>
+          </p:cNvSpPr>
+          <p:nvPr/>
+        </p:nvSpPr>
+        <p:spPr>
+          <a:xfrm xmlns:a="http://schemas.openxmlformats.org/drawingml/2006/main">
+            <a:off x="10248900" y="5295900"/>
+            <a:ext cx="323850" cy="323850"/>
+          </a:xfrm>
+          <a:prstGeom xmlns:a="http://schemas.openxmlformats.org/drawingml/2006/main" prst="rect">
+            <a:avLst/>
+          </a:prstGeom>
+          <a:solidFill xmlns:a="http://schemas.openxmlformats.org/drawingml/2006/main">
+            <a:srgbClr val="064957"/>
+          </a:solidFill>
+          <a:ln xmlns:a="http://schemas.openxmlformats.org/drawingml/2006/main" w="0">
+            <a:solidFill>
+              <a:srgbClr val="064957"/>
+            </a:solidFill>
+            <a:prstDash val="solid"/>
+          </a:ln>
+        </p:spPr>
+      </p:sp>
+      <p:sp>
+        <p:nvSpPr>
+          <p:cNvPr id="180" name="accent-pixel-b">
+            <a:extLst xmlns:a="http://schemas.openxmlformats.org/drawingml/2006/main">
+              <a:ext uri="{FF2B5EF4-FFF2-40B4-BE49-F238E27FC236}">
+                <a16:creationId xmlns:a16="http://schemas.microsoft.com/office/drawing/2014/main" id="{DF833025-6AFC-4ECB-81CF-195B6B3B0CAA}"/>
+              </a:ext>
+            </a:extLst>
+          </p:cNvPr>
+          <p:cNvSpPr>
+            <a:spLocks xmlns:a="http://schemas.openxmlformats.org/drawingml/2006/main" noGrp="1"/>
+          </p:cNvSpPr>
+          <p:nvPr/>
+        </p:nvSpPr>
+        <p:spPr>
+          <a:xfrm xmlns:a="http://schemas.openxmlformats.org/drawingml/2006/main">
+            <a:off x="10572750" y="5619750"/>
+            <a:ext cx="323850" cy="323850"/>
+          </a:xfrm>
+          <a:prstGeom xmlns:a="http://schemas.openxmlformats.org/drawingml/2006/main" prst="rect">
+            <a:avLst/>
+          </a:prstGeom>
+          <a:solidFill xmlns:a="http://schemas.openxmlformats.org/drawingml/2006/main">
+            <a:srgbClr val="087F8F"/>
+          </a:solidFill>
+          <a:ln xmlns:a="http://schemas.openxmlformats.org/drawingml/2006/main" w="0">
+            <a:solidFill>
+              <a:srgbClr val="087F8F"/>
+            </a:solidFill>
+            <a:prstDash val="solid"/>
+          </a:ln>
+        </p:spPr>
+      </p:sp>
+      <p:sp>
+        <p:nvSpPr>
+          <p:cNvPr id="181" name="accent-pixel-c">
+            <a:extLst xmlns:a="http://schemas.openxmlformats.org/drawingml/2006/main">
+              <a:ext uri="{FF2B5EF4-FFF2-40B4-BE49-F238E27FC236}">
+                <a16:creationId xmlns:a16="http://schemas.microsoft.com/office/drawing/2014/main" id="{AE5592A6-F9B0-4481-B54A-38A75969C2AD}"/>
+              </a:ext>
+            </a:extLst>
+          </p:cNvPr>
+          <p:cNvSpPr>
+            <a:spLocks xmlns:a="http://schemas.openxmlformats.org/drawingml/2006/main" noGrp="1"/>
+          </p:cNvSpPr>
+          <p:nvPr/>
+        </p:nvSpPr>
+        <p:spPr>
+          <a:xfrm xmlns:a="http://schemas.openxmlformats.org/drawingml/2006/main">
+            <a:off x="10896600" y="5943600"/>
+            <a:ext cx="323850" cy="323850"/>
+          </a:xfrm>
+          <a:prstGeom xmlns:a="http://schemas.openxmlformats.org/drawingml/2006/main" prst="rect">
+            <a:avLst/>
+          </a:prstGeom>
+          <a:solidFill xmlns:a="http://schemas.openxmlformats.org/drawingml/2006/main">
+            <a:srgbClr val="064957"/>
+          </a:solidFill>
+          <a:ln xmlns:a="http://schemas.openxmlformats.org/drawingml/2006/main" w="0">
+            <a:solidFill>
+              <a:srgbClr val="064957"/>
+            </a:solidFill>
+            <a:prstDash val="solid"/>
+          </a:ln>
+        </p:spPr>
+      </p:sp>
+      <p:sp>
+        <p:nvSpPr>
+          <p:cNvPr id="182" name="accent-bar">
+            <a:extLst xmlns:a="http://schemas.openxmlformats.org/drawingml/2006/main">
+              <a:ext uri="{FF2B5EF4-FFF2-40B4-BE49-F238E27FC236}">
+                <a16:creationId xmlns:a16="http://schemas.microsoft.com/office/drawing/2014/main" id="{D5D96C3F-F726-40DD-A9AB-3C83E7F3DC7B}"/>
+              </a:ext>
+            </a:extLst>
+          </p:cNvPr>
+          <p:cNvSpPr>
+            <a:spLocks xmlns:a="http://schemas.openxmlformats.org/drawingml/2006/main" noGrp="1"/>
+          </p:cNvSpPr>
+          <p:nvPr/>
+        </p:nvSpPr>
+        <p:spPr>
+          <a:xfrm xmlns:a="http://schemas.openxmlformats.org/drawingml/2006/main">
+            <a:off x="9696450" y="6172200"/>
+            <a:ext cx="1200150" cy="190500"/>
+          </a:xfrm>
+          <a:prstGeom xmlns:a="http://schemas.openxmlformats.org/drawingml/2006/main" prst="rect">
+            <a:avLst/>
+          </a:prstGeom>
+          <a:solidFill xmlns:a="http://schemas.openxmlformats.org/drawingml/2006/main">
+            <a:srgbClr val="064957"/>
+          </a:solidFill>
+          <a:ln xmlns:a="http://schemas.openxmlformats.org/drawingml/2006/main" w="0">
+            <a:solidFill>
+              <a:srgbClr val="064957"/>
+            </a:solidFill>
+            <a:prstDash val="solid"/>
+          </a:ln>
+        </p:spPr>
+      </p:sp>
     </p:spTree>
     <p:extLst>
       <p:ext uri="{BB962C8B-B14F-4D97-AF65-F5344CB8AC3E}">
-        <p14:creationId xmlns:p14="http://schemas.microsoft.com/office/powerpoint/2010/main" val="14787873"/>
+        <p14:creationId xmlns:p14="http://schemas.microsoft.com/office/powerpoint/2010/main" val="745991542"/>
       </p:ext>
     </p:extLst>
   </p:cSld>
@@ -21173,7 +21563,7 @@
           <p:cNvPr id="175" name="Google Shape;175;p3">
             <a:extLst xmlns:a="http://schemas.openxmlformats.org/drawingml/2006/main">
               <a:ext uri="{FF2B5EF4-FFF2-40B4-BE49-F238E27FC236}">
-                <a16:creationId xmlns:a16="http://schemas.microsoft.com/office/drawing/2014/main" id="{40C78BDE-25E5-48A5-A51C-5D396B75AC50}"/>
+                <a16:creationId xmlns:a16="http://schemas.microsoft.com/office/drawing/2014/main" id="{E3CF531B-BDA9-40BB-9167-1BA062CC1373}"/>
               </a:ext>
             </a:extLst>
           </p:cNvPr>
@@ -21214,16 +21604,11 @@
                 <a:spcPts val="0"/>
               </a:spcAft>
               <a:buNone/>
-              <a:defRPr sz="2850" b="1">
-                <a:solidFill>
-                  <a:srgbClr val="111827"/>
-                </a:solidFill>
-              </a:defRPr>
             </a:pPr>
             <a:r>
-              <a:rPr sz="2850" b="1">
-                <a:solidFill>
-                  <a:srgbClr val="111827"/>
+              <a:rPr>
+                <a:solidFill>
+                  <a:srgbClr val="172024"/>
                 </a:solidFill>
               </a:rPr>
               <a:t>Problem statement and proposed solution</a:t>
@@ -21236,7 +21621,7 @@
           <p:cNvPr id="176" name="Google Shape;176;p3">
             <a:extLst xmlns:a="http://schemas.openxmlformats.org/drawingml/2006/main">
               <a:ext uri="{FF2B5EF4-FFF2-40B4-BE49-F238E27FC236}">
-                <a16:creationId xmlns:a16="http://schemas.microsoft.com/office/drawing/2014/main" id="{661DDBCC-3D33-4AF8-92D8-D46A801EB2C5}"/>
+                <a16:creationId xmlns:a16="http://schemas.microsoft.com/office/drawing/2014/main" id="{CE9F7217-A6BD-4AF1-92FB-8FEF41E05E29}"/>
               </a:ext>
             </a:extLst>
           </p:cNvPr>
@@ -21289,7 +21674,7 @@
           <p:cNvPr id="177" name="Google Shape;177;p3">
             <a:extLst xmlns:a="http://schemas.openxmlformats.org/drawingml/2006/main">
               <a:ext uri="{FF2B5EF4-FFF2-40B4-BE49-F238E27FC236}">
-                <a16:creationId xmlns:a16="http://schemas.microsoft.com/office/drawing/2014/main" id="{262AA786-39BE-4058-9C27-A3C94A99AB43}"/>
+                <a16:creationId xmlns:a16="http://schemas.microsoft.com/office/drawing/2014/main" id="{F8124802-0334-467C-91A6-0C49EE993469}"/>
               </a:ext>
             </a:extLst>
           </p:cNvPr>
@@ -21330,18 +21715,8 @@
                 <a:spcPts val="0"/>
               </a:spcAft>
               <a:buNone/>
-              <a:defRPr sz="1650" b="1">
-                <a:solidFill>
-                  <a:srgbClr val="111827"/>
-                </a:solidFill>
-              </a:defRPr>
             </a:pPr>
             <a:r>
-              <a:rPr sz="1650" b="1">
-                <a:solidFill>
-                  <a:srgbClr val="111827"/>
-                </a:solidFill>
-              </a:rPr>
               <a:t>Problem</a:t>
             </a:r>
           </a:p>
@@ -21352,7 +21727,7 @@
           <p:cNvPr id="178" name="Google Shape;178;p3">
             <a:extLst xmlns:a="http://schemas.openxmlformats.org/drawingml/2006/main">
               <a:ext uri="{FF2B5EF4-FFF2-40B4-BE49-F238E27FC236}">
-                <a16:creationId xmlns:a16="http://schemas.microsoft.com/office/drawing/2014/main" id="{15F2C314-6E23-43DC-8681-0E6B5C86ECE4}"/>
+                <a16:creationId xmlns:a16="http://schemas.microsoft.com/office/drawing/2014/main" id="{4170F5F0-3E08-4B40-8594-95E7E74AB21C}"/>
               </a:ext>
             </a:extLst>
           </p:cNvPr>
@@ -21393,19 +21768,34 @@
                 <a:spcPts val="0"/>
               </a:spcAft>
               <a:buNone/>
-              <a:defRPr sz="1275">
-                <a:solidFill>
-                  <a:srgbClr val="111827"/>
-                </a:solidFill>
-              </a:defRPr>
             </a:pPr>
             <a:r>
-              <a:rPr sz="1275">
-                <a:solidFill>
-                  <a:srgbClr val="111827"/>
-                </a:solidFill>
+              <a:t/>
+            </a:r>
+          </a:p>
+          <a:p xmlns:a="http://schemas.openxmlformats.org/drawingml/2006/main">
+            <a:pPr marL="0" indent="0" algn="l">
+              <a:lnSpc>
+                <a:spcPct val="100000"/>
+              </a:lnSpc>
+              <a:spcBef>
+                <a:spcPts val="500"/>
+              </a:spcBef>
+              <a:spcAft>
+                <a:spcPts val="0"/>
+              </a:spcAft>
+              <a:buNone/>
+            </a:pPr>
+            <a:r>
+              <a:rPr>
+                <a:solidFill>
+                  <a:srgbClr val="1D1D1F"/>
+                </a:solidFill>
+                <a:highlight>
+                  <a:srgbClr val="FFFFFF"/>
+                </a:highlight>
               </a:rPr>
-              <a:t>AI can prepare a refund exception case quickly, but a prepared case can still miss evidence, skip a milestone, bypass policy, or route a high-value refund too early.</a:t>
+              <a:t>People with disabilities often deal with unnecessary barriers when they’re using digital services, government portals, and regular everyday places. While a lot of accessibility tools solve one little thing at a time, very few actually give a unified experience, one that can “read” what the person is seeing around them, explain complicated stuff, and also automate tasks in the real world.</a:t>
             </a:r>
           </a:p>
         </p:txBody>
@@ -21415,7 +21805,7 @@
           <p:cNvPr id="179" name="Google Shape;179;p3">
             <a:extLst xmlns:a="http://schemas.openxmlformats.org/drawingml/2006/main">
               <a:ext uri="{FF2B5EF4-FFF2-40B4-BE49-F238E27FC236}">
-                <a16:creationId xmlns:a16="http://schemas.microsoft.com/office/drawing/2014/main" id="{B1DF1021-3272-4540-9C29-62A25B717A8F}"/>
+                <a16:creationId xmlns:a16="http://schemas.microsoft.com/office/drawing/2014/main" id="{4495010B-08DB-487A-94E0-203385F74B0F}"/>
               </a:ext>
             </a:extLst>
           </p:cNvPr>
@@ -21456,18 +21846,8 @@
                 <a:spcPts val="0"/>
               </a:spcAft>
               <a:buNone/>
-              <a:defRPr sz="1650" b="1">
-                <a:solidFill>
-                  <a:srgbClr val="111827"/>
-                </a:solidFill>
-              </a:defRPr>
             </a:pPr>
             <a:r>
-              <a:rPr sz="1650" b="1">
-                <a:solidFill>
-                  <a:srgbClr val="111827"/>
-                </a:solidFill>
-              </a:rPr>
               <a:t>Solution</a:t>
             </a:r>
           </a:p>
@@ -21478,7 +21858,7 @@
           <p:cNvPr id="180" name="Google Shape;180;p3">
             <a:extLst xmlns:a="http://schemas.openxmlformats.org/drawingml/2006/main">
               <a:ext uri="{FF2B5EF4-FFF2-40B4-BE49-F238E27FC236}">
-                <a16:creationId xmlns:a16="http://schemas.microsoft.com/office/drawing/2014/main" id="{78682F06-B6DB-499A-97BC-AFB8F2935F18}"/>
+                <a16:creationId xmlns:a16="http://schemas.microsoft.com/office/drawing/2014/main" id="{398C27AB-D330-4110-AB4A-17E192CD1C47}"/>
               </a:ext>
             </a:extLst>
           </p:cNvPr>
@@ -21519,19 +21899,85 @@
                 <a:spcPts val="0"/>
               </a:spcAft>
               <a:buNone/>
-              <a:defRPr sz="1275">
-                <a:solidFill>
-                  <a:srgbClr val="111827"/>
-                </a:solidFill>
-              </a:defRPr>
             </a:pPr>
             <a:r>
-              <a:rPr sz="1275">
-                <a:solidFill>
-                  <a:srgbClr val="111827"/>
-                </a:solidFill>
+              <a:t/>
+            </a:r>
+          </a:p>
+          <a:p xmlns:a="http://schemas.openxmlformats.org/drawingml/2006/main">
+            <a:pPr marL="0" indent="0" algn="l">
+              <a:lnSpc>
+                <a:spcPct val="150000"/>
+              </a:lnSpc>
+              <a:spcBef>
+                <a:spcPts val="1200"/>
+              </a:spcBef>
+              <a:spcAft>
+                <a:spcPts val="0"/>
+              </a:spcAft>
+              <a:buNone/>
+            </a:pPr>
+            <a:r>
+              <a:rPr>
+                <a:solidFill>
+                  <a:srgbClr val="1D1D1F"/>
+                </a:solidFill>
+                <a:highlight>
+                  <a:srgbClr val="FFFFFF"/>
+                </a:highlight>
               </a:rPr>
-              <a:t>CaseProof validates a synthetic Maestro case packet and returns HOLD, BLOCK, or ALLOW_HUMAN_REVIEW_ONLY. It never issues refunds or changes customer records.</a:t>
+              <a:t> AURA is an AI-powered accessibility companion that combines multimodal AI with UiPath intelligent automation to help people with disabilities navigate, understand, and automate everyday tasks . It is more than a typical AI assistant it’s like an intelligent accessibility companion that helps users move around, make sense of information, and finish daily activities with more confidence. and, honestly, more independence too.</a:t>
+            </a:r>
+          </a:p>
+          <a:p xmlns:a="http://schemas.openxmlformats.org/drawingml/2006/main">
+            <a:pPr marL="0" indent="0" algn="l">
+              <a:lnSpc>
+                <a:spcPct val="150000"/>
+              </a:lnSpc>
+              <a:spcBef>
+                <a:spcPts val="1200"/>
+              </a:spcBef>
+              <a:spcAft>
+                <a:spcPts val="0"/>
+              </a:spcAft>
+              <a:buNone/>
+            </a:pPr>
+            <a:r>
+              <a:t/>
+            </a:r>
+          </a:p>
+          <a:p xmlns:a="http://schemas.openxmlformats.org/drawingml/2006/main">
+            <a:pPr marL="0" indent="0" algn="l">
+              <a:lnSpc>
+                <a:spcPct val="150000"/>
+              </a:lnSpc>
+              <a:spcBef>
+                <a:spcPts val="1200"/>
+              </a:spcBef>
+              <a:spcAft>
+                <a:spcPts val="0"/>
+              </a:spcAft>
+              <a:buNone/>
+            </a:pPr>
+            <a:r>
+              <a:t/>
+            </a:r>
+          </a:p>
+          <a:p xmlns:a="http://schemas.openxmlformats.org/drawingml/2006/main">
+            <a:pPr marL="457200" indent="0" algn="l">
+              <a:lnSpc>
+                <a:spcPct val="150000"/>
+              </a:lnSpc>
+              <a:spcBef>
+                <a:spcPts val="1200"/>
+              </a:spcBef>
+              <a:spcAft>
+                <a:spcPts val="1200"/>
+              </a:spcAft>
+              <a:buNone/>
+            </a:pPr>
+            <a:r>
+              <a:t/>
             </a:r>
           </a:p>
         </p:txBody>
@@ -21541,7 +21987,7 @@
           <p:cNvPr id="181" name="Google Shape;181;p3">
             <a:extLst xmlns:a="http://schemas.openxmlformats.org/drawingml/2006/main">
               <a:ext uri="{FF2B5EF4-FFF2-40B4-BE49-F238E27FC236}">
-                <a16:creationId xmlns:a16="http://schemas.microsoft.com/office/drawing/2014/main" id="{BB235B91-ACFE-402F-8388-E2831CD7301A}"/>
+                <a16:creationId xmlns:a16="http://schemas.microsoft.com/office/drawing/2014/main" id="{1FD05A07-C9DA-4541-BB03-D7E029B4C1CB}"/>
               </a:ext>
             </a:extLst>
           </p:cNvPr>
@@ -21584,10 +22030,409 @@
           </a:p>
         </p:txBody>
       </p:sp>
+      <p:sp>
+        <p:nvSpPr>
+          <p:cNvPr id="182" name="clean-white-background">
+            <a:extLst xmlns:a="http://schemas.openxmlformats.org/drawingml/2006/main">
+              <a:ext uri="{FF2B5EF4-FFF2-40B4-BE49-F238E27FC236}">
+                <a16:creationId xmlns:a16="http://schemas.microsoft.com/office/drawing/2014/main" id="{F5A54A3A-85FA-4A04-9823-31748B146903}"/>
+              </a:ext>
+            </a:extLst>
+          </p:cNvPr>
+          <p:cNvSpPr>
+            <a:spLocks xmlns:a="http://schemas.openxmlformats.org/drawingml/2006/main" noGrp="1"/>
+          </p:cNvSpPr>
+          <p:nvPr/>
+        </p:nvSpPr>
+        <p:spPr>
+          <a:xfrm xmlns:a="http://schemas.openxmlformats.org/drawingml/2006/main">
+            <a:off x="0" y="0"/>
+            <a:ext cx="12192000" cy="6858000"/>
+          </a:xfrm>
+          <a:prstGeom xmlns:a="http://schemas.openxmlformats.org/drawingml/2006/main" prst="rect">
+            <a:avLst/>
+          </a:prstGeom>
+          <a:solidFill xmlns:a="http://schemas.openxmlformats.org/drawingml/2006/main">
+            <a:srgbClr val="FFFFFF"/>
+          </a:solidFill>
+          <a:ln xmlns:a="http://schemas.openxmlformats.org/drawingml/2006/main" w="0">
+            <a:solidFill>
+              <a:srgbClr val="FFFFFF"/>
+            </a:solidFill>
+            <a:prstDash val="solid"/>
+          </a:ln>
+        </p:spPr>
+      </p:sp>
+      <p:sp>
+        <p:nvSpPr>
+          <p:cNvPr id="183" name="slide-title">
+            <a:extLst xmlns:a="http://schemas.openxmlformats.org/drawingml/2006/main">
+              <a:ext uri="{FF2B5EF4-FFF2-40B4-BE49-F238E27FC236}">
+                <a16:creationId xmlns:a16="http://schemas.microsoft.com/office/drawing/2014/main" id="{42CD9AEA-76CB-444F-B45C-57ADD8113EF7}"/>
+              </a:ext>
+            </a:extLst>
+          </p:cNvPr>
+          <p:cNvSpPr>
+            <a:spLocks xmlns:a="http://schemas.openxmlformats.org/drawingml/2006/main" noGrp="1"/>
+          </p:cNvSpPr>
+          <p:nvPr/>
+        </p:nvSpPr>
+        <p:spPr>
+          <a:xfrm xmlns:a="http://schemas.openxmlformats.org/drawingml/2006/main">
+            <a:off x="685800" y="495300"/>
+            <a:ext cx="8191500" cy="590550"/>
+          </a:xfrm>
+          <a:prstGeom xmlns:a="http://schemas.openxmlformats.org/drawingml/2006/main" prst="rect">
+            <a:avLst/>
+          </a:prstGeom>
+          <a:noFill xmlns:a="http://schemas.openxmlformats.org/drawingml/2006/main"/>
+          <a:ln xmlns:a="http://schemas.openxmlformats.org/drawingml/2006/main" w="0">
+            <a:noFill/>
+            <a:prstDash val="solid"/>
+          </a:ln>
+        </p:spPr>
+        <p:txBody>
+          <a:bodyPr xmlns:a="http://schemas.openxmlformats.org/drawingml/2006/main"/>
+          <a:lstStyle xmlns:a="http://schemas.openxmlformats.org/drawingml/2006/main"/>
+          <a:p xmlns:a="http://schemas.openxmlformats.org/drawingml/2006/main">
+            <a:pPr>
+              <a:defRPr sz="2850" b="1">
+                <a:solidFill>
+                  <a:srgbClr val="111827"/>
+                </a:solidFill>
+              </a:defRPr>
+            </a:pPr>
+            <a:r>
+              <a:rPr sz="2850" b="1">
+                <a:solidFill>
+                  <a:srgbClr val="111827"/>
+                </a:solidFill>
+              </a:rPr>
+              <a:t>Problem statement and proposed solution</a:t>
+            </a:r>
+          </a:p>
+        </p:txBody>
+      </p:sp>
+      <p:sp>
+        <p:nvSpPr>
+          <p:cNvPr id="184" name="wordmark">
+            <a:extLst xmlns:a="http://schemas.openxmlformats.org/drawingml/2006/main">
+              <a:ext uri="{FF2B5EF4-FFF2-40B4-BE49-F238E27FC236}">
+                <a16:creationId xmlns:a16="http://schemas.microsoft.com/office/drawing/2014/main" id="{07901BE7-AB95-4BC4-B1D2-B32FD38C1675}"/>
+              </a:ext>
+            </a:extLst>
+          </p:cNvPr>
+          <p:cNvSpPr>
+            <a:spLocks xmlns:a="http://schemas.openxmlformats.org/drawingml/2006/main" noGrp="1"/>
+          </p:cNvSpPr>
+          <p:nvPr/>
+        </p:nvSpPr>
+        <p:spPr>
+          <a:xfrm xmlns:a="http://schemas.openxmlformats.org/drawingml/2006/main">
+            <a:off x="10287000" y="514350"/>
+            <a:ext cx="1285875" cy="400050"/>
+          </a:xfrm>
+          <a:prstGeom xmlns:a="http://schemas.openxmlformats.org/drawingml/2006/main" prst="rect">
+            <a:avLst/>
+          </a:prstGeom>
+          <a:noFill xmlns:a="http://schemas.openxmlformats.org/drawingml/2006/main"/>
+          <a:ln xmlns:a="http://schemas.openxmlformats.org/drawingml/2006/main" w="0">
+            <a:noFill/>
+            <a:prstDash val="solid"/>
+          </a:ln>
+        </p:spPr>
+        <p:txBody>
+          <a:bodyPr xmlns:a="http://schemas.openxmlformats.org/drawingml/2006/main"/>
+          <a:lstStyle xmlns:a="http://schemas.openxmlformats.org/drawingml/2006/main"/>
+          <a:p xmlns:a="http://schemas.openxmlformats.org/drawingml/2006/main">
+            <a:pPr algn="r">
+              <a:defRPr sz="2250" b="1">
+                <a:solidFill>
+                  <a:srgbClr val="111827"/>
+                </a:solidFill>
+              </a:defRPr>
+            </a:pPr>
+            <a:r>
+              <a:rPr sz="2250" b="1">
+                <a:solidFill>
+                  <a:srgbClr val="111827"/>
+                </a:solidFill>
+              </a:rPr>
+              <a:t>UiPath</a:t>
+            </a:r>
+          </a:p>
+        </p:txBody>
+      </p:sp>
+      <p:sp>
+        <p:nvSpPr>
+          <p:cNvPr id="185" name="bottom-rule">
+            <a:extLst xmlns:a="http://schemas.openxmlformats.org/drawingml/2006/main">
+              <a:ext uri="{FF2B5EF4-FFF2-40B4-BE49-F238E27FC236}">
+                <a16:creationId xmlns:a16="http://schemas.microsoft.com/office/drawing/2014/main" id="{32B20C5A-CF5B-40A5-A581-68D0B5D2BCE3}"/>
+              </a:ext>
+            </a:extLst>
+          </p:cNvPr>
+          <p:cNvSpPr>
+            <a:spLocks xmlns:a="http://schemas.openxmlformats.org/drawingml/2006/main" noGrp="1"/>
+          </p:cNvSpPr>
+          <p:nvPr/>
+        </p:nvSpPr>
+        <p:spPr>
+          <a:xfrm xmlns:a="http://schemas.openxmlformats.org/drawingml/2006/main">
+            <a:off x="0" y="6743700"/>
+            <a:ext cx="12192000" cy="114300"/>
+          </a:xfrm>
+          <a:prstGeom xmlns:a="http://schemas.openxmlformats.org/drawingml/2006/main" prst="rect">
+            <a:avLst/>
+          </a:prstGeom>
+          <a:solidFill xmlns:a="http://schemas.openxmlformats.org/drawingml/2006/main">
+            <a:srgbClr val="FA4616"/>
+          </a:solidFill>
+          <a:ln xmlns:a="http://schemas.openxmlformats.org/drawingml/2006/main" w="0">
+            <a:solidFill>
+              <a:srgbClr val="FA4616"/>
+            </a:solidFill>
+            <a:prstDash val="solid"/>
+          </a:ln>
+        </p:spPr>
+      </p:sp>
+      <p:sp>
+        <p:nvSpPr>
+          <p:cNvPr id="186" name="problem-label">
+            <a:extLst xmlns:a="http://schemas.openxmlformats.org/drawingml/2006/main">
+              <a:ext uri="{FF2B5EF4-FFF2-40B4-BE49-F238E27FC236}">
+                <a16:creationId xmlns:a16="http://schemas.microsoft.com/office/drawing/2014/main" id="{89EB1F6C-A9F6-42F0-8DAB-0E570EF733CC}"/>
+              </a:ext>
+            </a:extLst>
+          </p:cNvPr>
+          <p:cNvSpPr>
+            <a:spLocks xmlns:a="http://schemas.openxmlformats.org/drawingml/2006/main" noGrp="1"/>
+          </p:cNvSpPr>
+          <p:nvPr/>
+        </p:nvSpPr>
+        <p:spPr>
+          <a:xfrm xmlns:a="http://schemas.openxmlformats.org/drawingml/2006/main">
+            <a:off x="685800" y="1485900"/>
+            <a:ext cx="4000500" cy="361950"/>
+          </a:xfrm>
+          <a:prstGeom xmlns:a="http://schemas.openxmlformats.org/drawingml/2006/main" prst="rect">
+            <a:avLst/>
+          </a:prstGeom>
+          <a:noFill xmlns:a="http://schemas.openxmlformats.org/drawingml/2006/main"/>
+          <a:ln xmlns:a="http://schemas.openxmlformats.org/drawingml/2006/main" w="0">
+            <a:noFill/>
+            <a:prstDash val="solid"/>
+          </a:ln>
+        </p:spPr>
+        <p:txBody>
+          <a:bodyPr xmlns:a="http://schemas.openxmlformats.org/drawingml/2006/main"/>
+          <a:lstStyle xmlns:a="http://schemas.openxmlformats.org/drawingml/2006/main"/>
+          <a:p xmlns:a="http://schemas.openxmlformats.org/drawingml/2006/main">
+            <a:pPr>
+              <a:defRPr sz="1650" b="1">
+                <a:solidFill>
+                  <a:srgbClr val="111827"/>
+                </a:solidFill>
+              </a:defRPr>
+            </a:pPr>
+            <a:r>
+              <a:rPr sz="1650" b="1">
+                <a:solidFill>
+                  <a:srgbClr val="111827"/>
+                </a:solidFill>
+              </a:rPr>
+              <a:t>Problem</a:t>
+            </a:r>
+          </a:p>
+        </p:txBody>
+      </p:sp>
+      <p:sp>
+        <p:nvSpPr>
+          <p:cNvPr id="187" name="problem-copy">
+            <a:extLst xmlns:a="http://schemas.openxmlformats.org/drawingml/2006/main">
+              <a:ext uri="{FF2B5EF4-FFF2-40B4-BE49-F238E27FC236}">
+                <a16:creationId xmlns:a16="http://schemas.microsoft.com/office/drawing/2014/main" id="{A3467B59-B8EE-41C4-B7FE-4BDD7E37256A}"/>
+              </a:ext>
+            </a:extLst>
+          </p:cNvPr>
+          <p:cNvSpPr>
+            <a:spLocks xmlns:a="http://schemas.openxmlformats.org/drawingml/2006/main" noGrp="1"/>
+          </p:cNvSpPr>
+          <p:nvPr/>
+        </p:nvSpPr>
+        <p:spPr>
+          <a:xfrm xmlns:a="http://schemas.openxmlformats.org/drawingml/2006/main">
+            <a:off x="685800" y="2114550"/>
+            <a:ext cx="4381500" cy="2095500"/>
+          </a:xfrm>
+          <a:prstGeom xmlns:a="http://schemas.openxmlformats.org/drawingml/2006/main" prst="rect">
+            <a:avLst/>
+          </a:prstGeom>
+          <a:noFill xmlns:a="http://schemas.openxmlformats.org/drawingml/2006/main"/>
+          <a:ln xmlns:a="http://schemas.openxmlformats.org/drawingml/2006/main" w="0">
+            <a:noFill/>
+            <a:prstDash val="solid"/>
+          </a:ln>
+        </p:spPr>
+        <p:txBody>
+          <a:bodyPr xmlns:a="http://schemas.openxmlformats.org/drawingml/2006/main"/>
+          <a:lstStyle xmlns:a="http://schemas.openxmlformats.org/drawingml/2006/main"/>
+          <a:p xmlns:a="http://schemas.openxmlformats.org/drawingml/2006/main">
+            <a:pPr>
+              <a:defRPr sz="1500">
+                <a:solidFill>
+                  <a:srgbClr val="111827"/>
+                </a:solidFill>
+              </a:defRPr>
+            </a:pPr>
+            <a:r>
+              <a:rPr sz="1500">
+                <a:solidFill>
+                  <a:srgbClr val="111827"/>
+                </a:solidFill>
+              </a:rPr>
+              <a:t>AI can prepare a refund exception case quickly, but a prepared case can still miss evidence, skip a milestone, bypass policy, or route a high-value refund too early.</a:t>
+            </a:r>
+          </a:p>
+        </p:txBody>
+      </p:sp>
+      <p:sp>
+        <p:nvSpPr>
+          <p:cNvPr id="188" name="solution-label">
+            <a:extLst xmlns:a="http://schemas.openxmlformats.org/drawingml/2006/main">
+              <a:ext uri="{FF2B5EF4-FFF2-40B4-BE49-F238E27FC236}">
+                <a16:creationId xmlns:a16="http://schemas.microsoft.com/office/drawing/2014/main" id="{D700F751-7417-4C60-937F-C27417758BDF}"/>
+              </a:ext>
+            </a:extLst>
+          </p:cNvPr>
+          <p:cNvSpPr>
+            <a:spLocks xmlns:a="http://schemas.openxmlformats.org/drawingml/2006/main" noGrp="1"/>
+          </p:cNvSpPr>
+          <p:nvPr/>
+        </p:nvSpPr>
+        <p:spPr>
+          <a:xfrm xmlns:a="http://schemas.openxmlformats.org/drawingml/2006/main">
+            <a:off x="6496050" y="1485900"/>
+            <a:ext cx="4000500" cy="361950"/>
+          </a:xfrm>
+          <a:prstGeom xmlns:a="http://schemas.openxmlformats.org/drawingml/2006/main" prst="rect">
+            <a:avLst/>
+          </a:prstGeom>
+          <a:noFill xmlns:a="http://schemas.openxmlformats.org/drawingml/2006/main"/>
+          <a:ln xmlns:a="http://schemas.openxmlformats.org/drawingml/2006/main" w="0">
+            <a:noFill/>
+            <a:prstDash val="solid"/>
+          </a:ln>
+        </p:spPr>
+        <p:txBody>
+          <a:bodyPr xmlns:a="http://schemas.openxmlformats.org/drawingml/2006/main"/>
+          <a:lstStyle xmlns:a="http://schemas.openxmlformats.org/drawingml/2006/main"/>
+          <a:p xmlns:a="http://schemas.openxmlformats.org/drawingml/2006/main">
+            <a:pPr>
+              <a:defRPr sz="1650" b="1">
+                <a:solidFill>
+                  <a:srgbClr val="111827"/>
+                </a:solidFill>
+              </a:defRPr>
+            </a:pPr>
+            <a:r>
+              <a:rPr sz="1650" b="1">
+                <a:solidFill>
+                  <a:srgbClr val="111827"/>
+                </a:solidFill>
+              </a:rPr>
+              <a:t>Solution</a:t>
+            </a:r>
+          </a:p>
+        </p:txBody>
+      </p:sp>
+      <p:sp>
+        <p:nvSpPr>
+          <p:cNvPr id="189" name="solution-copy">
+            <a:extLst xmlns:a="http://schemas.openxmlformats.org/drawingml/2006/main">
+              <a:ext uri="{FF2B5EF4-FFF2-40B4-BE49-F238E27FC236}">
+                <a16:creationId xmlns:a16="http://schemas.microsoft.com/office/drawing/2014/main" id="{2B92426F-B2D5-4F11-A8C0-06C90A80BD22}"/>
+              </a:ext>
+            </a:extLst>
+          </p:cNvPr>
+          <p:cNvSpPr>
+            <a:spLocks xmlns:a="http://schemas.openxmlformats.org/drawingml/2006/main" noGrp="1"/>
+          </p:cNvSpPr>
+          <p:nvPr/>
+        </p:nvSpPr>
+        <p:spPr>
+          <a:xfrm xmlns:a="http://schemas.openxmlformats.org/drawingml/2006/main">
+            <a:off x="6496050" y="2114550"/>
+            <a:ext cx="4476750" cy="2095500"/>
+          </a:xfrm>
+          <a:prstGeom xmlns:a="http://schemas.openxmlformats.org/drawingml/2006/main" prst="rect">
+            <a:avLst/>
+          </a:prstGeom>
+          <a:noFill xmlns:a="http://schemas.openxmlformats.org/drawingml/2006/main"/>
+          <a:ln xmlns:a="http://schemas.openxmlformats.org/drawingml/2006/main" w="0">
+            <a:noFill/>
+            <a:prstDash val="solid"/>
+          </a:ln>
+        </p:spPr>
+        <p:txBody>
+          <a:bodyPr xmlns:a="http://schemas.openxmlformats.org/drawingml/2006/main"/>
+          <a:lstStyle xmlns:a="http://schemas.openxmlformats.org/drawingml/2006/main"/>
+          <a:p xmlns:a="http://schemas.openxmlformats.org/drawingml/2006/main">
+            <a:pPr>
+              <a:defRPr sz="1500">
+                <a:solidFill>
+                  <a:srgbClr val="111827"/>
+                </a:solidFill>
+              </a:defRPr>
+            </a:pPr>
+            <a:r>
+              <a:rPr sz="1500">
+                <a:solidFill>
+                  <a:srgbClr val="111827"/>
+                </a:solidFill>
+              </a:rPr>
+              <a:t>CaseProof validates a synthetic Maestro case packet and returns HOLD, BLOCK, or ALLOW_HUMAN_REVIEW_ONLY. It never issues refunds or changes customer records.</a:t>
+            </a:r>
+          </a:p>
+        </p:txBody>
+      </p:sp>
+      <p:sp>
+        <p:nvSpPr>
+          <p:cNvPr id="190" name="column-divider">
+            <a:extLst xmlns:a="http://schemas.openxmlformats.org/drawingml/2006/main">
+              <a:ext uri="{FF2B5EF4-FFF2-40B4-BE49-F238E27FC236}">
+                <a16:creationId xmlns:a16="http://schemas.microsoft.com/office/drawing/2014/main" id="{B76F00ED-41AA-4A66-89DC-B9E2C1D79A43}"/>
+              </a:ext>
+            </a:extLst>
+          </p:cNvPr>
+          <p:cNvSpPr>
+            <a:spLocks xmlns:a="http://schemas.openxmlformats.org/drawingml/2006/main" noGrp="1"/>
+          </p:cNvSpPr>
+          <p:nvPr/>
+        </p:nvSpPr>
+        <p:spPr>
+          <a:xfrm xmlns:a="http://schemas.openxmlformats.org/drawingml/2006/main">
+            <a:off x="5905500" y="1371600"/>
+            <a:ext cx="19050" cy="3524250"/>
+          </a:xfrm>
+          <a:prstGeom xmlns:a="http://schemas.openxmlformats.org/drawingml/2006/main" prst="rect">
+            <a:avLst/>
+          </a:prstGeom>
+          <a:solidFill xmlns:a="http://schemas.openxmlformats.org/drawingml/2006/main">
+            <a:srgbClr val="D1D5DB"/>
+          </a:solidFill>
+          <a:ln xmlns:a="http://schemas.openxmlformats.org/drawingml/2006/main" w="0">
+            <a:solidFill>
+              <a:srgbClr val="D1D5DB"/>
+            </a:solidFill>
+            <a:prstDash val="solid"/>
+          </a:ln>
+        </p:spPr>
+      </p:sp>
     </p:spTree>
     <p:extLst>
       <p:ext uri="{BB962C8B-B14F-4D97-AF65-F5344CB8AC3E}">
-        <p14:creationId xmlns:p14="http://schemas.microsoft.com/office/powerpoint/2010/main" val="1437228123"/>
+        <p14:creationId xmlns:p14="http://schemas.microsoft.com/office/powerpoint/2010/main" val="707133918"/>
       </p:ext>
     </p:extLst>
   </p:cSld>
@@ -21611,7 +22456,7 @@
           <p:cNvPr id="186" name="Google Shape;186;p4">
             <a:extLst xmlns:a="http://schemas.openxmlformats.org/drawingml/2006/main">
               <a:ext uri="{FF2B5EF4-FFF2-40B4-BE49-F238E27FC236}">
-                <a16:creationId xmlns:a16="http://schemas.microsoft.com/office/drawing/2014/main" id="{7E92B326-2F71-4D52-A1E0-1D2CEB08EAED}"/>
+                <a16:creationId xmlns:a16="http://schemas.microsoft.com/office/drawing/2014/main" id="{00A120A0-4202-423F-9C3C-8463A7FEC553}"/>
               </a:ext>
             </a:extLst>
           </p:cNvPr>
@@ -21650,16 +22495,11 @@
                 <a:spcPts val="0"/>
               </a:spcAft>
               <a:buNone/>
-              <a:defRPr sz="2850" b="1">
-                <a:solidFill>
-                  <a:srgbClr val="111827"/>
-                </a:solidFill>
-              </a:defRPr>
             </a:pPr>
             <a:r>
-              <a:rPr sz="2850" b="1" i="0" u="none" cap="none">
-                <a:solidFill>
-                  <a:srgbClr val="111827"/>
+              <a:rPr sz="3000" b="1" i="0" u="none" cap="none">
+                <a:solidFill>
+                  <a:schemeClr val="dk1"/>
                 </a:solidFill>
                 <a:latin typeface="Arial"/>
                 <a:ea typeface="Arial"/>
@@ -21675,7 +22515,7 @@
           <p:cNvPr id="187" name="Google Shape;187;p4">
             <a:extLst xmlns:a="http://schemas.openxmlformats.org/drawingml/2006/main">
               <a:ext uri="{FF2B5EF4-FFF2-40B4-BE49-F238E27FC236}">
-                <a16:creationId xmlns:a16="http://schemas.microsoft.com/office/drawing/2014/main" id="{973E0366-34DC-438B-9BE2-D03D91C67983}"/>
+                <a16:creationId xmlns:a16="http://schemas.microsoft.com/office/drawing/2014/main" id="{AC09B72B-AA0F-4451-B405-22F5C062B75C}"/>
               </a:ext>
             </a:extLst>
           </p:cNvPr>
@@ -21725,7 +22565,7 @@
       </p:sp>
       <p:graphicFrame>
         <p:nvGraphicFramePr>
-          <p:cNvPr id="201" name="Google Shape;188;p4"/>
+          <p:cNvPr id="204" name="Google Shape;188;p4"/>
           <p:cNvGraphicFramePr/>
           <p:nvPr/>
         </p:nvGraphicFramePr>
@@ -22311,7 +23151,7 @@
           <p:cNvPr id="189" name="Google Shape;189;p4">
             <a:extLst xmlns:a="http://schemas.openxmlformats.org/drawingml/2006/main">
               <a:ext uri="{FF2B5EF4-FFF2-40B4-BE49-F238E27FC236}">
-                <a16:creationId xmlns:a16="http://schemas.microsoft.com/office/drawing/2014/main" id="{84CF8D19-C139-4B63-8C68-6CB7D5D4C8AC}"/>
+                <a16:creationId xmlns:a16="http://schemas.microsoft.com/office/drawing/2014/main" id="{37B3ED93-4579-4589-842E-C4698E2CC188}"/>
               </a:ext>
             </a:extLst>
           </p:cNvPr>
@@ -22387,7 +23227,7 @@
           <p:cNvPr id="190" name="Google Shape;190;p4">
             <a:extLst xmlns:a="http://schemas.openxmlformats.org/drawingml/2006/main">
               <a:ext uri="{FF2B5EF4-FFF2-40B4-BE49-F238E27FC236}">
-                <a16:creationId xmlns:a16="http://schemas.microsoft.com/office/drawing/2014/main" id="{5B23BD26-4D47-4486-BAB9-2365D104B3CB}"/>
+                <a16:creationId xmlns:a16="http://schemas.microsoft.com/office/drawing/2014/main" id="{9FABB9C2-F72C-4D5B-A2BA-16301F265BF8}"/>
               </a:ext>
             </a:extLst>
           </p:cNvPr>
@@ -22426,22 +23266,17 @@
                 <a:spcPts val="0"/>
               </a:spcAft>
               <a:buNone/>
-              <a:defRPr sz="1650" b="1">
-                <a:solidFill>
-                  <a:srgbClr val="111827"/>
-                </a:solidFill>
-              </a:defRPr>
             </a:pPr>
             <a:r>
-              <a:rPr sz="1650" b="1" i="0" u="none" cap="none">
-                <a:solidFill>
-                  <a:srgbClr val="111827"/>
+              <a:rPr sz="2100" b="1" i="0" u="none" cap="none">
+                <a:solidFill>
+                  <a:schemeClr val="dk1"/>
                 </a:solidFill>
                 <a:latin typeface="Arial"/>
                 <a:ea typeface="Arial"/>
                 <a:cs typeface="Arial"/>
               </a:rPr>
-              <a:t>UiPath components and agent type</a:t>
+              <a:t>Benefits, impact and outcomes</a:t>
             </a:r>
           </a:p>
         </p:txBody>
@@ -22451,7 +23286,7 @@
           <p:cNvPr id="191" name="Google Shape;191;p4">
             <a:extLst xmlns:a="http://schemas.openxmlformats.org/drawingml/2006/main">
               <a:ext uri="{FF2B5EF4-FFF2-40B4-BE49-F238E27FC236}">
-                <a16:creationId xmlns:a16="http://schemas.microsoft.com/office/drawing/2014/main" id="{200D0F2B-7A6D-4478-8B1E-3A4613F98A64}"/>
+                <a16:creationId xmlns:a16="http://schemas.microsoft.com/office/drawing/2014/main" id="{2136395D-D7DA-4A2B-9EE4-9F863FB057BF}"/>
               </a:ext>
             </a:extLst>
           </p:cNvPr>
@@ -22490,22 +23325,17 @@
                 <a:spcPts val="0"/>
               </a:spcAft>
               <a:buChar char="●"/>
-              <a:defRPr sz="1275">
-                <a:solidFill>
-                  <a:srgbClr val="111827"/>
-                </a:solidFill>
-              </a:defRPr>
             </a:pPr>
             <a:r>
-              <a:rPr sz="1275">
-                <a:solidFill>
-                  <a:srgbClr val="111827"/>
+              <a:rPr sz="1800">
+                <a:solidFill>
+                  <a:srgbClr val="1D1D1F"/>
                 </a:solidFill>
                 <a:highlight>
                   <a:srgbClr val="FFFFFF"/>
                 </a:highlight>
               </a:rPr>
-              <a:t>UiPath Components:</a:t>
+              <a:t>Reduces the complexity of government paperwork through AI-guided assistance. </a:t>
             </a:r>
           </a:p>
           <a:p xmlns:a="http://schemas.openxmlformats.org/drawingml/2006/main">
@@ -22520,22 +23350,17 @@
                 <a:spcPts val="0"/>
               </a:spcAft>
               <a:buChar char="●"/>
-              <a:defRPr sz="1275">
-                <a:solidFill>
-                  <a:srgbClr val="111827"/>
-                </a:solidFill>
-              </a:defRPr>
             </a:pPr>
             <a:r>
-              <a:rPr sz="1275">
-                <a:solidFill>
-                  <a:srgbClr val="111827"/>
+              <a:rPr sz="1800">
+                <a:solidFill>
+                  <a:srgbClr val="1D1D1F"/>
                 </a:solidFill>
                 <a:highlight>
                   <a:srgbClr val="FFFFFF"/>
                 </a:highlight>
               </a:rPr>
-              <a:t>Automation Cloud, Maestro case model, Studio Web or API Workflow handoff, optional Apps/Action Center style human review, coded Python validator, synthetic Maestro case packets.</a:t>
+              <a:t>Enables users to understand official documents using AI-powered document intelligence. </a:t>
             </a:r>
           </a:p>
           <a:p xmlns:a="http://schemas.openxmlformats.org/drawingml/2006/main">
@@ -22560,7 +23385,7 @@
                   <a:srgbClr val="FFFFFF"/>
                 </a:highlight>
               </a:rPr>
-              <a:t/>
+              <a:t>Minimizes repetitive form filling with reusable user profiles and automation. </a:t>
             </a:r>
           </a:p>
           <a:p xmlns:a="http://schemas.openxmlformats.org/drawingml/2006/main">
@@ -22575,22 +23400,17 @@
                 <a:spcPts val="0"/>
               </a:spcAft>
               <a:buChar char="●"/>
-              <a:defRPr sz="1275">
-                <a:solidFill>
-                  <a:srgbClr val="111827"/>
-                </a:solidFill>
-              </a:defRPr>
             </a:pPr>
             <a:r>
-              <a:rPr sz="1275">
-                <a:solidFill>
-                  <a:srgbClr val="111827"/>
+              <a:rPr sz="1800">
+                <a:solidFill>
+                  <a:srgbClr val="1D1D1F"/>
                 </a:solidFill>
                 <a:highlight>
                   <a:srgbClr val="FFFFFF"/>
                 </a:highlight>
               </a:rPr>
-              <a:t>Agent Type:</a:t>
+              <a:t> Improves accessibility by combining voice, vision, and document understanding in a single platform. .</a:t>
             </a:r>
           </a:p>
           <a:p xmlns:a="http://schemas.openxmlformats.org/drawingml/2006/main">
@@ -22605,29 +23425,19 @@
                 <a:spcPts val="0"/>
               </a:spcAft>
               <a:buNone/>
-              <a:defRPr sz="1275">
-                <a:solidFill>
-                  <a:srgbClr val="111827"/>
-                </a:solidFill>
-              </a:defRPr>
             </a:pPr>
             <a:r>
-              <a:rPr sz="1275">
-                <a:solidFill>
-                  <a:srgbClr val="111827"/>
-                </a:solidFill>
-              </a:rPr>
-              <a:t>Coded Agent validator plus low-code Maestro/API workflow integration path.</a:t>
+              <a:t/>
             </a:r>
           </a:p>
         </p:txBody>
       </p:sp>
       <p:sp>
         <p:nvSpPr>
-          <p:cNvPr id="193" name="benefits-cover">
+          <p:cNvPr id="193" name="clean-white-background">
             <a:extLst xmlns:a="http://schemas.openxmlformats.org/drawingml/2006/main">
               <a:ext uri="{FF2B5EF4-FFF2-40B4-BE49-F238E27FC236}">
-                <a16:creationId xmlns:a16="http://schemas.microsoft.com/office/drawing/2014/main" id="{2697A87A-CD81-48C7-AE6A-4FC7F4C85265}"/>
+                <a16:creationId xmlns:a16="http://schemas.microsoft.com/office/drawing/2014/main" id="{CC2D9216-3433-4D05-AF7D-9B1842150FBA}"/>
               </a:ext>
             </a:extLst>
           </p:cNvPr>
@@ -22638,8 +23448,8 @@
         </p:nvSpPr>
         <p:spPr>
           <a:xfrm xmlns:a="http://schemas.openxmlformats.org/drawingml/2006/main">
-            <a:off x="228600" y="990600"/>
-            <a:ext cx="5524500" cy="5695950"/>
+            <a:off x="0" y="0"/>
+            <a:ext cx="12192000" cy="6858000"/>
           </a:xfrm>
           <a:prstGeom xmlns:a="http://schemas.openxmlformats.org/drawingml/2006/main" prst="rect">
             <a:avLst/>
@@ -22657,10 +23467,10 @@
       </p:sp>
       <p:sp>
         <p:nvSpPr>
-          <p:cNvPr id="194" name="benefits-label">
+          <p:cNvPr id="194" name="slide-title">
             <a:extLst xmlns:a="http://schemas.openxmlformats.org/drawingml/2006/main">
               <a:ext uri="{FF2B5EF4-FFF2-40B4-BE49-F238E27FC236}">
-                <a16:creationId xmlns:a16="http://schemas.microsoft.com/office/drawing/2014/main" id="{5414C415-3E7B-4FE8-9B26-BCC539EC4292}"/>
+                <a16:creationId xmlns:a16="http://schemas.microsoft.com/office/drawing/2014/main" id="{AEFFAE15-5252-451F-8A10-582CEC85FC3A}"/>
               </a:ext>
             </a:extLst>
           </p:cNvPr>
@@ -22671,7 +23481,140 @@
         </p:nvSpPr>
         <p:spPr>
           <a:xfrm xmlns:a="http://schemas.openxmlformats.org/drawingml/2006/main">
-            <a:off x="495300" y="1257300"/>
+            <a:off x="685800" y="495300"/>
+            <a:ext cx="8191500" cy="590550"/>
+          </a:xfrm>
+          <a:prstGeom xmlns:a="http://schemas.openxmlformats.org/drawingml/2006/main" prst="rect">
+            <a:avLst/>
+          </a:prstGeom>
+          <a:noFill xmlns:a="http://schemas.openxmlformats.org/drawingml/2006/main"/>
+          <a:ln xmlns:a="http://schemas.openxmlformats.org/drawingml/2006/main" w="0">
+            <a:noFill/>
+            <a:prstDash val="solid"/>
+          </a:ln>
+        </p:spPr>
+        <p:txBody>
+          <a:bodyPr xmlns:a="http://schemas.openxmlformats.org/drawingml/2006/main"/>
+          <a:lstStyle xmlns:a="http://schemas.openxmlformats.org/drawingml/2006/main"/>
+          <a:p xmlns:a="http://schemas.openxmlformats.org/drawingml/2006/main">
+            <a:pPr>
+              <a:defRPr sz="2850" b="1">
+                <a:solidFill>
+                  <a:srgbClr val="111827"/>
+                </a:solidFill>
+              </a:defRPr>
+            </a:pPr>
+            <a:r>
+              <a:rPr sz="2850" b="1">
+                <a:solidFill>
+                  <a:srgbClr val="111827"/>
+                </a:solidFill>
+              </a:rPr>
+              <a:t>Benefits and technologies used</a:t>
+            </a:r>
+          </a:p>
+        </p:txBody>
+      </p:sp>
+      <p:sp>
+        <p:nvSpPr>
+          <p:cNvPr id="195" name="wordmark">
+            <a:extLst xmlns:a="http://schemas.openxmlformats.org/drawingml/2006/main">
+              <a:ext uri="{FF2B5EF4-FFF2-40B4-BE49-F238E27FC236}">
+                <a16:creationId xmlns:a16="http://schemas.microsoft.com/office/drawing/2014/main" id="{4D380737-769B-4FFB-88AE-3E89B17A0756}"/>
+              </a:ext>
+            </a:extLst>
+          </p:cNvPr>
+          <p:cNvSpPr>
+            <a:spLocks xmlns:a="http://schemas.openxmlformats.org/drawingml/2006/main" noGrp="1"/>
+          </p:cNvSpPr>
+          <p:nvPr/>
+        </p:nvSpPr>
+        <p:spPr>
+          <a:xfrm xmlns:a="http://schemas.openxmlformats.org/drawingml/2006/main">
+            <a:off x="10287000" y="514350"/>
+            <a:ext cx="1285875" cy="400050"/>
+          </a:xfrm>
+          <a:prstGeom xmlns:a="http://schemas.openxmlformats.org/drawingml/2006/main" prst="rect">
+            <a:avLst/>
+          </a:prstGeom>
+          <a:noFill xmlns:a="http://schemas.openxmlformats.org/drawingml/2006/main"/>
+          <a:ln xmlns:a="http://schemas.openxmlformats.org/drawingml/2006/main" w="0">
+            <a:noFill/>
+            <a:prstDash val="solid"/>
+          </a:ln>
+        </p:spPr>
+        <p:txBody>
+          <a:bodyPr xmlns:a="http://schemas.openxmlformats.org/drawingml/2006/main"/>
+          <a:lstStyle xmlns:a="http://schemas.openxmlformats.org/drawingml/2006/main"/>
+          <a:p xmlns:a="http://schemas.openxmlformats.org/drawingml/2006/main">
+            <a:pPr algn="r">
+              <a:defRPr sz="2250" b="1">
+                <a:solidFill>
+                  <a:srgbClr val="111827"/>
+                </a:solidFill>
+              </a:defRPr>
+            </a:pPr>
+            <a:r>
+              <a:rPr sz="2250" b="1">
+                <a:solidFill>
+                  <a:srgbClr val="111827"/>
+                </a:solidFill>
+              </a:rPr>
+              <a:t>UiPath</a:t>
+            </a:r>
+          </a:p>
+        </p:txBody>
+      </p:sp>
+      <p:sp>
+        <p:nvSpPr>
+          <p:cNvPr id="196" name="bottom-rule">
+            <a:extLst xmlns:a="http://schemas.openxmlformats.org/drawingml/2006/main">
+              <a:ext uri="{FF2B5EF4-FFF2-40B4-BE49-F238E27FC236}">
+                <a16:creationId xmlns:a16="http://schemas.microsoft.com/office/drawing/2014/main" id="{78A93A76-3227-4086-A838-761A92E2DAC0}"/>
+              </a:ext>
+            </a:extLst>
+          </p:cNvPr>
+          <p:cNvSpPr>
+            <a:spLocks xmlns:a="http://schemas.openxmlformats.org/drawingml/2006/main" noGrp="1"/>
+          </p:cNvSpPr>
+          <p:nvPr/>
+        </p:nvSpPr>
+        <p:spPr>
+          <a:xfrm xmlns:a="http://schemas.openxmlformats.org/drawingml/2006/main">
+            <a:off x="0" y="6743700"/>
+            <a:ext cx="12192000" cy="114300"/>
+          </a:xfrm>
+          <a:prstGeom xmlns:a="http://schemas.openxmlformats.org/drawingml/2006/main" prst="rect">
+            <a:avLst/>
+          </a:prstGeom>
+          <a:solidFill xmlns:a="http://schemas.openxmlformats.org/drawingml/2006/main">
+            <a:srgbClr val="FA4616"/>
+          </a:solidFill>
+          <a:ln xmlns:a="http://schemas.openxmlformats.org/drawingml/2006/main" w="0">
+            <a:solidFill>
+              <a:srgbClr val="FA4616"/>
+            </a:solidFill>
+            <a:prstDash val="solid"/>
+          </a:ln>
+        </p:spPr>
+      </p:sp>
+      <p:sp>
+        <p:nvSpPr>
+          <p:cNvPr id="197" name="benefits-label">
+            <a:extLst xmlns:a="http://schemas.openxmlformats.org/drawingml/2006/main">
+              <a:ext uri="{FF2B5EF4-FFF2-40B4-BE49-F238E27FC236}">
+                <a16:creationId xmlns:a16="http://schemas.microsoft.com/office/drawing/2014/main" id="{33C2EF30-A9C9-49FA-A2EB-903FAE7A192F}"/>
+              </a:ext>
+            </a:extLst>
+          </p:cNvPr>
+          <p:cNvSpPr>
+            <a:spLocks xmlns:a="http://schemas.openxmlformats.org/drawingml/2006/main" noGrp="1"/>
+          </p:cNvSpPr>
+          <p:nvPr/>
+        </p:nvSpPr>
+        <p:spPr>
+          <a:xfrm xmlns:a="http://schemas.openxmlformats.org/drawingml/2006/main">
+            <a:off x="685800" y="1390650"/>
             <a:ext cx="4953000" cy="400050"/>
           </a:xfrm>
           <a:prstGeom xmlns:a="http://schemas.openxmlformats.org/drawingml/2006/main" prst="rect">
@@ -22707,10 +23650,10 @@
       </p:sp>
       <p:sp>
         <p:nvSpPr>
-          <p:cNvPr id="195" name="benefits-body">
+          <p:cNvPr id="198" name="benefits-body">
             <a:extLst xmlns:a="http://schemas.openxmlformats.org/drawingml/2006/main">
               <a:ext uri="{FF2B5EF4-FFF2-40B4-BE49-F238E27FC236}">
-                <a16:creationId xmlns:a16="http://schemas.microsoft.com/office/drawing/2014/main" id="{9D35AF9B-C70D-42C1-B693-DA3E5ED9518E}"/>
+                <a16:creationId xmlns:a16="http://schemas.microsoft.com/office/drawing/2014/main" id="{7B3661B6-7939-47FE-B3F7-54CA3842AD84}"/>
               </a:ext>
             </a:extLst>
           </p:cNvPr>
@@ -22721,8 +23664,8 @@
         </p:nvSpPr>
         <p:spPr>
           <a:xfrm xmlns:a="http://schemas.openxmlformats.org/drawingml/2006/main">
-            <a:off x="495300" y="1847850"/>
-            <a:ext cx="4857750" cy="3429000"/>
+            <a:off x="685800" y="2038350"/>
+            <a:ext cx="4857750" cy="3143250"/>
           </a:xfrm>
           <a:prstGeom xmlns:a="http://schemas.openxmlformats.org/drawingml/2006/main" prst="rect">
             <a:avLst/>
@@ -22791,10 +23734,10 @@
       </p:sp>
       <p:sp>
         <p:nvSpPr>
-          <p:cNvPr id="196" name="tech-cover">
+          <p:cNvPr id="199" name="tech-label">
             <a:extLst xmlns:a="http://schemas.openxmlformats.org/drawingml/2006/main">
               <a:ext uri="{FF2B5EF4-FFF2-40B4-BE49-F238E27FC236}">
-                <a16:creationId xmlns:a16="http://schemas.microsoft.com/office/drawing/2014/main" id="{E0B6F359-E7BF-45AB-8EF1-247DCE656B55}"/>
+                <a16:creationId xmlns:a16="http://schemas.microsoft.com/office/drawing/2014/main" id="{523CE3ED-3383-44E6-99D1-7C21102017AA}"/>
               </a:ext>
             </a:extLst>
           </p:cNvPr>
@@ -22805,40 +23748,7 @@
         </p:nvSpPr>
         <p:spPr>
           <a:xfrm xmlns:a="http://schemas.openxmlformats.org/drawingml/2006/main">
-            <a:off x="6096000" y="1085850"/>
-            <a:ext cx="5638800" cy="4095750"/>
-          </a:xfrm>
-          <a:prstGeom xmlns:a="http://schemas.openxmlformats.org/drawingml/2006/main" prst="rect">
-            <a:avLst/>
-          </a:prstGeom>
-          <a:solidFill xmlns:a="http://schemas.openxmlformats.org/drawingml/2006/main">
-            <a:srgbClr val="FFFFFF"/>
-          </a:solidFill>
-          <a:ln xmlns:a="http://schemas.openxmlformats.org/drawingml/2006/main" w="0">
-            <a:solidFill>
-              <a:srgbClr val="FFFFFF"/>
-            </a:solidFill>
-            <a:prstDash val="solid"/>
-          </a:ln>
-        </p:spPr>
-      </p:sp>
-      <p:sp>
-        <p:nvSpPr>
-          <p:cNvPr id="197" name="tech-label">
-            <a:extLst xmlns:a="http://schemas.openxmlformats.org/drawingml/2006/main">
-              <a:ext uri="{FF2B5EF4-FFF2-40B4-BE49-F238E27FC236}">
-                <a16:creationId xmlns:a16="http://schemas.microsoft.com/office/drawing/2014/main" id="{5C2AE83F-B3CE-4DDB-8AE0-C8E535025F5A}"/>
-              </a:ext>
-            </a:extLst>
-          </p:cNvPr>
-          <p:cNvSpPr>
-            <a:spLocks xmlns:a="http://schemas.openxmlformats.org/drawingml/2006/main" noGrp="1"/>
-          </p:cNvSpPr>
-          <p:nvPr/>
-        </p:nvSpPr>
-        <p:spPr>
-          <a:xfrm xmlns:a="http://schemas.openxmlformats.org/drawingml/2006/main">
-            <a:off x="6438900" y="1295400"/>
+            <a:off x="6572250" y="1390650"/>
             <a:ext cx="4953000" cy="400050"/>
           </a:xfrm>
           <a:prstGeom xmlns:a="http://schemas.openxmlformats.org/drawingml/2006/main" prst="rect">
@@ -22874,10 +23784,10 @@
       </p:sp>
       <p:sp>
         <p:nvSpPr>
-          <p:cNvPr id="198" name="tech-body">
+          <p:cNvPr id="200" name="tech-body">
             <a:extLst xmlns:a="http://schemas.openxmlformats.org/drawingml/2006/main">
               <a:ext uri="{FF2B5EF4-FFF2-40B4-BE49-F238E27FC236}">
-                <a16:creationId xmlns:a16="http://schemas.microsoft.com/office/drawing/2014/main" id="{DCF88E56-1268-4236-9418-4490F1955F54}"/>
+                <a16:creationId xmlns:a16="http://schemas.microsoft.com/office/drawing/2014/main" id="{0FBE6236-E41D-46EF-89C7-DD19691B7E75}"/>
               </a:ext>
             </a:extLst>
           </p:cNvPr>
@@ -22888,8 +23798,8 @@
         </p:nvSpPr>
         <p:spPr>
           <a:xfrm xmlns:a="http://schemas.openxmlformats.org/drawingml/2006/main">
-            <a:off x="6438900" y="2038350"/>
-            <a:ext cx="4810125" cy="2857500"/>
+            <a:off x="6572250" y="2038350"/>
+            <a:ext cx="4476750" cy="3333750"/>
           </a:xfrm>
           <a:prstGeom xmlns:a="http://schemas.openxmlformats.org/drawingml/2006/main" prst="rect">
             <a:avLst/>
@@ -22978,10 +23888,43 @@
           </a:p>
         </p:txBody>
       </p:sp>
+      <p:sp>
+        <p:nvSpPr>
+          <p:cNvPr id="201" name="column-divider">
+            <a:extLst xmlns:a="http://schemas.openxmlformats.org/drawingml/2006/main">
+              <a:ext uri="{FF2B5EF4-FFF2-40B4-BE49-F238E27FC236}">
+                <a16:creationId xmlns:a16="http://schemas.microsoft.com/office/drawing/2014/main" id="{5CEFD0B5-8627-4251-933C-162F36522724}"/>
+              </a:ext>
+            </a:extLst>
+          </p:cNvPr>
+          <p:cNvSpPr>
+            <a:spLocks xmlns:a="http://schemas.openxmlformats.org/drawingml/2006/main" noGrp="1"/>
+          </p:cNvSpPr>
+          <p:nvPr/>
+        </p:nvSpPr>
+        <p:spPr>
+          <a:xfrm xmlns:a="http://schemas.openxmlformats.org/drawingml/2006/main">
+            <a:off x="5981700" y="1371600"/>
+            <a:ext cx="19050" cy="3857625"/>
+          </a:xfrm>
+          <a:prstGeom xmlns:a="http://schemas.openxmlformats.org/drawingml/2006/main" prst="rect">
+            <a:avLst/>
+          </a:prstGeom>
+          <a:solidFill xmlns:a="http://schemas.openxmlformats.org/drawingml/2006/main">
+            <a:srgbClr val="D1D5DB"/>
+          </a:solidFill>
+          <a:ln xmlns:a="http://schemas.openxmlformats.org/drawingml/2006/main" w="0">
+            <a:solidFill>
+              <a:srgbClr val="D1D5DB"/>
+            </a:solidFill>
+            <a:prstDash val="solid"/>
+          </a:ln>
+        </p:spPr>
+      </p:sp>
     </p:spTree>
     <p:extLst>
       <p:ext uri="{BB962C8B-B14F-4D97-AF65-F5344CB8AC3E}">
-        <p14:creationId xmlns:p14="http://schemas.microsoft.com/office/powerpoint/2010/main" val="778437877"/>
+        <p14:creationId xmlns:p14="http://schemas.microsoft.com/office/powerpoint/2010/main" val="1108315016"/>
       </p:ext>
     </p:extLst>
   </p:cSld>
@@ -23005,7 +23948,7 @@
           <p:cNvPr id="196" name="Google Shape;196;p5">
             <a:extLst xmlns:a="http://schemas.openxmlformats.org/drawingml/2006/main">
               <a:ext uri="{FF2B5EF4-FFF2-40B4-BE49-F238E27FC236}">
-                <a16:creationId xmlns:a16="http://schemas.microsoft.com/office/drawing/2014/main" id="{F40FF282-F565-403D-9C0A-2956BD91B3AB}"/>
+                <a16:creationId xmlns:a16="http://schemas.microsoft.com/office/drawing/2014/main" id="{F14D1BD7-8A6D-4116-B1ED-7B236A7688F5}"/>
               </a:ext>
             </a:extLst>
           </p:cNvPr>
@@ -23058,7 +24001,7 @@
           <p:cNvPr id="197" name="Google Shape;197;p5">
             <a:extLst xmlns:a="http://schemas.openxmlformats.org/drawingml/2006/main">
               <a:ext uri="{FF2B5EF4-FFF2-40B4-BE49-F238E27FC236}">
-                <a16:creationId xmlns:a16="http://schemas.microsoft.com/office/drawing/2014/main" id="{B93E3817-3938-4F4E-97E6-55733513DF45}"/>
+                <a16:creationId xmlns:a16="http://schemas.microsoft.com/office/drawing/2014/main" id="{20FCF454-BE91-441B-81C3-E828B57EAB00}"/>
               </a:ext>
             </a:extLst>
           </p:cNvPr>
@@ -23134,7 +24077,7 @@
           <p:cNvPr id="198" name="Google Shape;198;p5">
             <a:extLst xmlns:a="http://schemas.openxmlformats.org/drawingml/2006/main">
               <a:ext uri="{FF2B5EF4-FFF2-40B4-BE49-F238E27FC236}">
-                <a16:creationId xmlns:a16="http://schemas.microsoft.com/office/drawing/2014/main" id="{DFEAFF36-70E0-4AB5-8C52-00877F81733D}"/>
+                <a16:creationId xmlns:a16="http://schemas.microsoft.com/office/drawing/2014/main" id="{DB738CF2-2B62-4E19-B819-6CCE3B4AA231}"/>
               </a:ext>
             </a:extLst>
           </p:cNvPr>
@@ -23173,16 +24116,11 @@
                 <a:spcPts val="0"/>
               </a:spcAft>
               <a:buNone/>
-              <a:defRPr sz="2850" b="1">
-                <a:solidFill>
-                  <a:srgbClr val="111827"/>
-                </a:solidFill>
-              </a:defRPr>
             </a:pPr>
             <a:r>
-              <a:rPr sz="2850" b="1" i="0" u="none" cap="none">
-                <a:solidFill>
-                  <a:srgbClr val="111827"/>
+              <a:rPr sz="3000" b="1" i="0" u="none" cap="none">
+                <a:solidFill>
+                  <a:schemeClr val="dk1"/>
                 </a:solidFill>
                 <a:latin typeface="Arial"/>
                 <a:ea typeface="Arial"/>
@@ -23198,7 +24136,7 @@
           <p:cNvPr id="199" name="Google Shape;199;p5">
             <a:extLst xmlns:a="http://schemas.openxmlformats.org/drawingml/2006/main">
               <a:ext uri="{FF2B5EF4-FFF2-40B4-BE49-F238E27FC236}">
-                <a16:creationId xmlns:a16="http://schemas.microsoft.com/office/drawing/2014/main" id="{C691290D-C3E6-4591-98AF-1E105365EE28}"/>
+                <a16:creationId xmlns:a16="http://schemas.microsoft.com/office/drawing/2014/main" id="{F702F80B-5755-442C-8518-C0CE7636C982}"/>
               </a:ext>
             </a:extLst>
           </p:cNvPr>
@@ -23237,14 +24175,298 @@
                 <a:spcPts val="0"/>
               </a:spcAft>
               <a:buNone/>
-              <a:defRPr sz="1650">
-                <a:solidFill>
-                  <a:srgbClr val="111827"/>
-                </a:solidFill>
-              </a:defRPr>
             </a:pPr>
             <a:r>
-              <a:rPr sz="1650">
+              <a:t/>
+            </a:r>
+          </a:p>
+          <a:p xmlns:a="http://schemas.openxmlformats.org/drawingml/2006/main">
+            <a:pPr marL="0" indent="0" algn="l">
+              <a:lnSpc>
+                <a:spcPct val="115000"/>
+              </a:lnSpc>
+              <a:spcBef>
+                <a:spcPts val="0"/>
+              </a:spcBef>
+              <a:spcAft>
+                <a:spcPts val="0"/>
+              </a:spcAft>
+              <a:buNone/>
+            </a:pPr>
+            <a:r>
+              <a:rPr sz="2100">
+                <a:solidFill>
+                  <a:srgbClr val="1D1D1F"/>
+                </a:solidFill>
+                <a:highlight>
+                  <a:srgbClr val="FFFFFF"/>
+                </a:highlight>
+              </a:rPr>
+              <a:t>"See complete architecture and screenshots in our GitHub repository:"</a:t>
+            </a:r>
+          </a:p>
+          <a:p xmlns:a="http://schemas.openxmlformats.org/drawingml/2006/main">
+            <a:pPr marL="0" indent="0" algn="l">
+              <a:lnSpc>
+                <a:spcPct val="115000"/>
+              </a:lnSpc>
+              <a:spcBef>
+                <a:spcPts val="0"/>
+              </a:spcBef>
+              <a:spcAft>
+                <a:spcPts val="0"/>
+              </a:spcAft>
+              <a:buNone/>
+            </a:pPr>
+            <a:r>
+              <a:t/>
+            </a:r>
+          </a:p>
+          <a:p xmlns:a="http://schemas.openxmlformats.org/drawingml/2006/main">
+            <a:pPr marL="0" indent="0" algn="l">
+              <a:lnSpc>
+                <a:spcPct val="115000"/>
+              </a:lnSpc>
+              <a:spcBef>
+                <a:spcPts val="0"/>
+              </a:spcBef>
+              <a:spcAft>
+                <a:spcPts val="0"/>
+              </a:spcAft>
+              <a:buNone/>
+            </a:pPr>
+            <a:r>
+              <a:rPr sz="2100">
+                <a:solidFill>
+                  <a:srgbClr val="1D1D1F"/>
+                </a:solidFill>
+                <a:highlight>
+                  <a:srgbClr val="FFFFFF"/>
+                </a:highlight>
+              </a:rPr>
+              <a:t>GitHub Repo: </a:t>
+            </a:r>
+            <a:r>
+              <a:rPr sz="2100">
+                <a:solidFill>
+                  <a:srgbClr val="1D1D1F"/>
+                </a:solidFill>
+                <a:highlight>
+                  <a:srgbClr val="EFEEFF"/>
+                </a:highlight>
+              </a:rPr>
+              <a:t>https://github.com/nisithaa-03/AURA-.git</a:t>
+            </a:r>
+          </a:p>
+        </p:txBody>
+      </p:sp>
+      <p:sp>
+        <p:nvSpPr>
+          <p:cNvPr id="200" name="clean-white-background">
+            <a:extLst xmlns:a="http://schemas.openxmlformats.org/drawingml/2006/main">
+              <a:ext uri="{FF2B5EF4-FFF2-40B4-BE49-F238E27FC236}">
+                <a16:creationId xmlns:a16="http://schemas.microsoft.com/office/drawing/2014/main" id="{043007BF-8B66-46AE-AD84-87CCCB5A810F}"/>
+              </a:ext>
+            </a:extLst>
+          </p:cNvPr>
+          <p:cNvSpPr>
+            <a:spLocks xmlns:a="http://schemas.openxmlformats.org/drawingml/2006/main" noGrp="1"/>
+          </p:cNvSpPr>
+          <p:nvPr/>
+        </p:nvSpPr>
+        <p:spPr>
+          <a:xfrm xmlns:a="http://schemas.openxmlformats.org/drawingml/2006/main">
+            <a:off x="0" y="0"/>
+            <a:ext cx="12192000" cy="6858000"/>
+          </a:xfrm>
+          <a:prstGeom xmlns:a="http://schemas.openxmlformats.org/drawingml/2006/main" prst="rect">
+            <a:avLst/>
+          </a:prstGeom>
+          <a:solidFill xmlns:a="http://schemas.openxmlformats.org/drawingml/2006/main">
+            <a:srgbClr val="FFFFFF"/>
+          </a:solidFill>
+          <a:ln xmlns:a="http://schemas.openxmlformats.org/drawingml/2006/main" w="0">
+            <a:solidFill>
+              <a:srgbClr val="FFFFFF"/>
+            </a:solidFill>
+            <a:prstDash val="solid"/>
+          </a:ln>
+        </p:spPr>
+      </p:sp>
+      <p:sp>
+        <p:nvSpPr>
+          <p:cNvPr id="201" name="slide-title">
+            <a:extLst xmlns:a="http://schemas.openxmlformats.org/drawingml/2006/main">
+              <a:ext uri="{FF2B5EF4-FFF2-40B4-BE49-F238E27FC236}">
+                <a16:creationId xmlns:a16="http://schemas.microsoft.com/office/drawing/2014/main" id="{7606216D-6B69-491D-9973-8C73B89DE141}"/>
+              </a:ext>
+            </a:extLst>
+          </p:cNvPr>
+          <p:cNvSpPr>
+            <a:spLocks xmlns:a="http://schemas.openxmlformats.org/drawingml/2006/main" noGrp="1"/>
+          </p:cNvSpPr>
+          <p:nvPr/>
+        </p:nvSpPr>
+        <p:spPr>
+          <a:xfrm xmlns:a="http://schemas.openxmlformats.org/drawingml/2006/main">
+            <a:off x="685800" y="495300"/>
+            <a:ext cx="8191500" cy="590550"/>
+          </a:xfrm>
+          <a:prstGeom xmlns:a="http://schemas.openxmlformats.org/drawingml/2006/main" prst="rect">
+            <a:avLst/>
+          </a:prstGeom>
+          <a:noFill xmlns:a="http://schemas.openxmlformats.org/drawingml/2006/main"/>
+          <a:ln xmlns:a="http://schemas.openxmlformats.org/drawingml/2006/main" w="0">
+            <a:noFill/>
+            <a:prstDash val="solid"/>
+          </a:ln>
+        </p:spPr>
+        <p:txBody>
+          <a:bodyPr xmlns:a="http://schemas.openxmlformats.org/drawingml/2006/main"/>
+          <a:lstStyle xmlns:a="http://schemas.openxmlformats.org/drawingml/2006/main"/>
+          <a:p xmlns:a="http://schemas.openxmlformats.org/drawingml/2006/main">
+            <a:pPr>
+              <a:defRPr sz="2850" b="1">
+                <a:solidFill>
+                  <a:srgbClr val="111827"/>
+                </a:solidFill>
+              </a:defRPr>
+            </a:pPr>
+            <a:r>
+              <a:rPr sz="2850" b="1">
+                <a:solidFill>
+                  <a:srgbClr val="111827"/>
+                </a:solidFill>
+              </a:rPr>
+              <a:t>Solution architecture</a:t>
+            </a:r>
+          </a:p>
+        </p:txBody>
+      </p:sp>
+      <p:sp>
+        <p:nvSpPr>
+          <p:cNvPr id="202" name="wordmark">
+            <a:extLst xmlns:a="http://schemas.openxmlformats.org/drawingml/2006/main">
+              <a:ext uri="{FF2B5EF4-FFF2-40B4-BE49-F238E27FC236}">
+                <a16:creationId xmlns:a16="http://schemas.microsoft.com/office/drawing/2014/main" id="{666EA4FF-CACB-46F7-AFB1-2F37857119C0}"/>
+              </a:ext>
+            </a:extLst>
+          </p:cNvPr>
+          <p:cNvSpPr>
+            <a:spLocks xmlns:a="http://schemas.openxmlformats.org/drawingml/2006/main" noGrp="1"/>
+          </p:cNvSpPr>
+          <p:nvPr/>
+        </p:nvSpPr>
+        <p:spPr>
+          <a:xfrm xmlns:a="http://schemas.openxmlformats.org/drawingml/2006/main">
+            <a:off x="10287000" y="514350"/>
+            <a:ext cx="1285875" cy="400050"/>
+          </a:xfrm>
+          <a:prstGeom xmlns:a="http://schemas.openxmlformats.org/drawingml/2006/main" prst="rect">
+            <a:avLst/>
+          </a:prstGeom>
+          <a:noFill xmlns:a="http://schemas.openxmlformats.org/drawingml/2006/main"/>
+          <a:ln xmlns:a="http://schemas.openxmlformats.org/drawingml/2006/main" w="0">
+            <a:noFill/>
+            <a:prstDash val="solid"/>
+          </a:ln>
+        </p:spPr>
+        <p:txBody>
+          <a:bodyPr xmlns:a="http://schemas.openxmlformats.org/drawingml/2006/main"/>
+          <a:lstStyle xmlns:a="http://schemas.openxmlformats.org/drawingml/2006/main"/>
+          <a:p xmlns:a="http://schemas.openxmlformats.org/drawingml/2006/main">
+            <a:pPr algn="r">
+              <a:defRPr sz="2250" b="1">
+                <a:solidFill>
+                  <a:srgbClr val="111827"/>
+                </a:solidFill>
+              </a:defRPr>
+            </a:pPr>
+            <a:r>
+              <a:rPr sz="2250" b="1">
+                <a:solidFill>
+                  <a:srgbClr val="111827"/>
+                </a:solidFill>
+              </a:rPr>
+              <a:t>UiPath</a:t>
+            </a:r>
+          </a:p>
+        </p:txBody>
+      </p:sp>
+      <p:sp>
+        <p:nvSpPr>
+          <p:cNvPr id="203" name="bottom-rule">
+            <a:extLst xmlns:a="http://schemas.openxmlformats.org/drawingml/2006/main">
+              <a:ext uri="{FF2B5EF4-FFF2-40B4-BE49-F238E27FC236}">
+                <a16:creationId xmlns:a16="http://schemas.microsoft.com/office/drawing/2014/main" id="{A33F4FFF-D074-4378-A098-6453DF291945}"/>
+              </a:ext>
+            </a:extLst>
+          </p:cNvPr>
+          <p:cNvSpPr>
+            <a:spLocks xmlns:a="http://schemas.openxmlformats.org/drawingml/2006/main" noGrp="1"/>
+          </p:cNvSpPr>
+          <p:nvPr/>
+        </p:nvSpPr>
+        <p:spPr>
+          <a:xfrm xmlns:a="http://schemas.openxmlformats.org/drawingml/2006/main">
+            <a:off x="0" y="6743700"/>
+            <a:ext cx="12192000" cy="114300"/>
+          </a:xfrm>
+          <a:prstGeom xmlns:a="http://schemas.openxmlformats.org/drawingml/2006/main" prst="rect">
+            <a:avLst/>
+          </a:prstGeom>
+          <a:solidFill xmlns:a="http://schemas.openxmlformats.org/drawingml/2006/main">
+            <a:srgbClr val="FA4616"/>
+          </a:solidFill>
+          <a:ln xmlns:a="http://schemas.openxmlformats.org/drawingml/2006/main" w="0">
+            <a:solidFill>
+              <a:srgbClr val="FA4616"/>
+            </a:solidFill>
+            <a:prstDash val="solid"/>
+          </a:ln>
+        </p:spPr>
+      </p:sp>
+      <p:sp>
+        <p:nvSpPr>
+          <p:cNvPr id="204" name="architecture-copy">
+            <a:extLst xmlns:a="http://schemas.openxmlformats.org/drawingml/2006/main">
+              <a:ext uri="{FF2B5EF4-FFF2-40B4-BE49-F238E27FC236}">
+                <a16:creationId xmlns:a16="http://schemas.microsoft.com/office/drawing/2014/main" id="{EB86C6E0-7748-4F89-8903-EEEE751F460D}"/>
+              </a:ext>
+            </a:extLst>
+          </p:cNvPr>
+          <p:cNvSpPr>
+            <a:spLocks xmlns:a="http://schemas.openxmlformats.org/drawingml/2006/main" noGrp="1"/>
+          </p:cNvSpPr>
+          <p:nvPr/>
+        </p:nvSpPr>
+        <p:spPr>
+          <a:xfrm xmlns:a="http://schemas.openxmlformats.org/drawingml/2006/main">
+            <a:off x="685800" y="1543050"/>
+            <a:ext cx="10001250" cy="2571750"/>
+          </a:xfrm>
+          <a:prstGeom xmlns:a="http://schemas.openxmlformats.org/drawingml/2006/main" prst="rect">
+            <a:avLst/>
+          </a:prstGeom>
+          <a:noFill xmlns:a="http://schemas.openxmlformats.org/drawingml/2006/main"/>
+          <a:ln xmlns:a="http://schemas.openxmlformats.org/drawingml/2006/main" w="0">
+            <a:noFill/>
+            <a:prstDash val="solid"/>
+          </a:ln>
+        </p:spPr>
+        <p:txBody>
+          <a:bodyPr xmlns:a="http://schemas.openxmlformats.org/drawingml/2006/main"/>
+          <a:lstStyle xmlns:a="http://schemas.openxmlformats.org/drawingml/2006/main"/>
+          <a:p xmlns:a="http://schemas.openxmlformats.org/drawingml/2006/main">
+            <a:pPr>
+              <a:defRPr sz="1800">
+                <a:solidFill>
+                  <a:srgbClr val="111827"/>
+                </a:solidFill>
+              </a:defRPr>
+            </a:pPr>
+            <a:r>
+              <a:rPr sz="1800">
                 <a:solidFill>
                   <a:srgbClr val="111827"/>
                 </a:solidFill>
@@ -23253,50 +24475,20 @@
             </a:r>
           </a:p>
           <a:p xmlns:a="http://schemas.openxmlformats.org/drawingml/2006/main">
-            <a:pPr marL="0" indent="0" algn="l">
-              <a:lnSpc>
-                <a:spcPct val="115000"/>
-              </a:lnSpc>
-              <a:spcBef>
-                <a:spcPts val="0"/>
-              </a:spcBef>
-              <a:spcAft>
-                <a:spcPts val="0"/>
-              </a:spcAft>
-              <a:buNone/>
-            </a:pPr>
             <a:r>
-              <a:rPr sz="2100">
-                <a:solidFill>
-                  <a:srgbClr val="1D1D1F"/>
-                </a:solidFill>
-                <a:highlight>
-                  <a:srgbClr val="FFFFFF"/>
-                </a:highlight>
-              </a:rPr>
               <a:t/>
             </a:r>
           </a:p>
           <a:p xmlns:a="http://schemas.openxmlformats.org/drawingml/2006/main">
-            <a:pPr marL="0" indent="0" algn="l">
-              <a:lnSpc>
-                <a:spcPct val="115000"/>
-              </a:lnSpc>
-              <a:spcBef>
-                <a:spcPts val="0"/>
-              </a:spcBef>
-              <a:spcAft>
-                <a:spcPts val="0"/>
-              </a:spcAft>
-              <a:buNone/>
-              <a:defRPr sz="1650">
+            <a:pPr>
+              <a:defRPr sz="1800">
                 <a:solidFill>
                   <a:srgbClr val="111827"/>
                 </a:solidFill>
               </a:defRPr>
             </a:pPr>
             <a:r>
-              <a:rPr sz="1650">
+              <a:rPr sz="1800">
                 <a:solidFill>
                   <a:srgbClr val="111827"/>
                 </a:solidFill>
@@ -23305,33 +24497,70 @@
             </a:r>
           </a:p>
           <a:p xmlns:a="http://schemas.openxmlformats.org/drawingml/2006/main">
-            <a:pPr marL="0" indent="0" algn="l">
-              <a:lnSpc>
-                <a:spcPct val="115000"/>
-              </a:lnSpc>
-              <a:spcBef>
-                <a:spcPts val="0"/>
-              </a:spcBef>
-              <a:spcAft>
-                <a:spcPts val="0"/>
-              </a:spcAft>
-              <a:buNone/>
-              <a:defRPr sz="1650">
+            <a:pPr>
+              <a:defRPr sz="1800">
                 <a:solidFill>
                   <a:srgbClr val="111827"/>
                 </a:solidFill>
               </a:defRPr>
             </a:pPr>
             <a:r>
-              <a:rPr sz="1650">
+              <a:rPr sz="1800">
                 <a:solidFill>
                   <a:srgbClr val="111827"/>
                 </a:solidFill>
-                <a:highlight>
-                  <a:srgbClr val="FFFFFF"/>
-                </a:highlight>
               </a:rPr>
               <a:t>Demo: https://youtu.be/N25lvoKJjug</a:t>
+            </a:r>
+          </a:p>
+        </p:txBody>
+      </p:sp>
+      <p:sp>
+        <p:nvSpPr>
+          <p:cNvPr id="205" name="architecture-note">
+            <a:extLst xmlns:a="http://schemas.openxmlformats.org/drawingml/2006/main">
+              <a:ext uri="{FF2B5EF4-FFF2-40B4-BE49-F238E27FC236}">
+                <a16:creationId xmlns:a16="http://schemas.microsoft.com/office/drawing/2014/main" id="{A1BE4FF9-0EA4-45E9-ABDC-A04BB7FC5BDA}"/>
+              </a:ext>
+            </a:extLst>
+          </p:cNvPr>
+          <p:cNvSpPr>
+            <a:spLocks xmlns:a="http://schemas.openxmlformats.org/drawingml/2006/main" noGrp="1"/>
+          </p:cNvSpPr>
+          <p:nvPr/>
+        </p:nvSpPr>
+        <p:spPr>
+          <a:xfrm xmlns:a="http://schemas.openxmlformats.org/drawingml/2006/main">
+            <a:off x="685800" y="5048250"/>
+            <a:ext cx="9525000" cy="552450"/>
+          </a:xfrm>
+          <a:prstGeom xmlns:a="http://schemas.openxmlformats.org/drawingml/2006/main" prst="rect">
+            <a:avLst/>
+          </a:prstGeom>
+          <a:noFill xmlns:a="http://schemas.openxmlformats.org/drawingml/2006/main"/>
+          <a:ln xmlns:a="http://schemas.openxmlformats.org/drawingml/2006/main" w="0">
+            <a:noFill/>
+            <a:prstDash val="solid"/>
+          </a:ln>
+        </p:spPr>
+        <p:txBody>
+          <a:bodyPr xmlns:a="http://schemas.openxmlformats.org/drawingml/2006/main"/>
+          <a:lstStyle xmlns:a="http://schemas.openxmlformats.org/drawingml/2006/main"/>
+          <a:p xmlns:a="http://schemas.openxmlformats.org/drawingml/2006/main">
+            <a:pPr>
+              <a:defRPr sz="1500">
+                <a:solidFill>
+                  <a:srgbClr val="4B5563"/>
+                </a:solidFill>
+              </a:defRPr>
+            </a:pPr>
+            <a:r>
+              <a:rPr sz="1500">
+                <a:solidFill>
+                  <a:srgbClr val="4B5563"/>
+                </a:solidFill>
+              </a:rPr>
+              <a:t>Boundary: the app prepares evidence for review. It does not approve, merge, deploy, issue refunds, or update customer records.</a:t>
             </a:r>
           </a:p>
         </p:txBody>
@@ -23339,7 +24568,7 @@
     </p:spTree>
     <p:extLst>
       <p:ext uri="{BB962C8B-B14F-4D97-AF65-F5344CB8AC3E}">
-        <p14:creationId xmlns:p14="http://schemas.microsoft.com/office/powerpoint/2010/main" val="1464593496"/>
+        <p14:creationId xmlns:p14="http://schemas.microsoft.com/office/powerpoint/2010/main" val="219610058"/>
       </p:ext>
     </p:extLst>
   </p:cSld>
@@ -23349,13 +24578,6 @@
 <file path=ppt/slides/slide5.xml><?xml version="1.0" encoding="utf-8"?>
 <p:sld xmlns:p="http://schemas.openxmlformats.org/presentationml/2006/main">
   <p:cSld>
-    <p:bg>
-      <p:bgPr>
-        <a:solidFill xmlns:a="http://schemas.openxmlformats.org/drawingml/2006/main">
-          <a:srgbClr val="0F9EA8"/>
-        </a:solidFill>
-      </p:bgPr>
-    </p:bg>
     <p:spTree>
       <p:nvGrpSpPr>
         <p:cNvPr id="1" name=""/>
@@ -23367,10 +24589,10 @@
       </p:grpSpPr>
       <p:sp>
         <p:nvSpPr>
-          <p:cNvPr id="1" name="closing-title">
+          <p:cNvPr id="1" name="clean-closing-background">
             <a:extLst xmlns:a="http://schemas.openxmlformats.org/drawingml/2006/main">
               <a:ext uri="{FF2B5EF4-FFF2-40B4-BE49-F238E27FC236}">
-                <a16:creationId xmlns:a16="http://schemas.microsoft.com/office/drawing/2014/main" id="{41F1B264-DBCC-4192-B106-2A69E313C210}"/>
+                <a16:creationId xmlns:a16="http://schemas.microsoft.com/office/drawing/2014/main" id="{1D924437-2488-4D50-89C3-6E5F81B5E7E7}"/>
               </a:ext>
             </a:extLst>
           </p:cNvPr>
@@ -23381,7 +24603,222 @@
         </p:nvSpPr>
         <p:spPr>
           <a:xfrm xmlns:a="http://schemas.openxmlformats.org/drawingml/2006/main">
-            <a:off x="666750" y="1428750"/>
+            <a:off x="0" y="0"/>
+            <a:ext cx="12192000" cy="6858000"/>
+          </a:xfrm>
+          <a:prstGeom xmlns:a="http://schemas.openxmlformats.org/drawingml/2006/main" prst="rect">
+            <a:avLst/>
+          </a:prstGeom>
+          <a:solidFill xmlns:a="http://schemas.openxmlformats.org/drawingml/2006/main">
+            <a:srgbClr val="0BA2B3"/>
+          </a:solidFill>
+          <a:ln xmlns:a="http://schemas.openxmlformats.org/drawingml/2006/main" w="0">
+            <a:solidFill>
+              <a:srgbClr val="0BA2B3"/>
+            </a:solidFill>
+            <a:prstDash val="solid"/>
+          </a:ln>
+        </p:spPr>
+      </p:sp>
+      <p:sp>
+        <p:nvSpPr>
+          <p:cNvPr id="2" name="closing-frame-top">
+            <a:extLst xmlns:a="http://schemas.openxmlformats.org/drawingml/2006/main">
+              <a:ext uri="{FF2B5EF4-FFF2-40B4-BE49-F238E27FC236}">
+                <a16:creationId xmlns:a16="http://schemas.microsoft.com/office/drawing/2014/main" id="{CF0900D0-A838-4F41-BAD4-7A5AB218D24F}"/>
+              </a:ext>
+            </a:extLst>
+          </p:cNvPr>
+          <p:cNvSpPr>
+            <a:spLocks xmlns:a="http://schemas.openxmlformats.org/drawingml/2006/main" noGrp="1"/>
+          </p:cNvSpPr>
+          <p:nvPr/>
+        </p:nvSpPr>
+        <p:spPr>
+          <a:xfrm xmlns:a="http://schemas.openxmlformats.org/drawingml/2006/main">
+            <a:off x="266700" y="209550"/>
+            <a:ext cx="11658600" cy="19050"/>
+          </a:xfrm>
+          <a:prstGeom xmlns:a="http://schemas.openxmlformats.org/drawingml/2006/main" prst="rect">
+            <a:avLst/>
+          </a:prstGeom>
+          <a:solidFill xmlns:a="http://schemas.openxmlformats.org/drawingml/2006/main">
+            <a:srgbClr val="FFFFFF"/>
+          </a:solidFill>
+          <a:ln xmlns:a="http://schemas.openxmlformats.org/drawingml/2006/main" w="0">
+            <a:solidFill>
+              <a:srgbClr val="FFFFFF"/>
+            </a:solidFill>
+            <a:prstDash val="solid"/>
+          </a:ln>
+        </p:spPr>
+      </p:sp>
+      <p:sp>
+        <p:nvSpPr>
+          <p:cNvPr id="3" name="closing-frame-left">
+            <a:extLst xmlns:a="http://schemas.openxmlformats.org/drawingml/2006/main">
+              <a:ext uri="{FF2B5EF4-FFF2-40B4-BE49-F238E27FC236}">
+                <a16:creationId xmlns:a16="http://schemas.microsoft.com/office/drawing/2014/main" id="{E1549B4A-B16A-4B3F-BD0B-3399AA1FF6D8}"/>
+              </a:ext>
+            </a:extLst>
+          </p:cNvPr>
+          <p:cNvSpPr>
+            <a:spLocks xmlns:a="http://schemas.openxmlformats.org/drawingml/2006/main" noGrp="1"/>
+          </p:cNvSpPr>
+          <p:nvPr/>
+        </p:nvSpPr>
+        <p:spPr>
+          <a:xfrm xmlns:a="http://schemas.openxmlformats.org/drawingml/2006/main">
+            <a:off x="266700" y="209550"/>
+            <a:ext cx="19050" cy="6438900"/>
+          </a:xfrm>
+          <a:prstGeom xmlns:a="http://schemas.openxmlformats.org/drawingml/2006/main" prst="rect">
+            <a:avLst/>
+          </a:prstGeom>
+          <a:solidFill xmlns:a="http://schemas.openxmlformats.org/drawingml/2006/main">
+            <a:srgbClr val="FFFFFF"/>
+          </a:solidFill>
+          <a:ln xmlns:a="http://schemas.openxmlformats.org/drawingml/2006/main" w="0">
+            <a:solidFill>
+              <a:srgbClr val="FFFFFF"/>
+            </a:solidFill>
+            <a:prstDash val="solid"/>
+          </a:ln>
+        </p:spPr>
+      </p:sp>
+      <p:sp>
+        <p:nvSpPr>
+          <p:cNvPr id="4" name="closing-frame-right">
+            <a:extLst xmlns:a="http://schemas.openxmlformats.org/drawingml/2006/main">
+              <a:ext uri="{FF2B5EF4-FFF2-40B4-BE49-F238E27FC236}">
+                <a16:creationId xmlns:a16="http://schemas.microsoft.com/office/drawing/2014/main" id="{943A1B57-C9A5-4B58-BB36-007F3E161F12}"/>
+              </a:ext>
+            </a:extLst>
+          </p:cNvPr>
+          <p:cNvSpPr>
+            <a:spLocks xmlns:a="http://schemas.openxmlformats.org/drawingml/2006/main" noGrp="1"/>
+          </p:cNvSpPr>
+          <p:nvPr/>
+        </p:nvSpPr>
+        <p:spPr>
+          <a:xfrm xmlns:a="http://schemas.openxmlformats.org/drawingml/2006/main">
+            <a:off x="11906250" y="209550"/>
+            <a:ext cx="19050" cy="6438900"/>
+          </a:xfrm>
+          <a:prstGeom xmlns:a="http://schemas.openxmlformats.org/drawingml/2006/main" prst="rect">
+            <a:avLst/>
+          </a:prstGeom>
+          <a:solidFill xmlns:a="http://schemas.openxmlformats.org/drawingml/2006/main">
+            <a:srgbClr val="FFFFFF"/>
+          </a:solidFill>
+          <a:ln xmlns:a="http://schemas.openxmlformats.org/drawingml/2006/main" w="0">
+            <a:solidFill>
+              <a:srgbClr val="FFFFFF"/>
+            </a:solidFill>
+            <a:prstDash val="solid"/>
+          </a:ln>
+        </p:spPr>
+      </p:sp>
+      <p:sp>
+        <p:nvSpPr>
+          <p:cNvPr id="5" name="closing-frame-bottom">
+            <a:extLst xmlns:a="http://schemas.openxmlformats.org/drawingml/2006/main">
+              <a:ext uri="{FF2B5EF4-FFF2-40B4-BE49-F238E27FC236}">
+                <a16:creationId xmlns:a16="http://schemas.microsoft.com/office/drawing/2014/main" id="{462F65BC-B0B8-4B22-83B2-B6B1E1BD205A}"/>
+              </a:ext>
+            </a:extLst>
+          </p:cNvPr>
+          <p:cNvSpPr>
+            <a:spLocks xmlns:a="http://schemas.openxmlformats.org/drawingml/2006/main" noGrp="1"/>
+          </p:cNvSpPr>
+          <p:nvPr/>
+        </p:nvSpPr>
+        <p:spPr>
+          <a:xfrm xmlns:a="http://schemas.openxmlformats.org/drawingml/2006/main">
+            <a:off x="266700" y="6629400"/>
+            <a:ext cx="11658600" cy="19050"/>
+          </a:xfrm>
+          <a:prstGeom xmlns:a="http://schemas.openxmlformats.org/drawingml/2006/main" prst="rect">
+            <a:avLst/>
+          </a:prstGeom>
+          <a:solidFill xmlns:a="http://schemas.openxmlformats.org/drawingml/2006/main">
+            <a:srgbClr val="FFFFFF"/>
+          </a:solidFill>
+          <a:ln xmlns:a="http://schemas.openxmlformats.org/drawingml/2006/main" w="0">
+            <a:solidFill>
+              <a:srgbClr val="FFFFFF"/>
+            </a:solidFill>
+            <a:prstDash val="solid"/>
+          </a:ln>
+        </p:spPr>
+      </p:sp>
+      <p:sp>
+        <p:nvSpPr>
+          <p:cNvPr id="6" name="wordmark">
+            <a:extLst xmlns:a="http://schemas.openxmlformats.org/drawingml/2006/main">
+              <a:ext uri="{FF2B5EF4-FFF2-40B4-BE49-F238E27FC236}">
+                <a16:creationId xmlns:a16="http://schemas.microsoft.com/office/drawing/2014/main" id="{5620A1A7-91F4-4AD4-8297-8E9B738D5FC3}"/>
+              </a:ext>
+            </a:extLst>
+          </p:cNvPr>
+          <p:cNvSpPr>
+            <a:spLocks xmlns:a="http://schemas.openxmlformats.org/drawingml/2006/main" noGrp="1"/>
+          </p:cNvSpPr>
+          <p:nvPr/>
+        </p:nvSpPr>
+        <p:spPr>
+          <a:xfrm xmlns:a="http://schemas.openxmlformats.org/drawingml/2006/main">
+            <a:off x="10287000" y="514350"/>
+            <a:ext cx="1285875" cy="400050"/>
+          </a:xfrm>
+          <a:prstGeom xmlns:a="http://schemas.openxmlformats.org/drawingml/2006/main" prst="rect">
+            <a:avLst/>
+          </a:prstGeom>
+          <a:noFill xmlns:a="http://schemas.openxmlformats.org/drawingml/2006/main"/>
+          <a:ln xmlns:a="http://schemas.openxmlformats.org/drawingml/2006/main" w="0">
+            <a:noFill/>
+            <a:prstDash val="solid"/>
+          </a:ln>
+        </p:spPr>
+        <p:txBody>
+          <a:bodyPr xmlns:a="http://schemas.openxmlformats.org/drawingml/2006/main"/>
+          <a:lstStyle xmlns:a="http://schemas.openxmlformats.org/drawingml/2006/main"/>
+          <a:p xmlns:a="http://schemas.openxmlformats.org/drawingml/2006/main">
+            <a:pPr algn="r">
+              <a:defRPr sz="2250" b="1">
+                <a:solidFill>
+                  <a:srgbClr val="FFFFFF"/>
+                </a:solidFill>
+              </a:defRPr>
+            </a:pPr>
+            <a:r>
+              <a:rPr sz="2250" b="1">
+                <a:solidFill>
+                  <a:srgbClr val="FFFFFF"/>
+                </a:solidFill>
+              </a:rPr>
+              <a:t>UiPath</a:t>
+            </a:r>
+          </a:p>
+        </p:txBody>
+      </p:sp>
+      <p:sp>
+        <p:nvSpPr>
+          <p:cNvPr id="7" name="closing-title">
+            <a:extLst xmlns:a="http://schemas.openxmlformats.org/drawingml/2006/main">
+              <a:ext uri="{FF2B5EF4-FFF2-40B4-BE49-F238E27FC236}">
+                <a16:creationId xmlns:a16="http://schemas.microsoft.com/office/drawing/2014/main" id="{1868521E-D774-4A45-9FD5-7F7190FBDB26}"/>
+              </a:ext>
+            </a:extLst>
+          </p:cNvPr>
+          <p:cNvSpPr>
+            <a:spLocks xmlns:a="http://schemas.openxmlformats.org/drawingml/2006/main" noGrp="1"/>
+          </p:cNvSpPr>
+          <p:nvPr/>
+        </p:nvSpPr>
+        <p:spPr>
+          <a:xfrm xmlns:a="http://schemas.openxmlformats.org/drawingml/2006/main">
+            <a:off x="704850" y="1428750"/>
             <a:ext cx="9810750" cy="904875"/>
           </a:xfrm>
           <a:prstGeom xmlns:a="http://schemas.openxmlformats.org/drawingml/2006/main" prst="rect">
@@ -23410,17 +24847,17 @@
                   <a:srgbClr val="FFFFFF"/>
                 </a:solidFill>
               </a:rPr>
-              <a:t>CaseProof AI: review only, action never automatic</a:t>
+              <a:t>CaseProof AI: review only</a:t>
             </a:r>
           </a:p>
         </p:txBody>
       </p:sp>
       <p:sp>
         <p:nvSpPr>
-          <p:cNvPr id="2" name="closing-body">
+          <p:cNvPr id="8" name="closing-body">
             <a:extLst xmlns:a="http://schemas.openxmlformats.org/drawingml/2006/main">
               <a:ext uri="{FF2B5EF4-FFF2-40B4-BE49-F238E27FC236}">
-                <a16:creationId xmlns:a16="http://schemas.microsoft.com/office/drawing/2014/main" id="{FD087102-1A42-4A5D-BE20-1DD2BDBE599A}"/>
+                <a16:creationId xmlns:a16="http://schemas.microsoft.com/office/drawing/2014/main" id="{15BA7857-9D3C-45A7-AD6F-88C0A4D450B8}"/>
               </a:ext>
             </a:extLst>
           </p:cNvPr>
@@ -23431,7 +24868,7 @@
         </p:nvSpPr>
         <p:spPr>
           <a:xfrm xmlns:a="http://schemas.openxmlformats.org/drawingml/2006/main">
-            <a:off x="685800" y="2857500"/>
+            <a:off x="723900" y="2724150"/>
             <a:ext cx="9334500" cy="1714500"/>
           </a:xfrm>
           <a:prstGeom xmlns:a="http://schemas.openxmlformats.org/drawingml/2006/main" prst="rect">
@@ -23467,10 +24904,10 @@
       </p:sp>
       <p:sp>
         <p:nvSpPr>
-          <p:cNvPr id="3" name="closing-footer">
+          <p:cNvPr id="9" name="closing-footer">
             <a:extLst xmlns:a="http://schemas.openxmlformats.org/drawingml/2006/main">
               <a:ext uri="{FF2B5EF4-FFF2-40B4-BE49-F238E27FC236}">
-                <a16:creationId xmlns:a16="http://schemas.microsoft.com/office/drawing/2014/main" id="{BDCFC035-7694-4DBD-B16F-AF6D31A3062B}"/>
+                <a16:creationId xmlns:a16="http://schemas.microsoft.com/office/drawing/2014/main" id="{B8EAC792-B456-48BB-A05E-6632085C1F89}"/>
               </a:ext>
             </a:extLst>
           </p:cNvPr>
@@ -23481,7 +24918,7 @@
         </p:nvSpPr>
         <p:spPr>
           <a:xfrm xmlns:a="http://schemas.openxmlformats.org/drawingml/2006/main">
-            <a:off x="685800" y="5810250"/>
+            <a:off x="723900" y="5810250"/>
             <a:ext cx="9144000" cy="381000"/>
           </a:xfrm>
           <a:prstGeom xmlns:a="http://schemas.openxmlformats.org/drawingml/2006/main" prst="rect">
@@ -23515,10 +24952,142 @@
           </a:p>
         </p:txBody>
       </p:sp>
+      <p:sp>
+        <p:nvSpPr>
+          <p:cNvPr id="10" name="accent-pixel-a">
+            <a:extLst xmlns:a="http://schemas.openxmlformats.org/drawingml/2006/main">
+              <a:ext uri="{FF2B5EF4-FFF2-40B4-BE49-F238E27FC236}">
+                <a16:creationId xmlns:a16="http://schemas.microsoft.com/office/drawing/2014/main" id="{A560FC0F-5FB7-4179-AF34-E3E06F995ADD}"/>
+              </a:ext>
+            </a:extLst>
+          </p:cNvPr>
+          <p:cNvSpPr>
+            <a:spLocks xmlns:a="http://schemas.openxmlformats.org/drawingml/2006/main" noGrp="1"/>
+          </p:cNvSpPr>
+          <p:nvPr/>
+        </p:nvSpPr>
+        <p:spPr>
+          <a:xfrm xmlns:a="http://schemas.openxmlformats.org/drawingml/2006/main">
+            <a:off x="10248900" y="5295900"/>
+            <a:ext cx="323850" cy="323850"/>
+          </a:xfrm>
+          <a:prstGeom xmlns:a="http://schemas.openxmlformats.org/drawingml/2006/main" prst="rect">
+            <a:avLst/>
+          </a:prstGeom>
+          <a:solidFill xmlns:a="http://schemas.openxmlformats.org/drawingml/2006/main">
+            <a:srgbClr val="064957"/>
+          </a:solidFill>
+          <a:ln xmlns:a="http://schemas.openxmlformats.org/drawingml/2006/main" w="0">
+            <a:solidFill>
+              <a:srgbClr val="064957"/>
+            </a:solidFill>
+            <a:prstDash val="solid"/>
+          </a:ln>
+        </p:spPr>
+      </p:sp>
+      <p:sp>
+        <p:nvSpPr>
+          <p:cNvPr id="11" name="accent-pixel-b">
+            <a:extLst xmlns:a="http://schemas.openxmlformats.org/drawingml/2006/main">
+              <a:ext uri="{FF2B5EF4-FFF2-40B4-BE49-F238E27FC236}">
+                <a16:creationId xmlns:a16="http://schemas.microsoft.com/office/drawing/2014/main" id="{F1EE94BA-E775-489E-BD3C-EC534968953F}"/>
+              </a:ext>
+            </a:extLst>
+          </p:cNvPr>
+          <p:cNvSpPr>
+            <a:spLocks xmlns:a="http://schemas.openxmlformats.org/drawingml/2006/main" noGrp="1"/>
+          </p:cNvSpPr>
+          <p:nvPr/>
+        </p:nvSpPr>
+        <p:spPr>
+          <a:xfrm xmlns:a="http://schemas.openxmlformats.org/drawingml/2006/main">
+            <a:off x="10572750" y="5619750"/>
+            <a:ext cx="323850" cy="323850"/>
+          </a:xfrm>
+          <a:prstGeom xmlns:a="http://schemas.openxmlformats.org/drawingml/2006/main" prst="rect">
+            <a:avLst/>
+          </a:prstGeom>
+          <a:solidFill xmlns:a="http://schemas.openxmlformats.org/drawingml/2006/main">
+            <a:srgbClr val="087F8F"/>
+          </a:solidFill>
+          <a:ln xmlns:a="http://schemas.openxmlformats.org/drawingml/2006/main" w="0">
+            <a:solidFill>
+              <a:srgbClr val="087F8F"/>
+            </a:solidFill>
+            <a:prstDash val="solid"/>
+          </a:ln>
+        </p:spPr>
+      </p:sp>
+      <p:sp>
+        <p:nvSpPr>
+          <p:cNvPr id="12" name="accent-pixel-c">
+            <a:extLst xmlns:a="http://schemas.openxmlformats.org/drawingml/2006/main">
+              <a:ext uri="{FF2B5EF4-FFF2-40B4-BE49-F238E27FC236}">
+                <a16:creationId xmlns:a16="http://schemas.microsoft.com/office/drawing/2014/main" id="{7E0C657B-038D-4040-877B-D7BB86DF7C9B}"/>
+              </a:ext>
+            </a:extLst>
+          </p:cNvPr>
+          <p:cNvSpPr>
+            <a:spLocks xmlns:a="http://schemas.openxmlformats.org/drawingml/2006/main" noGrp="1"/>
+          </p:cNvSpPr>
+          <p:nvPr/>
+        </p:nvSpPr>
+        <p:spPr>
+          <a:xfrm xmlns:a="http://schemas.openxmlformats.org/drawingml/2006/main">
+            <a:off x="10896600" y="5943600"/>
+            <a:ext cx="323850" cy="323850"/>
+          </a:xfrm>
+          <a:prstGeom xmlns:a="http://schemas.openxmlformats.org/drawingml/2006/main" prst="rect">
+            <a:avLst/>
+          </a:prstGeom>
+          <a:solidFill xmlns:a="http://schemas.openxmlformats.org/drawingml/2006/main">
+            <a:srgbClr val="064957"/>
+          </a:solidFill>
+          <a:ln xmlns:a="http://schemas.openxmlformats.org/drawingml/2006/main" w="0">
+            <a:solidFill>
+              <a:srgbClr val="064957"/>
+            </a:solidFill>
+            <a:prstDash val="solid"/>
+          </a:ln>
+        </p:spPr>
+      </p:sp>
+      <p:sp>
+        <p:nvSpPr>
+          <p:cNvPr id="13" name="accent-bar">
+            <a:extLst xmlns:a="http://schemas.openxmlformats.org/drawingml/2006/main">
+              <a:ext uri="{FF2B5EF4-FFF2-40B4-BE49-F238E27FC236}">
+                <a16:creationId xmlns:a16="http://schemas.microsoft.com/office/drawing/2014/main" id="{534FC939-597C-4FCE-9EC4-666E9FA32BCD}"/>
+              </a:ext>
+            </a:extLst>
+          </p:cNvPr>
+          <p:cNvSpPr>
+            <a:spLocks xmlns:a="http://schemas.openxmlformats.org/drawingml/2006/main" noGrp="1"/>
+          </p:cNvSpPr>
+          <p:nvPr/>
+        </p:nvSpPr>
+        <p:spPr>
+          <a:xfrm xmlns:a="http://schemas.openxmlformats.org/drawingml/2006/main">
+            <a:off x="9696450" y="6172200"/>
+            <a:ext cx="1200150" cy="190500"/>
+          </a:xfrm>
+          <a:prstGeom xmlns:a="http://schemas.openxmlformats.org/drawingml/2006/main" prst="rect">
+            <a:avLst/>
+          </a:prstGeom>
+          <a:solidFill xmlns:a="http://schemas.openxmlformats.org/drawingml/2006/main">
+            <a:srgbClr val="064957"/>
+          </a:solidFill>
+          <a:ln xmlns:a="http://schemas.openxmlformats.org/drawingml/2006/main" w="0">
+            <a:solidFill>
+              <a:srgbClr val="064957"/>
+            </a:solidFill>
+            <a:prstDash val="solid"/>
+          </a:ln>
+        </p:spPr>
+      </p:sp>
     </p:spTree>
     <p:extLst>
       <p:ext uri="{BB962C8B-B14F-4D97-AF65-F5344CB8AC3E}">
-        <p14:creationId xmlns:p14="http://schemas.microsoft.com/office/powerpoint/2010/main" val="900799640"/>
+        <p14:creationId xmlns:p14="http://schemas.microsoft.com/office/powerpoint/2010/main" val="2111576676"/>
       </p:ext>
     </p:extLst>
   </p:cSld>

</xml_diff>